<commit_message>
Upgrade PowerPoint presentation to Silicon Valley VC Tier-1 Design
</commit_message>
<xml_diff>
--- a/EvalMesh_Investor_Pitch_Deck.pptx
+++ b/EvalMesh_Investor_Pitch_Deck.pptx
@@ -16,7 +16,7 @@
     <p:sldId id="264" r:id="rId15"/>
     <p:sldId id="265" r:id="rId16"/>
   </p:sldIdLst>
-  <p:sldSz cx="12188952" cy="6858000" type="screen4x3"/>
+  <p:sldSz cx="12191695" cy="6858000" type="screen4x3"/>
   <p:notesSz cx="6858000" cy="9144000"/>
   <p:defaultTextStyle>
     <a:defPPr>
@@ -3093,7 +3093,7 @@
     <p:bg>
       <p:bgPr>
         <a:solidFill>
-          <a:srgbClr val="06080E"/>
+          <a:srgbClr val="0B0F19"/>
         </a:solidFill>
         <a:effectLst/>
       </p:bgPr>
@@ -3113,14 +3113,14 @@
         </p:nvSpPr>
         <p:spPr>
           <a:xfrm>
-            <a:off x="1371600" y="1371600"/>
-            <a:ext cx="9445752" cy="4114800"/>
+            <a:off x="1097280" y="1097280"/>
+            <a:ext cx="9994392" cy="4663440"/>
           </a:xfrm>
           <a:prstGeom prst="roundRect">
             <a:avLst/>
           </a:prstGeom>
           <a:solidFill>
-            <a:srgbClr val="0D1322"/>
+            <a:srgbClr val="111827"/>
           </a:solidFill>
           <a:ln w="25400">
             <a:solidFill>
@@ -3158,8 +3158,8 @@
         </p:nvSpPr>
         <p:spPr>
           <a:xfrm>
-            <a:off x="1828800" y="2011680"/>
-            <a:ext cx="8531352" cy="2743200"/>
+            <a:off x="1645920" y="1645920"/>
+            <a:ext cx="8869680" cy="3566160"/>
           </a:xfrm>
           <a:prstGeom prst="rect">
             <a:avLst/>
@@ -3173,21 +3173,33 @@
           <a:lstStyle/>
           <a:p>
             <a:pPr>
-              <a:defRPr sz="4400" b="1">
-                <a:solidFill>
-                  <a:srgbClr val="F8FAFC"/>
-                </a:solidFill>
-              </a:defRPr>
-            </a:pPr>
-            <a:r>
-              <a:t>🛡️ EvalMesh</a:t>
+              <a:defRPr sz="1100" b="1">
+                <a:solidFill>
+                  <a:srgbClr val="00F0FF"/>
+                </a:solidFill>
+              </a:defRPr>
+            </a:pPr>
+            <a:r>
+              <a:t>SERIES SEED PITCH DECK</a:t>
+            </a:r>
+          </a:p>
+          <a:p>
+            <a:pPr>
+              <a:defRPr sz="5200" b="1">
+                <a:solidFill>
+                  <a:srgbClr val="F9FAFB"/>
+                </a:solidFill>
+              </a:defRPr>
+            </a:pPr>
+            <a:r>
+              <a:t>EvalMesh</a:t>
             </a:r>
           </a:p>
           <a:p>
             <a:pPr>
               <a:defRPr sz="2400" b="1">
                 <a:solidFill>
-                  <a:srgbClr val="06B6D4"/>
+                  <a:srgbClr val="3B82F6"/>
                 </a:solidFill>
               </a:defRPr>
             </a:pPr>
@@ -3200,7 +3212,7 @@
             <a:pPr>
               <a:defRPr sz="1600">
                 <a:solidFill>
-                  <a:srgbClr val="94A3B8"/>
+                  <a:srgbClr val="9CA3AF"/>
                 </a:solidFill>
               </a:defRPr>
             </a:pPr>
@@ -3224,7 +3236,7 @@
     <p:bg>
       <p:bgPr>
         <a:solidFill>
-          <a:srgbClr val="06080E"/>
+          <a:srgbClr val="0B0F19"/>
         </a:solidFill>
         <a:effectLst/>
       </p:bgPr>
@@ -3244,18 +3256,18 @@
         </p:nvSpPr>
         <p:spPr>
           <a:xfrm>
-            <a:off x="1371600" y="1371600"/>
-            <a:ext cx="9445752" cy="4114800"/>
+            <a:off x="1097280" y="1097280"/>
+            <a:ext cx="9994392" cy="4663440"/>
           </a:xfrm>
           <a:prstGeom prst="roundRect">
             <a:avLst/>
           </a:prstGeom>
           <a:solidFill>
-            <a:srgbClr val="0D1322"/>
+            <a:srgbClr val="111827"/>
           </a:solidFill>
           <a:ln w="25400">
             <a:solidFill>
-              <a:srgbClr val="06B6D4"/>
+              <a:srgbClr val="00F0FF"/>
             </a:solidFill>
           </a:ln>
         </p:spPr>
@@ -3289,8 +3301,8 @@
         </p:nvSpPr>
         <p:spPr>
           <a:xfrm>
-            <a:off x="1828800" y="2011680"/>
-            <a:ext cx="8531352" cy="2743200"/>
+            <a:off x="1645920" y="1645920"/>
+            <a:ext cx="8869680" cy="3566160"/>
           </a:xfrm>
           <a:prstGeom prst="rect">
             <a:avLst/>
@@ -3304,9 +3316,9 @@
           <a:lstStyle/>
           <a:p>
             <a:pPr>
-              <a:defRPr sz="4000" b="1">
-                <a:solidFill>
-                  <a:srgbClr val="F8FAFC"/>
+              <a:defRPr sz="4200" b="1">
+                <a:solidFill>
+                  <a:srgbClr val="F9FAFB"/>
                 </a:solidFill>
               </a:defRPr>
             </a:pPr>
@@ -3318,7 +3330,7 @@
             <a:pPr>
               <a:defRPr sz="2200" b="1">
                 <a:solidFill>
-                  <a:srgbClr val="06B6D4"/>
+                  <a:srgbClr val="00F0FF"/>
                 </a:solidFill>
               </a:defRPr>
             </a:pPr>
@@ -3331,16 +3343,20 @@
             <a:pPr>
               <a:defRPr sz="1600">
                 <a:solidFill>
-                  <a:srgbClr val="94A3B8"/>
-                </a:solidFill>
-              </a:defRPr>
-            </a:pPr>
-            <a:r>
-              <a:t>GitHub: https://github.com/deswanth12/EvalMesh</a:t>
+                  <a:srgbClr val="9CA3AF"/>
+                </a:solidFill>
+              </a:defRPr>
+            </a:pPr>
+            <a:r>
+              <a:t>GitHub Repository : https://github.com/deswanth12/EvalMesh</a:t>
             </a:r>
             <a:br/>
             <a:r>
-              <a:t>Contact: founder@evalmesh.io</a:t>
+              <a:t>Live Dashboard    : http://localhost:8000</a:t>
+            </a:r>
+            <a:br/>
+            <a:r>
+              <a:t>Contact Email     : founder@evalmesh.io</a:t>
             </a:r>
           </a:p>
         </p:txBody>
@@ -3359,7 +3375,7 @@
     <p:bg>
       <p:bgPr>
         <a:solidFill>
-          <a:srgbClr val="06080E"/>
+          <a:srgbClr val="0B0F19"/>
         </a:solidFill>
         <a:effectLst/>
       </p:bgPr>
@@ -3380,7 +3396,7 @@
         <p:spPr>
           <a:xfrm>
             <a:off x="731520" y="365760"/>
-            <a:ext cx="9144000" cy="365760"/>
+            <a:ext cx="9144000" cy="320040"/>
           </a:xfrm>
           <a:prstGeom prst="rect">
             <a:avLst/>
@@ -3396,12 +3412,12 @@
             <a:pPr>
               <a:defRPr sz="1000" b="1">
                 <a:solidFill>
-                  <a:srgbClr val="06B6D4"/>
-                </a:solidFill>
-              </a:defRPr>
-            </a:pPr>
-            <a:r>
-              <a:t>EVALMESH INVESTOR DECK</a:t>
+                  <a:srgbClr val="00F0FF"/>
+                </a:solidFill>
+              </a:defRPr>
+            </a:pPr>
+            <a:r>
+              <a:t>01 / PROBLEM DEFINITION</a:t>
             </a:r>
           </a:p>
         </p:txBody>
@@ -3415,7 +3431,7 @@
         <p:spPr>
           <a:xfrm>
             <a:off x="731520" y="640080"/>
-            <a:ext cx="10515600" cy="731520"/>
+            <a:ext cx="10698480" cy="685800"/>
           </a:xfrm>
           <a:prstGeom prst="rect">
             <a:avLst/>
@@ -3431,12 +3447,12 @@
             <a:pPr>
               <a:defRPr sz="2600" b="1">
                 <a:solidFill>
-                  <a:srgbClr val="F8FAFC"/>
-                </a:solidFill>
-              </a:defRPr>
-            </a:pPr>
-            <a:r>
-              <a:t>The Problem: Autonomous AI Agents in Production are Vulnerable</a:t>
+                  <a:srgbClr val="F9FAFB"/>
+                </a:solidFill>
+              </a:defRPr>
+            </a:pPr>
+            <a:r>
+              <a:t>The Problem: Autonomous Agents Break in Production</a:t>
             </a:r>
           </a:p>
         </p:txBody>
@@ -3456,7 +3472,7 @@
             <a:avLst/>
           </a:prstGeom>
           <a:solidFill>
-            <a:srgbClr val="0D1322"/>
+            <a:srgbClr val="111827"/>
           </a:solidFill>
           <a:ln w="19050">
             <a:solidFill>
@@ -3509,27 +3525,40 @@
           <a:lstStyle/>
           <a:p>
             <a:pPr>
-              <a:defRPr sz="2000" b="1">
+              <a:defRPr sz="1800" b="1">
                 <a:solidFill>
                   <a:srgbClr val="EF4444"/>
                 </a:solidFill>
               </a:defRPr>
             </a:pPr>
             <a:r>
-              <a:t>💸 Runaway API Bills</a:t>
+              <a:t>💸 Runaway API Billing Spikes</a:t>
             </a:r>
           </a:p>
           <a:p>
             <a:br/>
             <a:pPr>
-              <a:defRPr sz="1400">
-                <a:solidFill>
-                  <a:srgbClr val="94A3B8"/>
-                </a:solidFill>
-              </a:defRPr>
-            </a:pPr>
-            <a:r>
-              <a:t>Buggy agent loops execute 500+ calls overnight, causing surprise $2,000+ API bill spikes per session.</a:t>
+              <a:defRPr sz="1500" b="1">
+                <a:solidFill>
+                  <a:srgbClr val="F9FAFB"/>
+                </a:solidFill>
+              </a:defRPr>
+            </a:pPr>
+            <a:r>
+              <a:t>$2,000+ Surprise Bills</a:t>
+            </a:r>
+          </a:p>
+          <a:p>
+            <a:br/>
+            <a:pPr>
+              <a:defRPr sz="1300">
+                <a:solidFill>
+                  <a:srgbClr val="9CA3AF"/>
+                </a:solidFill>
+              </a:defRPr>
+            </a:pPr>
+            <a:r>
+              <a:t>Recursive agent loops execute 500+ calls overnight without safety limits.</a:t>
             </a:r>
           </a:p>
         </p:txBody>
@@ -3549,7 +3578,7 @@
             <a:avLst/>
           </a:prstGeom>
           <a:solidFill>
-            <a:srgbClr val="0D1322"/>
+            <a:srgbClr val="111827"/>
           </a:solidFill>
           <a:ln w="19050">
             <a:solidFill>
@@ -3602,27 +3631,40 @@
           <a:lstStyle/>
           <a:p>
             <a:pPr>
-              <a:defRPr sz="2000" b="1">
+              <a:defRPr sz="1800" b="1">
                 <a:solidFill>
                   <a:srgbClr val="EF4444"/>
                 </a:solidFill>
               </a:defRPr>
             </a:pPr>
             <a:r>
-              <a:t>🔓 Security &amp; PII Leaks</a:t>
+              <a:t>🔓 Security &amp; PII Data Leaks</a:t>
             </a:r>
           </a:p>
           <a:p>
             <a:br/>
             <a:pPr>
-              <a:defRPr sz="1400">
-                <a:solidFill>
-                  <a:srgbClr val="94A3B8"/>
-                </a:solidFill>
-              </a:defRPr>
-            </a:pPr>
-            <a:r>
-              <a:t>Prompt injection jailbreaks trick bots into leaking system secrets or sensitive customer PII (Emails, SSNs, Credit Cards).</a:t>
+              <a:defRPr sz="1500" b="1">
+                <a:solidFill>
+                  <a:srgbClr val="F9FAFB"/>
+                </a:solidFill>
+              </a:defRPr>
+            </a:pPr>
+            <a:r>
+              <a:t>Zero PII Redaction Egress</a:t>
+            </a:r>
+          </a:p>
+          <a:p>
+            <a:br/>
+            <a:pPr>
+              <a:defRPr sz="1300">
+                <a:solidFill>
+                  <a:srgbClr val="9CA3AF"/>
+                </a:solidFill>
+              </a:defRPr>
+            </a:pPr>
+            <a:r>
+              <a:t>Prompt injection jailbreaks trick bots into leaking system secrets &amp; SSNs.</a:t>
             </a:r>
           </a:p>
         </p:txBody>
@@ -3642,7 +3684,7 @@
             <a:avLst/>
           </a:prstGeom>
           <a:solidFill>
-            <a:srgbClr val="0D1322"/>
+            <a:srgbClr val="111827"/>
           </a:solidFill>
           <a:ln w="19050">
             <a:solidFill>
@@ -3695,27 +3737,40 @@
           <a:lstStyle/>
           <a:p>
             <a:pPr>
-              <a:defRPr sz="2000" b="1">
+              <a:defRPr sz="1800" b="1">
                 <a:solidFill>
                   <a:srgbClr val="EF4444"/>
                 </a:solidFill>
               </a:defRPr>
             </a:pPr>
             <a:r>
-              <a:t>💥 Silent Output Drift</a:t>
+              <a:t>💥 Silent Model Output Drift</a:t>
             </a:r>
           </a:p>
           <a:p>
             <a:br/>
             <a:pPr>
-              <a:defRPr sz="1400">
-                <a:solidFill>
-                  <a:srgbClr val="94A3B8"/>
-                </a:solidFill>
-              </a:defRPr>
-            </a:pPr>
-            <a:r>
-              <a:t>Upstream LLM updates change JSON schema outputs without warning, breaking production client applications.</a:t>
+              <a:defRPr sz="1500" b="1">
+                <a:solidFill>
+                  <a:srgbClr val="F9FAFB"/>
+                </a:solidFill>
+              </a:defRPr>
+            </a:pPr>
+            <a:r>
+              <a:t>Broken Downstream Schema</a:t>
+            </a:r>
+          </a:p>
+          <a:p>
+            <a:br/>
+            <a:pPr>
+              <a:defRPr sz="1300">
+                <a:solidFill>
+                  <a:srgbClr val="9CA3AF"/>
+                </a:solidFill>
+              </a:defRPr>
+            </a:pPr>
+            <a:r>
+              <a:t>Upstream model updates alter JSON outputs, crashing client applications.</a:t>
             </a:r>
           </a:p>
         </p:txBody>
@@ -3734,7 +3789,7 @@
     <p:bg>
       <p:bgPr>
         <a:solidFill>
-          <a:srgbClr val="06080E"/>
+          <a:srgbClr val="0B0F19"/>
         </a:solidFill>
         <a:effectLst/>
       </p:bgPr>
@@ -3755,7 +3810,7 @@
         <p:spPr>
           <a:xfrm>
             <a:off x="731520" y="365760"/>
-            <a:ext cx="9144000" cy="365760"/>
+            <a:ext cx="9144000" cy="320040"/>
           </a:xfrm>
           <a:prstGeom prst="rect">
             <a:avLst/>
@@ -3771,12 +3826,12 @@
             <a:pPr>
               <a:defRPr sz="1000" b="1">
                 <a:solidFill>
-                  <a:srgbClr val="06B6D4"/>
-                </a:solidFill>
-              </a:defRPr>
-            </a:pPr>
-            <a:r>
-              <a:t>EVALMESH INVESTOR DECK</a:t>
+                  <a:srgbClr val="00F0FF"/>
+                </a:solidFill>
+              </a:defRPr>
+            </a:pPr>
+            <a:r>
+              <a:t>02 / THE SOLUTION</a:t>
             </a:r>
           </a:p>
         </p:txBody>
@@ -3790,7 +3845,7 @@
         <p:spPr>
           <a:xfrm>
             <a:off x="731520" y="640080"/>
-            <a:ext cx="10515600" cy="731520"/>
+            <a:ext cx="10698480" cy="685800"/>
           </a:xfrm>
           <a:prstGeom prst="rect">
             <a:avLst/>
@@ -3806,7 +3861,7 @@
             <a:pPr>
               <a:defRPr sz="2600" b="1">
                 <a:solidFill>
-                  <a:srgbClr val="F8FAFC"/>
+                  <a:srgbClr val="F9FAFB"/>
                 </a:solidFill>
               </a:defRPr>
             </a:pPr>
@@ -3831,7 +3886,7 @@
             <a:avLst/>
           </a:prstGeom>
           <a:solidFill>
-            <a:srgbClr val="0D1322"/>
+            <a:srgbClr val="111827"/>
           </a:solidFill>
           <a:ln w="19050">
             <a:solidFill>
@@ -3884,7 +3939,7 @@
           <a:lstStyle/>
           <a:p>
             <a:pPr>
-              <a:defRPr sz="2000" b="1">
+              <a:defRPr sz="1800" b="1">
                 <a:solidFill>
                   <a:srgbClr val="10B981"/>
                 </a:solidFill>
@@ -3897,14 +3952,27 @@
           <a:p>
             <a:br/>
             <a:pPr>
-              <a:defRPr sz="1400">
-                <a:solidFill>
-                  <a:srgbClr val="94A3B8"/>
-                </a:solidFill>
-              </a:defRPr>
-            </a:pPr>
-            <a:r>
-              <a:t>Inline reverse proxy sidecar (&lt;15ms) enforcing real-time WAF firewall, PII DLP redactor, and tool RBAC.</a:t>
+              <a:defRPr sz="1500" b="1">
+                <a:solidFill>
+                  <a:srgbClr val="F9FAFB"/>
+                </a:solidFill>
+              </a:defRPr>
+            </a:pPr>
+            <a:r>
+              <a:t>&lt;15ms Proxy Guardrail</a:t>
+            </a:r>
+          </a:p>
+          <a:p>
+            <a:br/>
+            <a:pPr>
+              <a:defRPr sz="1300">
+                <a:solidFill>
+                  <a:srgbClr val="9CA3AF"/>
+                </a:solidFill>
+              </a:defRPr>
+            </a:pPr>
+            <a:r>
+              <a:t>Inline proxy enforcing real-time WAF, PII DLP redactor, and tool RBAC.</a:t>
             </a:r>
           </a:p>
         </p:txBody>
@@ -3924,7 +3992,7 @@
             <a:avLst/>
           </a:prstGeom>
           <a:solidFill>
-            <a:srgbClr val="0D1322"/>
+            <a:srgbClr val="111827"/>
           </a:solidFill>
           <a:ln w="19050">
             <a:solidFill>
@@ -3977,7 +4045,7 @@
           <a:lstStyle/>
           <a:p>
             <a:pPr>
-              <a:defRPr sz="2000" b="1">
+              <a:defRPr sz="1800" b="1">
                 <a:solidFill>
                   <a:srgbClr val="10B981"/>
                 </a:solidFill>
@@ -3990,14 +4058,27 @@
           <a:p>
             <a:br/>
             <a:pPr>
-              <a:defRPr sz="1400">
-                <a:solidFill>
-                  <a:srgbClr val="94A3B8"/>
-                </a:solidFill>
-              </a:defRPr>
-            </a:pPr>
-            <a:r>
-              <a:t>Semantic cache answering queries in 3ms for $0 cost + auto-killing runaway agent loops at message depth 25.</a:t>
+              <a:defRPr sz="1500" b="1">
+                <a:solidFill>
+                  <a:srgbClr val="F9FAFB"/>
+                </a:solidFill>
+              </a:defRPr>
+            </a:pPr>
+            <a:r>
+              <a:t>60-90% Cost Reduction</a:t>
+            </a:r>
+          </a:p>
+          <a:p>
+            <a:br/>
+            <a:pPr>
+              <a:defRPr sz="1300">
+                <a:solidFill>
+                  <a:srgbClr val="9CA3AF"/>
+                </a:solidFill>
+              </a:defRPr>
+            </a:pPr>
+            <a:r>
+              <a:t>Semantic cache (3ms, $0) + automatic circuit breaker killing loops at depth &gt; 25.</a:t>
             </a:r>
           </a:p>
         </p:txBody>
@@ -4017,7 +4098,7 @@
             <a:avLst/>
           </a:prstGeom>
           <a:solidFill>
-            <a:srgbClr val="0D1322"/>
+            <a:srgbClr val="111827"/>
           </a:solidFill>
           <a:ln w="19050">
             <a:solidFill>
@@ -4070,7 +4151,7 @@
           <a:lstStyle/>
           <a:p>
             <a:pPr>
-              <a:defRPr sz="2000" b="1">
+              <a:defRPr sz="1800" b="1">
                 <a:solidFill>
                   <a:srgbClr val="10B981"/>
                 </a:solidFill>
@@ -4083,14 +4164,27 @@
           <a:p>
             <a:br/>
             <a:pPr>
-              <a:defRPr sz="1400">
-                <a:solidFill>
-                  <a:srgbClr val="94A3B8"/>
-                </a:solidFill>
-              </a:defRPr>
-            </a:pPr>
-            <a:r>
-              <a:t>Continuous evaluation harness detecting semantic output drift &amp; auto-correcting malformed JSON schema outputs.</a:t>
+              <a:defRPr sz="1500" b="1">
+                <a:solidFill>
+                  <a:srgbClr val="F9FAFB"/>
+                </a:solidFill>
+              </a:defRPr>
+            </a:pPr>
+            <a:r>
+              <a:t>Continuous Evaluation</a:t>
+            </a:r>
+          </a:p>
+          <a:p>
+            <a:br/>
+            <a:pPr>
+              <a:defRPr sz="1300">
+                <a:solidFill>
+                  <a:srgbClr val="9CA3AF"/>
+                </a:solidFill>
+              </a:defRPr>
+            </a:pPr>
+            <a:r>
+              <a:t>Detects semantic output drift &amp; auto-corrects malformed JSON schema outputs.</a:t>
             </a:r>
           </a:p>
         </p:txBody>
@@ -4109,7 +4203,7 @@
     <p:bg>
       <p:bgPr>
         <a:solidFill>
-          <a:srgbClr val="06080E"/>
+          <a:srgbClr val="0B0F19"/>
         </a:solidFill>
         <a:effectLst/>
       </p:bgPr>
@@ -4130,7 +4224,7 @@
         <p:spPr>
           <a:xfrm>
             <a:off x="731520" y="365760"/>
-            <a:ext cx="9144000" cy="365760"/>
+            <a:ext cx="9144000" cy="320040"/>
           </a:xfrm>
           <a:prstGeom prst="rect">
             <a:avLst/>
@@ -4146,12 +4240,12 @@
             <a:pPr>
               <a:defRPr sz="1000" b="1">
                 <a:solidFill>
-                  <a:srgbClr val="06B6D4"/>
-                </a:solidFill>
-              </a:defRPr>
-            </a:pPr>
-            <a:r>
-              <a:t>EVALMESH INVESTOR DECK</a:t>
+                  <a:srgbClr val="00F0FF"/>
+                </a:solidFill>
+              </a:defRPr>
+            </a:pPr>
+            <a:r>
+              <a:t>03 / SYSTEM ARCHITECTURE</a:t>
             </a:r>
           </a:p>
         </p:txBody>
@@ -4165,7 +4259,7 @@
         <p:spPr>
           <a:xfrm>
             <a:off x="731520" y="640080"/>
-            <a:ext cx="10515600" cy="731520"/>
+            <a:ext cx="10698480" cy="685800"/>
           </a:xfrm>
           <a:prstGeom prst="rect">
             <a:avLst/>
@@ -4181,7 +4275,7 @@
             <a:pPr>
               <a:defRPr sz="2600" b="1">
                 <a:solidFill>
-                  <a:srgbClr val="F8FAFC"/>
+                  <a:srgbClr val="F9FAFB"/>
                 </a:solidFill>
               </a:defRPr>
             </a:pPr>
@@ -4206,7 +4300,7 @@
             <a:avLst/>
           </a:prstGeom>
           <a:solidFill>
-            <a:srgbClr val="0D1322"/>
+            <a:srgbClr val="111827"/>
           </a:solidFill>
           <a:ln>
             <a:solidFill>
@@ -4261,19 +4355,19 @@
             <a:pPr>
               <a:defRPr sz="1600" b="1">
                 <a:solidFill>
-                  <a:srgbClr val="06B6D4"/>
-                </a:solidFill>
-              </a:defRPr>
-            </a:pPr>
-            <a:r>
-              <a:t>CLIENT APPLICATION (Python / TypeScript / REST cURL)</a:t>
+                  <a:srgbClr val="00F0FF"/>
+                </a:solidFill>
+              </a:defRPr>
+            </a:pPr>
+            <a:r>
+              <a:t>CLIENT APPLICATION (Python SDK / TypeScript SDK / cURL REST)</a:t>
             </a:r>
           </a:p>
           <a:p>
             <a:pPr>
               <a:defRPr sz="1400">
                 <a:solidFill>
-                  <a:srgbClr val="F8FAFC"/>
+                  <a:srgbClr val="F9FAFB"/>
                 </a:solidFill>
                 <a:latin typeface="JetBrains Mono"/>
               </a:defRPr>
@@ -4342,7 +4436,7 @@
     <p:bg>
       <p:bgPr>
         <a:solidFill>
-          <a:srgbClr val="06080E"/>
+          <a:srgbClr val="0B0F19"/>
         </a:solidFill>
         <a:effectLst/>
       </p:bgPr>
@@ -4363,7 +4457,7 @@
         <p:spPr>
           <a:xfrm>
             <a:off x="731520" y="365760"/>
-            <a:ext cx="9144000" cy="365760"/>
+            <a:ext cx="9144000" cy="320040"/>
           </a:xfrm>
           <a:prstGeom prst="rect">
             <a:avLst/>
@@ -4379,12 +4473,12 @@
             <a:pPr>
               <a:defRPr sz="1000" b="1">
                 <a:solidFill>
-                  <a:srgbClr val="06B6D4"/>
-                </a:solidFill>
-              </a:defRPr>
-            </a:pPr>
-            <a:r>
-              <a:t>EVALMESH INVESTOR DECK</a:t>
+                  <a:srgbClr val="00F0FF"/>
+                </a:solidFill>
+              </a:defRPr>
+            </a:pPr>
+            <a:r>
+              <a:t>04 / PRODUCT CAPABILITIES</a:t>
             </a:r>
           </a:p>
         </p:txBody>
@@ -4398,7 +4492,7 @@
         <p:spPr>
           <a:xfrm>
             <a:off x="731520" y="640080"/>
-            <a:ext cx="10515600" cy="731520"/>
+            <a:ext cx="10698480" cy="685800"/>
           </a:xfrm>
           <a:prstGeom prst="rect">
             <a:avLst/>
@@ -4414,7 +4508,7 @@
             <a:pPr>
               <a:defRPr sz="2600" b="1">
                 <a:solidFill>
-                  <a:srgbClr val="F8FAFC"/>
+                  <a:srgbClr val="F9FAFB"/>
                 </a:solidFill>
               </a:defRPr>
             </a:pPr>
@@ -4439,7 +4533,7 @@
             <a:avLst/>
           </a:prstGeom>
           <a:solidFill>
-            <a:srgbClr val="0D1322"/>
+            <a:srgbClr val="111827"/>
           </a:solidFill>
           <a:ln>
             <a:solidFill>
@@ -4494,7 +4588,7 @@
             <a:pPr>
               <a:defRPr sz="1600" b="1">
                 <a:solidFill>
-                  <a:srgbClr val="F8FAFC"/>
+                  <a:srgbClr val="F9FAFB"/>
                 </a:solidFill>
               </a:defRPr>
             </a:pPr>
@@ -4506,7 +4600,7 @@
             <a:pPr>
               <a:defRPr sz="1200">
                 <a:solidFill>
-                  <a:srgbClr val="94A3B8"/>
+                  <a:srgbClr val="9CA3AF"/>
                 </a:solidFill>
               </a:defRPr>
             </a:pPr>
@@ -4531,7 +4625,7 @@
             <a:avLst/>
           </a:prstGeom>
           <a:solidFill>
-            <a:srgbClr val="0D1322"/>
+            <a:srgbClr val="111827"/>
           </a:solidFill>
           <a:ln>
             <a:solidFill>
@@ -4586,7 +4680,7 @@
             <a:pPr>
               <a:defRPr sz="1600" b="1">
                 <a:solidFill>
-                  <a:srgbClr val="F8FAFC"/>
+                  <a:srgbClr val="F9FAFB"/>
                 </a:solidFill>
               </a:defRPr>
             </a:pPr>
@@ -4598,7 +4692,7 @@
             <a:pPr>
               <a:defRPr sz="1200">
                 <a:solidFill>
-                  <a:srgbClr val="94A3B8"/>
+                  <a:srgbClr val="9CA3AF"/>
                 </a:solidFill>
               </a:defRPr>
             </a:pPr>
@@ -4623,7 +4717,7 @@
             <a:avLst/>
           </a:prstGeom>
           <a:solidFill>
-            <a:srgbClr val="0D1322"/>
+            <a:srgbClr val="111827"/>
           </a:solidFill>
           <a:ln>
             <a:solidFill>
@@ -4678,7 +4772,7 @@
             <a:pPr>
               <a:defRPr sz="1600" b="1">
                 <a:solidFill>
-                  <a:srgbClr val="F8FAFC"/>
+                  <a:srgbClr val="F9FAFB"/>
                 </a:solidFill>
               </a:defRPr>
             </a:pPr>
@@ -4690,7 +4784,7 @@
             <a:pPr>
               <a:defRPr sz="1200">
                 <a:solidFill>
-                  <a:srgbClr val="94A3B8"/>
+                  <a:srgbClr val="9CA3AF"/>
                 </a:solidFill>
               </a:defRPr>
             </a:pPr>
@@ -4715,7 +4809,7 @@
             <a:avLst/>
           </a:prstGeom>
           <a:solidFill>
-            <a:srgbClr val="0D1322"/>
+            <a:srgbClr val="111827"/>
           </a:solidFill>
           <a:ln>
             <a:solidFill>
@@ -4770,7 +4864,7 @@
             <a:pPr>
               <a:defRPr sz="1600" b="1">
                 <a:solidFill>
-                  <a:srgbClr val="F8FAFC"/>
+                  <a:srgbClr val="F9FAFB"/>
                 </a:solidFill>
               </a:defRPr>
             </a:pPr>
@@ -4782,7 +4876,7 @@
             <a:pPr>
               <a:defRPr sz="1200">
                 <a:solidFill>
-                  <a:srgbClr val="94A3B8"/>
+                  <a:srgbClr val="9CA3AF"/>
                 </a:solidFill>
               </a:defRPr>
             </a:pPr>
@@ -4807,7 +4901,7 @@
             <a:avLst/>
           </a:prstGeom>
           <a:solidFill>
-            <a:srgbClr val="0D1322"/>
+            <a:srgbClr val="111827"/>
           </a:solidFill>
           <a:ln>
             <a:solidFill>
@@ -4862,7 +4956,7 @@
             <a:pPr>
               <a:defRPr sz="1600" b="1">
                 <a:solidFill>
-                  <a:srgbClr val="F8FAFC"/>
+                  <a:srgbClr val="F9FAFB"/>
                 </a:solidFill>
               </a:defRPr>
             </a:pPr>
@@ -4874,7 +4968,7 @@
             <a:pPr>
               <a:defRPr sz="1200">
                 <a:solidFill>
-                  <a:srgbClr val="94A3B8"/>
+                  <a:srgbClr val="9CA3AF"/>
                 </a:solidFill>
               </a:defRPr>
             </a:pPr>
@@ -4899,7 +4993,7 @@
             <a:avLst/>
           </a:prstGeom>
           <a:solidFill>
-            <a:srgbClr val="0D1322"/>
+            <a:srgbClr val="111827"/>
           </a:solidFill>
           <a:ln>
             <a:solidFill>
@@ -4954,7 +5048,7 @@
             <a:pPr>
               <a:defRPr sz="1600" b="1">
                 <a:solidFill>
-                  <a:srgbClr val="F8FAFC"/>
+                  <a:srgbClr val="F9FAFB"/>
                 </a:solidFill>
               </a:defRPr>
             </a:pPr>
@@ -4966,7 +5060,7 @@
             <a:pPr>
               <a:defRPr sz="1200">
                 <a:solidFill>
-                  <a:srgbClr val="94A3B8"/>
+                  <a:srgbClr val="9CA3AF"/>
                 </a:solidFill>
               </a:defRPr>
             </a:pPr>
@@ -4991,7 +5085,7 @@
             <a:avLst/>
           </a:prstGeom>
           <a:solidFill>
-            <a:srgbClr val="0D1322"/>
+            <a:srgbClr val="111827"/>
           </a:solidFill>
           <a:ln>
             <a:solidFill>
@@ -5046,7 +5140,7 @@
             <a:pPr>
               <a:defRPr sz="1600" b="1">
                 <a:solidFill>
-                  <a:srgbClr val="F8FAFC"/>
+                  <a:srgbClr val="F9FAFB"/>
                 </a:solidFill>
               </a:defRPr>
             </a:pPr>
@@ -5058,7 +5152,7 @@
             <a:pPr>
               <a:defRPr sz="1200">
                 <a:solidFill>
-                  <a:srgbClr val="94A3B8"/>
+                  <a:srgbClr val="9CA3AF"/>
                 </a:solidFill>
               </a:defRPr>
             </a:pPr>
@@ -5083,7 +5177,7 @@
             <a:avLst/>
           </a:prstGeom>
           <a:solidFill>
-            <a:srgbClr val="0D1322"/>
+            <a:srgbClr val="111827"/>
           </a:solidFill>
           <a:ln>
             <a:solidFill>
@@ -5138,7 +5232,7 @@
             <a:pPr>
               <a:defRPr sz="1600" b="1">
                 <a:solidFill>
-                  <a:srgbClr val="F8FAFC"/>
+                  <a:srgbClr val="F9FAFB"/>
                 </a:solidFill>
               </a:defRPr>
             </a:pPr>
@@ -5150,7 +5244,7 @@
             <a:pPr>
               <a:defRPr sz="1200">
                 <a:solidFill>
-                  <a:srgbClr val="94A3B8"/>
+                  <a:srgbClr val="9CA3AF"/>
                 </a:solidFill>
               </a:defRPr>
             </a:pPr>
@@ -5174,7 +5268,7 @@
     <p:bg>
       <p:bgPr>
         <a:solidFill>
-          <a:srgbClr val="06080E"/>
+          <a:srgbClr val="0B0F19"/>
         </a:solidFill>
         <a:effectLst/>
       </p:bgPr>
@@ -5195,7 +5289,7 @@
         <p:spPr>
           <a:xfrm>
             <a:off x="731520" y="365760"/>
-            <a:ext cx="9144000" cy="365760"/>
+            <a:ext cx="9144000" cy="320040"/>
           </a:xfrm>
           <a:prstGeom prst="rect">
             <a:avLst/>
@@ -5211,12 +5305,12 @@
             <a:pPr>
               <a:defRPr sz="1000" b="1">
                 <a:solidFill>
-                  <a:srgbClr val="06B6D4"/>
-                </a:solidFill>
-              </a:defRPr>
-            </a:pPr>
-            <a:r>
-              <a:t>EVALMESH INVESTOR DECK</a:t>
+                  <a:srgbClr val="00F0FF"/>
+                </a:solidFill>
+              </a:defRPr>
+            </a:pPr>
+            <a:r>
+              <a:t>05 / ENTERPRISE GOVERNANCE</a:t>
             </a:r>
           </a:p>
         </p:txBody>
@@ -5230,7 +5324,7 @@
         <p:spPr>
           <a:xfrm>
             <a:off x="731520" y="640080"/>
-            <a:ext cx="10515600" cy="731520"/>
+            <a:ext cx="10698480" cy="685800"/>
           </a:xfrm>
           <a:prstGeom prst="rect">
             <a:avLst/>
@@ -5246,7 +5340,7 @@
             <a:pPr>
               <a:defRPr sz="2600" b="1">
                 <a:solidFill>
-                  <a:srgbClr val="F8FAFC"/>
+                  <a:srgbClr val="F9FAFB"/>
                 </a:solidFill>
               </a:defRPr>
             </a:pPr>
@@ -5271,7 +5365,7 @@
             <a:avLst/>
           </a:prstGeom>
           <a:solidFill>
-            <a:srgbClr val="0D1322"/>
+            <a:srgbClr val="111827"/>
           </a:solidFill>
           <a:ln>
             <a:solidFill>
@@ -5326,7 +5420,7 @@
             <a:pPr>
               <a:defRPr sz="1600" b="1">
                 <a:solidFill>
-                  <a:srgbClr val="F8FAFC"/>
+                  <a:srgbClr val="F9FAFB"/>
                 </a:solidFill>
               </a:defRPr>
             </a:pPr>
@@ -5351,7 +5445,7 @@
             <a:avLst/>
           </a:prstGeom>
           <a:solidFill>
-            <a:srgbClr val="0D1322"/>
+            <a:srgbClr val="111827"/>
           </a:solidFill>
           <a:ln>
             <a:solidFill>
@@ -5406,7 +5500,7 @@
             <a:pPr>
               <a:defRPr sz="1600" b="1">
                 <a:solidFill>
-                  <a:srgbClr val="F8FAFC"/>
+                  <a:srgbClr val="F9FAFB"/>
                 </a:solidFill>
               </a:defRPr>
             </a:pPr>
@@ -5431,7 +5525,7 @@
             <a:avLst/>
           </a:prstGeom>
           <a:solidFill>
-            <a:srgbClr val="0D1322"/>
+            <a:srgbClr val="111827"/>
           </a:solidFill>
           <a:ln>
             <a:solidFill>
@@ -5486,7 +5580,7 @@
             <a:pPr>
               <a:defRPr sz="1600" b="1">
                 <a:solidFill>
-                  <a:srgbClr val="F8FAFC"/>
+                  <a:srgbClr val="F9FAFB"/>
                 </a:solidFill>
               </a:defRPr>
             </a:pPr>
@@ -5511,7 +5605,7 @@
             <a:avLst/>
           </a:prstGeom>
           <a:solidFill>
-            <a:srgbClr val="0D1322"/>
+            <a:srgbClr val="111827"/>
           </a:solidFill>
           <a:ln>
             <a:solidFill>
@@ -5566,7 +5660,7 @@
             <a:pPr>
               <a:defRPr sz="1600" b="1">
                 <a:solidFill>
-                  <a:srgbClr val="F8FAFC"/>
+                  <a:srgbClr val="F9FAFB"/>
                 </a:solidFill>
               </a:defRPr>
             </a:pPr>
@@ -5591,7 +5685,7 @@
             <a:avLst/>
           </a:prstGeom>
           <a:solidFill>
-            <a:srgbClr val="0D1322"/>
+            <a:srgbClr val="111827"/>
           </a:solidFill>
           <a:ln>
             <a:solidFill>
@@ -5646,7 +5740,7 @@
             <a:pPr>
               <a:defRPr sz="1600" b="1">
                 <a:solidFill>
-                  <a:srgbClr val="F8FAFC"/>
+                  <a:srgbClr val="F9FAFB"/>
                 </a:solidFill>
               </a:defRPr>
             </a:pPr>
@@ -5670,7 +5764,7 @@
     <p:bg>
       <p:bgPr>
         <a:solidFill>
-          <a:srgbClr val="06080E"/>
+          <a:srgbClr val="0B0F19"/>
         </a:solidFill>
         <a:effectLst/>
       </p:bgPr>
@@ -5691,7 +5785,7 @@
         <p:spPr>
           <a:xfrm>
             <a:off x="731520" y="365760"/>
-            <a:ext cx="9144000" cy="365760"/>
+            <a:ext cx="9144000" cy="320040"/>
           </a:xfrm>
           <a:prstGeom prst="rect">
             <a:avLst/>
@@ -5707,12 +5801,12 @@
             <a:pPr>
               <a:defRPr sz="1000" b="1">
                 <a:solidFill>
-                  <a:srgbClr val="06B6D4"/>
-                </a:solidFill>
-              </a:defRPr>
-            </a:pPr>
-            <a:r>
-              <a:t>EVALMESH INVESTOR DECK</a:t>
+                  <a:srgbClr val="00F0FF"/>
+                </a:solidFill>
+              </a:defRPr>
+            </a:pPr>
+            <a:r>
+              <a:t>06 / MARKET OPPORTUNITY</a:t>
             </a:r>
           </a:p>
         </p:txBody>
@@ -5726,7 +5820,7 @@
         <p:spPr>
           <a:xfrm>
             <a:off x="731520" y="640080"/>
-            <a:ext cx="10515600" cy="731520"/>
+            <a:ext cx="10698480" cy="685800"/>
           </a:xfrm>
           <a:prstGeom prst="rect">
             <a:avLst/>
@@ -5742,12 +5836,12 @@
             <a:pPr>
               <a:defRPr sz="2600" b="1">
                 <a:solidFill>
-                  <a:srgbClr val="F8FAFC"/>
-                </a:solidFill>
-              </a:defRPr>
-            </a:pPr>
-            <a:r>
-              <a:t>Business Model &amp; Tiered Monetization</a:t>
+                  <a:srgbClr val="F9FAFB"/>
+                </a:solidFill>
+              </a:defRPr>
+            </a:pPr>
+            <a:r>
+              <a:t>Market Opportunity: $50B AI Infrastructure Frontier</a:t>
             </a:r>
           </a:p>
         </p:txBody>
@@ -5761,17 +5855,17 @@
         <p:spPr>
           <a:xfrm>
             <a:off x="731520" y="1645920"/>
-            <a:ext cx="2514600" cy="4389120"/>
+            <a:ext cx="3291840" cy="4389120"/>
           </a:xfrm>
           <a:prstGeom prst="roundRect">
             <a:avLst/>
           </a:prstGeom>
           <a:solidFill>
-            <a:srgbClr val="0D1322"/>
+            <a:srgbClr val="111827"/>
           </a:solidFill>
-          <a:ln w="25400">
+          <a:ln w="19050">
             <a:solidFill>
-              <a:srgbClr val="3B82F6"/>
+              <a:srgbClr val="00F0FF"/>
             </a:solidFill>
           </a:ln>
         </p:spPr>
@@ -5805,8 +5899,8 @@
         </p:nvSpPr>
         <p:spPr>
           <a:xfrm>
-            <a:off x="868680" y="1828800"/>
-            <a:ext cx="2240280" cy="4023360"/>
+            <a:off x="914400" y="1920240"/>
+            <a:ext cx="2926080" cy="3840480"/>
           </a:xfrm>
           <a:prstGeom prst="rect">
             <a:avLst/>
@@ -5820,51 +5914,40 @@
           <a:lstStyle/>
           <a:p>
             <a:pPr>
-              <a:defRPr sz="2200" b="1">
-                <a:solidFill>
-                  <a:srgbClr val="3B82F6"/>
-                </a:solidFill>
-              </a:defRPr>
-            </a:pPr>
-            <a:r>
-              <a:t>Starter</a:t>
-            </a:r>
-          </a:p>
-          <a:p>
-            <a:pPr>
-              <a:defRPr sz="2600" b="1">
-                <a:solidFill>
-                  <a:srgbClr val="F8FAFC"/>
-                </a:solidFill>
-              </a:defRPr>
-            </a:pPr>
-            <a:r>
-              <a:t>$0 / mo</a:t>
+              <a:defRPr sz="3600" b="1">
+                <a:solidFill>
+                  <a:srgbClr val="00F0FF"/>
+                </a:solidFill>
+              </a:defRPr>
+            </a:pPr>
+            <a:r>
+              <a:t>$50 Billion</a:t>
             </a:r>
           </a:p>
           <a:p>
             <a:br/>
             <a:pPr>
+              <a:defRPr sz="1600" b="1">
+                <a:solidFill>
+                  <a:srgbClr val="F9FAFB"/>
+                </a:solidFill>
+              </a:defRPr>
+            </a:pPr>
+            <a:r>
+              <a:t>Total Addressable Market (TAM)</a:t>
+            </a:r>
+          </a:p>
+          <a:p>
+            <a:br/>
+            <a:pPr>
               <a:defRPr sz="1300">
                 <a:solidFill>
-                  <a:srgbClr val="94A3B8"/>
-                </a:solidFill>
-              </a:defRPr>
-            </a:pPr>
-            <a:r>
-              <a:t>100k req/mo</a:t>
-            </a:r>
-            <a:br/>
-            <a:r>
-              <a:t>PII Redactor</a:t>
-            </a:r>
-            <a:br/>
-            <a:r>
-              <a:t>Prompt WAF</a:t>
-            </a:r>
-            <a:br/>
-            <a:r>
-              <a:t>Web Dashboard</a:t>
+                  <a:srgbClr val="9CA3AF"/>
+                </a:solidFill>
+              </a:defRPr>
+            </a:pPr>
+            <a:r>
+              <a:t>Enterprise AI security, governance, and infrastructure proxy sidecars by 2028.</a:t>
             </a:r>
           </a:p>
         </p:txBody>
@@ -5877,18 +5960,18 @@
         </p:nvSpPr>
         <p:spPr>
           <a:xfrm>
-            <a:off x="3429000" y="1645920"/>
-            <a:ext cx="2514600" cy="4389120"/>
+            <a:off x="4297680" y="1645920"/>
+            <a:ext cx="3291840" cy="4389120"/>
           </a:xfrm>
           <a:prstGeom prst="roundRect">
             <a:avLst/>
           </a:prstGeom>
           <a:solidFill>
-            <a:srgbClr val="0D1322"/>
+            <a:srgbClr val="111827"/>
           </a:solidFill>
-          <a:ln w="25400">
+          <a:ln w="19050">
             <a:solidFill>
-              <a:srgbClr val="10B981"/>
+              <a:srgbClr val="00F0FF"/>
             </a:solidFill>
           </a:ln>
         </p:spPr>
@@ -5922,8 +6005,8 @@
         </p:nvSpPr>
         <p:spPr>
           <a:xfrm>
-            <a:off x="3566160" y="1828800"/>
-            <a:ext cx="2240280" cy="4023360"/>
+            <a:off x="4480560" y="1920240"/>
+            <a:ext cx="2926080" cy="3840480"/>
           </a:xfrm>
           <a:prstGeom prst="rect">
             <a:avLst/>
@@ -5937,51 +6020,40 @@
           <a:lstStyle/>
           <a:p>
             <a:pPr>
-              <a:defRPr sz="2200" b="1">
-                <a:solidFill>
-                  <a:srgbClr val="10B981"/>
-                </a:solidFill>
-              </a:defRPr>
-            </a:pPr>
-            <a:r>
-              <a:t>Pro</a:t>
-            </a:r>
-          </a:p>
-          <a:p>
-            <a:pPr>
-              <a:defRPr sz="2600" b="1">
-                <a:solidFill>
-                  <a:srgbClr val="F8FAFC"/>
-                </a:solidFill>
-              </a:defRPr>
-            </a:pPr>
-            <a:r>
-              <a:t>$49 / mo</a:t>
+              <a:defRPr sz="3600" b="1">
+                <a:solidFill>
+                  <a:srgbClr val="00F0FF"/>
+                </a:solidFill>
+              </a:defRPr>
+            </a:pPr>
+            <a:r>
+              <a:t>400% YoY</a:t>
             </a:r>
           </a:p>
           <a:p>
             <a:br/>
             <a:pPr>
+              <a:defRPr sz="1600" b="1">
+                <a:solidFill>
+                  <a:srgbClr val="F9FAFB"/>
+                </a:solidFill>
+              </a:defRPr>
+            </a:pPr>
+            <a:r>
+              <a:t>AI Agent Adoption Growth</a:t>
+            </a:r>
+          </a:p>
+          <a:p>
+            <a:br/>
+            <a:pPr>
               <a:defRPr sz="1300">
                 <a:solidFill>
-                  <a:srgbClr val="94A3B8"/>
-                </a:solidFill>
-              </a:defRPr>
-            </a:pPr>
-            <a:r>
-              <a:t>1M req/mo</a:t>
-            </a:r>
-            <a:br/>
-            <a:r>
-              <a:t>Semantic Cache</a:t>
-            </a:r>
-            <a:br/>
-            <a:r>
-              <a:t>Smart Cost Router</a:t>
-            </a:r>
-            <a:br/>
-            <a:r>
-              <a:t>Auto-Healing</a:t>
+                  <a:srgbClr val="9CA3AF"/>
+                </a:solidFill>
+              </a:defRPr>
+            </a:pPr>
+            <a:r>
+              <a:t>Over 80% of Fortune 500 enterprises are deploying autonomous AI agents in 2026.</a:t>
             </a:r>
           </a:p>
         </p:txBody>
@@ -5994,18 +6066,18 @@
         </p:nvSpPr>
         <p:spPr>
           <a:xfrm>
-            <a:off x="6126480" y="1645920"/>
-            <a:ext cx="2514600" cy="4389120"/>
+            <a:off x="7863840" y="1645920"/>
+            <a:ext cx="3291840" cy="4389120"/>
           </a:xfrm>
           <a:prstGeom prst="roundRect">
             <a:avLst/>
           </a:prstGeom>
           <a:solidFill>
-            <a:srgbClr val="0D1322"/>
+            <a:srgbClr val="111827"/>
           </a:solidFill>
-          <a:ln w="25400">
+          <a:ln w="19050">
             <a:solidFill>
-              <a:srgbClr val="8B5CF6"/>
+              <a:srgbClr val="00F0FF"/>
             </a:solidFill>
           </a:ln>
         </p:spPr>
@@ -6039,8 +6111,8 @@
         </p:nvSpPr>
         <p:spPr>
           <a:xfrm>
-            <a:off x="6263640" y="1828800"/>
-            <a:ext cx="2240280" cy="4023360"/>
+            <a:off x="8046720" y="1920240"/>
+            <a:ext cx="2926080" cy="3840480"/>
           </a:xfrm>
           <a:prstGeom prst="rect">
             <a:avLst/>
@@ -6054,168 +6126,40 @@
           <a:lstStyle/>
           <a:p>
             <a:pPr>
-              <a:defRPr sz="2200" b="1">
-                <a:solidFill>
-                  <a:srgbClr val="8B5CF6"/>
-                </a:solidFill>
-              </a:defRPr>
-            </a:pPr>
-            <a:r>
-              <a:t>Team</a:t>
-            </a:r>
-          </a:p>
-          <a:p>
-            <a:pPr>
-              <a:defRPr sz="2600" b="1">
-                <a:solidFill>
-                  <a:srgbClr val="F8FAFC"/>
-                </a:solidFill>
-              </a:defRPr>
-            </a:pPr>
-            <a:r>
-              <a:t>$299 / mo</a:t>
+              <a:defRPr sz="3600" b="1">
+                <a:solidFill>
+                  <a:srgbClr val="00F0FF"/>
+                </a:solidFill>
+              </a:defRPr>
+            </a:pPr>
+            <a:r>
+              <a:t>60-90% ROI</a:t>
             </a:r>
           </a:p>
           <a:p>
             <a:br/>
             <a:pPr>
+              <a:defRPr sz="1600" b="1">
+                <a:solidFill>
+                  <a:srgbClr val="F9FAFB"/>
+                </a:solidFill>
+              </a:defRPr>
+            </a:pPr>
+            <a:r>
+              <a:t>Direct API Dollar Savings</a:t>
+            </a:r>
+          </a:p>
+          <a:p>
+            <a:br/>
+            <a:pPr>
               <a:defRPr sz="1300">
                 <a:solidFill>
-                  <a:srgbClr val="94A3B8"/>
-                </a:solidFill>
-              </a:defRPr>
-            </a:pPr>
-            <a:r>
-              <a:t>10M req/mo</a:t>
-            </a:r>
-            <a:br/>
-            <a:r>
-              <a:t>OTel Exporter</a:t>
-            </a:r>
-            <a:br/>
-            <a:r>
-              <a:t>Multi-Model Router</a:t>
-            </a:r>
-            <a:br/>
-            <a:r>
-              <a:t>Priority Support</a:t>
-            </a:r>
-          </a:p>
-        </p:txBody>
-      </p:sp>
-      <p:sp>
-        <p:nvSpPr>
-          <p:cNvPr id="10" name="Rounded Rectangle 9"/>
-          <p:cNvSpPr/>
-          <p:nvPr/>
-        </p:nvSpPr>
-        <p:spPr>
-          <a:xfrm>
-            <a:off x="8823960" y="1645920"/>
-            <a:ext cx="2514600" cy="4389120"/>
-          </a:xfrm>
-          <a:prstGeom prst="roundRect">
-            <a:avLst/>
-          </a:prstGeom>
-          <a:solidFill>
-            <a:srgbClr val="0D1322"/>
-          </a:solidFill>
-          <a:ln w="25400">
-            <a:solidFill>
-              <a:srgbClr val="06B6D4"/>
-            </a:solidFill>
-          </a:ln>
-        </p:spPr>
-        <p:style>
-          <a:lnRef idx="1">
-            <a:schemeClr val="accent1"/>
-          </a:lnRef>
-          <a:fillRef idx="3">
-            <a:schemeClr val="accent1"/>
-          </a:fillRef>
-          <a:effectRef idx="2">
-            <a:schemeClr val="accent1"/>
-          </a:effectRef>
-          <a:fontRef idx="minor">
-            <a:schemeClr val="lt1"/>
-          </a:fontRef>
-        </p:style>
-        <p:txBody>
-          <a:bodyPr rtlCol="0" anchor="ctr"/>
-          <a:lstStyle/>
-          <a:p>
-            <a:pPr algn="ctr"/>
-          </a:p>
-        </p:txBody>
-      </p:sp>
-      <p:sp>
-        <p:nvSpPr>
-          <p:cNvPr id="11" name="TextBox 10"/>
-          <p:cNvSpPr txBox="1"/>
-          <p:nvPr/>
-        </p:nvSpPr>
-        <p:spPr>
-          <a:xfrm>
-            <a:off x="8961120" y="1828800"/>
-            <a:ext cx="2240280" cy="4023360"/>
-          </a:xfrm>
-          <a:prstGeom prst="rect">
-            <a:avLst/>
-          </a:prstGeom>
-          <a:noFill/>
-        </p:spPr>
-        <p:txBody>
-          <a:bodyPr wrap="square">
-            <a:spAutoFit/>
-          </a:bodyPr>
-          <a:lstStyle/>
-          <a:p>
-            <a:pPr>
-              <a:defRPr sz="2200" b="1">
-                <a:solidFill>
-                  <a:srgbClr val="06B6D4"/>
-                </a:solidFill>
-              </a:defRPr>
-            </a:pPr>
-            <a:r>
-              <a:t>Enterprise</a:t>
-            </a:r>
-          </a:p>
-          <a:p>
-            <a:pPr>
-              <a:defRPr sz="2600" b="1">
-                <a:solidFill>
-                  <a:srgbClr val="F8FAFC"/>
-                </a:solidFill>
-              </a:defRPr>
-            </a:pPr>
-            <a:r>
-              <a:t>Custom</a:t>
-            </a:r>
-          </a:p>
-          <a:p>
-            <a:br/>
-            <a:pPr>
-              <a:defRPr sz="1300">
-                <a:solidFill>
-                  <a:srgbClr val="94A3B8"/>
-                </a:solidFill>
-              </a:defRPr>
-            </a:pPr>
-            <a:r>
-              <a:t>Unlimited req</a:t>
-            </a:r>
-            <a:br/>
-            <a:r>
-              <a:t>Dedicated VPC</a:t>
-            </a:r>
-            <a:br/>
-            <a:r>
-              <a:t>SLA Guarantee</a:t>
-            </a:r>
-            <a:br/>
-            <a:r>
-              <a:t>24/7 Support</a:t>
+                  <a:srgbClr val="9CA3AF"/>
+                </a:solidFill>
+              </a:defRPr>
+            </a:pPr>
+            <a:r>
+              <a:t>EvalMesh pays for itself instantly via semantic prompt caching &amp; cost routing.</a:t>
             </a:r>
           </a:p>
         </p:txBody>
@@ -6234,7 +6178,7 @@
     <p:bg>
       <p:bgPr>
         <a:solidFill>
-          <a:srgbClr val="06080E"/>
+          <a:srgbClr val="0B0F19"/>
         </a:solidFill>
         <a:effectLst/>
       </p:bgPr>
@@ -6255,7 +6199,7 @@
         <p:spPr>
           <a:xfrm>
             <a:off x="731520" y="365760"/>
-            <a:ext cx="9144000" cy="365760"/>
+            <a:ext cx="9144000" cy="320040"/>
           </a:xfrm>
           <a:prstGeom prst="rect">
             <a:avLst/>
@@ -6271,12 +6215,12 @@
             <a:pPr>
               <a:defRPr sz="1000" b="1">
                 <a:solidFill>
-                  <a:srgbClr val="06B6D4"/>
-                </a:solidFill>
-              </a:defRPr>
-            </a:pPr>
-            <a:r>
-              <a:t>EVALMESH INVESTOR DECK</a:t>
+                  <a:srgbClr val="00F0FF"/>
+                </a:solidFill>
+              </a:defRPr>
+            </a:pPr>
+            <a:r>
+              <a:t>07 / MONETIZATION MODEL</a:t>
             </a:r>
           </a:p>
         </p:txBody>
@@ -6290,7 +6234,7 @@
         <p:spPr>
           <a:xfrm>
             <a:off x="731520" y="640080"/>
-            <a:ext cx="10515600" cy="731520"/>
+            <a:ext cx="10698480" cy="685800"/>
           </a:xfrm>
           <a:prstGeom prst="rect">
             <a:avLst/>
@@ -6306,12 +6250,12 @@
             <a:pPr>
               <a:defRPr sz="2600" b="1">
                 <a:solidFill>
-                  <a:srgbClr val="F8FAFC"/>
-                </a:solidFill>
-              </a:defRPr>
-            </a:pPr>
-            <a:r>
-              <a:t>Competitive Moat: Why EvalMesh Wins</a:t>
+                  <a:srgbClr val="F9FAFB"/>
+                </a:solidFill>
+              </a:defRPr>
+            </a:pPr>
+            <a:r>
+              <a:t>Business Model &amp; Tiered Monetization</a:t>
             </a:r>
           </a:p>
         </p:txBody>
@@ -6325,17 +6269,17 @@
         <p:spPr>
           <a:xfrm>
             <a:off x="731520" y="1645920"/>
-            <a:ext cx="5120640" cy="1920240"/>
+            <a:ext cx="2514600" cy="4389120"/>
           </a:xfrm>
           <a:prstGeom prst="roundRect">
             <a:avLst/>
           </a:prstGeom>
           <a:solidFill>
-            <a:srgbClr val="0D1322"/>
+            <a:srgbClr val="111827"/>
           </a:solidFill>
-          <a:ln>
+          <a:ln w="25400">
             <a:solidFill>
-              <a:srgbClr val="10B981"/>
+              <a:srgbClr val="3B82F6"/>
             </a:solidFill>
           </a:ln>
         </p:spPr>
@@ -6369,8 +6313,8 @@
         </p:nvSpPr>
         <p:spPr>
           <a:xfrm>
-            <a:off x="914400" y="1828800"/>
-            <a:ext cx="4754880" cy="1554480"/>
+            <a:off x="868680" y="1828800"/>
+            <a:ext cx="2240280" cy="4023360"/>
           </a:xfrm>
           <a:prstGeom prst="rect">
             <a:avLst/>
@@ -6384,27 +6328,51 @@
           <a:lstStyle/>
           <a:p>
             <a:pPr>
-              <a:defRPr sz="2000" b="1">
-                <a:solidFill>
-                  <a:srgbClr val="10B981"/>
-                </a:solidFill>
-              </a:defRPr>
-            </a:pPr>
-            <a:r>
-              <a:t>⚡ 60-90% Cost Reduction</a:t>
+              <a:defRPr sz="2200" b="1">
+                <a:solidFill>
+                  <a:srgbClr val="3B82F6"/>
+                </a:solidFill>
+              </a:defRPr>
+            </a:pPr>
+            <a:r>
+              <a:t>Starter</a:t>
+            </a:r>
+          </a:p>
+          <a:p>
+            <a:pPr>
+              <a:defRPr sz="2600" b="1">
+                <a:solidFill>
+                  <a:srgbClr val="F9FAFB"/>
+                </a:solidFill>
+              </a:defRPr>
+            </a:pPr>
+            <a:r>
+              <a:t>$0 / mo</a:t>
             </a:r>
           </a:p>
           <a:p>
             <a:br/>
             <a:pPr>
-              <a:defRPr sz="1400">
-                <a:solidFill>
-                  <a:srgbClr val="94A3B8"/>
-                </a:solidFill>
-              </a:defRPr>
-            </a:pPr>
-            <a:r>
-              <a:t>Semantic caching + prompt complexity classifier slashes API costs instantly.</a:t>
+              <a:defRPr sz="1300">
+                <a:solidFill>
+                  <a:srgbClr val="9CA3AF"/>
+                </a:solidFill>
+              </a:defRPr>
+            </a:pPr>
+            <a:r>
+              <a:t>100k req/mo</a:t>
+            </a:r>
+            <a:br/>
+            <a:r>
+              <a:t>PII Redactor</a:t>
+            </a:r>
+            <a:br/>
+            <a:r>
+              <a:t>Prompt WAF</a:t>
+            </a:r>
+            <a:br/>
+            <a:r>
+              <a:t>Web Dashboard</a:t>
             </a:r>
           </a:p>
         </p:txBody>
@@ -6417,16 +6385,16 @@
         </p:nvSpPr>
         <p:spPr>
           <a:xfrm>
-            <a:off x="6126480" y="1645920"/>
-            <a:ext cx="5120640" cy="1920240"/>
+            <a:off x="3429000" y="1645920"/>
+            <a:ext cx="2514600" cy="4389120"/>
           </a:xfrm>
           <a:prstGeom prst="roundRect">
             <a:avLst/>
           </a:prstGeom>
           <a:solidFill>
-            <a:srgbClr val="0D1322"/>
+            <a:srgbClr val="111827"/>
           </a:solidFill>
-          <a:ln>
+          <a:ln w="25400">
             <a:solidFill>
               <a:srgbClr val="10B981"/>
             </a:solidFill>
@@ -6462,8 +6430,8 @@
         </p:nvSpPr>
         <p:spPr>
           <a:xfrm>
-            <a:off x="6309360" y="1828800"/>
-            <a:ext cx="4754880" cy="1554480"/>
+            <a:off x="3566160" y="1828800"/>
+            <a:ext cx="2240280" cy="4023360"/>
           </a:xfrm>
           <a:prstGeom prst="rect">
             <a:avLst/>
@@ -6477,27 +6445,51 @@
           <a:lstStyle/>
           <a:p>
             <a:pPr>
-              <a:defRPr sz="2000" b="1">
+              <a:defRPr sz="2200" b="1">
                 <a:solidFill>
                   <a:srgbClr val="10B981"/>
                 </a:solidFill>
               </a:defRPr>
             </a:pPr>
             <a:r>
-              <a:t>🛡️ Zero-Trust Security</a:t>
+              <a:t>Pro</a:t>
+            </a:r>
+          </a:p>
+          <a:p>
+            <a:pPr>
+              <a:defRPr sz="2600" b="1">
+                <a:solidFill>
+                  <a:srgbClr val="F9FAFB"/>
+                </a:solidFill>
+              </a:defRPr>
+            </a:pPr>
+            <a:r>
+              <a:t>$49 / mo</a:t>
             </a:r>
           </a:p>
           <a:p>
             <a:br/>
             <a:pPr>
-              <a:defRPr sz="1400">
-                <a:solidFill>
-                  <a:srgbClr val="94A3B8"/>
-                </a:solidFill>
-              </a:defRPr>
-            </a:pPr>
-            <a:r>
-              <a:t>Inline WAF &amp; PII redactor protects customer privacy before egress.</a:t>
+              <a:defRPr sz="1300">
+                <a:solidFill>
+                  <a:srgbClr val="9CA3AF"/>
+                </a:solidFill>
+              </a:defRPr>
+            </a:pPr>
+            <a:r>
+              <a:t>1M req/mo</a:t>
+            </a:r>
+            <a:br/>
+            <a:r>
+              <a:t>Semantic Cache</a:t>
+            </a:r>
+            <a:br/>
+            <a:r>
+              <a:t>Smart Cost Router</a:t>
+            </a:r>
+            <a:br/>
+            <a:r>
+              <a:t>Auto-Healing</a:t>
             </a:r>
           </a:p>
         </p:txBody>
@@ -6510,18 +6502,18 @@
         </p:nvSpPr>
         <p:spPr>
           <a:xfrm>
-            <a:off x="731520" y="3931920"/>
-            <a:ext cx="5120640" cy="1920240"/>
+            <a:off x="6126480" y="1645920"/>
+            <a:ext cx="2514600" cy="4389120"/>
           </a:xfrm>
           <a:prstGeom prst="roundRect">
             <a:avLst/>
           </a:prstGeom>
           <a:solidFill>
-            <a:srgbClr val="0D1322"/>
+            <a:srgbClr val="111827"/>
           </a:solidFill>
-          <a:ln>
+          <a:ln w="25400">
             <a:solidFill>
-              <a:srgbClr val="10B981"/>
+              <a:srgbClr val="8B5CF6"/>
             </a:solidFill>
           </a:ln>
         </p:spPr>
@@ -6555,8 +6547,8 @@
         </p:nvSpPr>
         <p:spPr>
           <a:xfrm>
-            <a:off x="914400" y="4114800"/>
-            <a:ext cx="4754880" cy="1554480"/>
+            <a:off x="6263640" y="1828800"/>
+            <a:ext cx="2240280" cy="4023360"/>
           </a:xfrm>
           <a:prstGeom prst="rect">
             <a:avLst/>
@@ -6570,27 +6562,51 @@
           <a:lstStyle/>
           <a:p>
             <a:pPr>
-              <a:defRPr sz="2000" b="1">
-                <a:solidFill>
-                  <a:srgbClr val="10B981"/>
-                </a:solidFill>
-              </a:defRPr>
-            </a:pPr>
-            <a:r>
-              <a:t>⏱️ Sub-15ms Latency SLA</a:t>
+              <a:defRPr sz="2200" b="1">
+                <a:solidFill>
+                  <a:srgbClr val="8B5CF6"/>
+                </a:solidFill>
+              </a:defRPr>
+            </a:pPr>
+            <a:r>
+              <a:t>Team</a:t>
+            </a:r>
+          </a:p>
+          <a:p>
+            <a:pPr>
+              <a:defRPr sz="2600" b="1">
+                <a:solidFill>
+                  <a:srgbClr val="F9FAFB"/>
+                </a:solidFill>
+              </a:defRPr>
+            </a:pPr>
+            <a:r>
+              <a:t>$299 / mo</a:t>
             </a:r>
           </a:p>
           <a:p>
             <a:br/>
             <a:pPr>
-              <a:defRPr sz="1400">
-                <a:solidFill>
-                  <a:srgbClr val="94A3B8"/>
-                </a:solidFill>
-              </a:defRPr>
-            </a:pPr>
-            <a:r>
-              <a:t>Ultra-fast proxy sidecar built for production high-concurrency workloads.</a:t>
+              <a:defRPr sz="1300">
+                <a:solidFill>
+                  <a:srgbClr val="9CA3AF"/>
+                </a:solidFill>
+              </a:defRPr>
+            </a:pPr>
+            <a:r>
+              <a:t>10M req/mo</a:t>
+            </a:r>
+            <a:br/>
+            <a:r>
+              <a:t>OTel Exporter</a:t>
+            </a:r>
+            <a:br/>
+            <a:r>
+              <a:t>Multi-Model Router</a:t>
+            </a:r>
+            <a:br/>
+            <a:r>
+              <a:t>Priority Support</a:t>
             </a:r>
           </a:p>
         </p:txBody>
@@ -6603,18 +6619,18 @@
         </p:nvSpPr>
         <p:spPr>
           <a:xfrm>
-            <a:off x="6126480" y="3931920"/>
-            <a:ext cx="5120640" cy="1920240"/>
+            <a:off x="8823960" y="1645920"/>
+            <a:ext cx="2514600" cy="4389120"/>
           </a:xfrm>
           <a:prstGeom prst="roundRect">
             <a:avLst/>
           </a:prstGeom>
           <a:solidFill>
-            <a:srgbClr val="0D1322"/>
+            <a:srgbClr val="111827"/>
           </a:solidFill>
-          <a:ln>
+          <a:ln w="25400">
             <a:solidFill>
-              <a:srgbClr val="10B981"/>
+              <a:srgbClr val="00F0FF"/>
             </a:solidFill>
           </a:ln>
         </p:spPr>
@@ -6648,8 +6664,8 @@
         </p:nvSpPr>
         <p:spPr>
           <a:xfrm>
-            <a:off x="6309360" y="4114800"/>
-            <a:ext cx="4754880" cy="1554480"/>
+            <a:off x="8961120" y="1828800"/>
+            <a:ext cx="2240280" cy="4023360"/>
           </a:xfrm>
           <a:prstGeom prst="rect">
             <a:avLst/>
@@ -6663,27 +6679,51 @@
           <a:lstStyle/>
           <a:p>
             <a:pPr>
-              <a:defRPr sz="2000" b="1">
-                <a:solidFill>
-                  <a:srgbClr val="10B981"/>
-                </a:solidFill>
-              </a:defRPr>
-            </a:pPr>
-            <a:r>
-              <a:t>🎬 3-Minute Live Demo</a:t>
+              <a:defRPr sz="2200" b="1">
+                <a:solidFill>
+                  <a:srgbClr val="00F0FF"/>
+                </a:solidFill>
+              </a:defRPr>
+            </a:pPr>
+            <a:r>
+              <a:t>Enterprise</a:t>
+            </a:r>
+          </a:p>
+          <a:p>
+            <a:pPr>
+              <a:defRPr sz="2600" b="1">
+                <a:solidFill>
+                  <a:srgbClr val="F9FAFB"/>
+                </a:solidFill>
+              </a:defRPr>
+            </a:pPr>
+            <a:r>
+              <a:t>Custom</a:t>
             </a:r>
           </a:p>
           <a:p>
             <a:br/>
             <a:pPr>
-              <a:defRPr sz="1400">
-                <a:solidFill>
-                  <a:srgbClr val="94A3B8"/>
-                </a:solidFill>
-              </a:defRPr>
-            </a:pPr>
-            <a:r>
-              <a:t>Proves real-time WAF blocks, loop termination, and auto-healing live.</a:t>
+              <a:defRPr sz="1300">
+                <a:solidFill>
+                  <a:srgbClr val="9CA3AF"/>
+                </a:solidFill>
+              </a:defRPr>
+            </a:pPr>
+            <a:r>
+              <a:t>Unlimited req</a:t>
+            </a:r>
+            <a:br/>
+            <a:r>
+              <a:t>Dedicated VPC</a:t>
+            </a:r>
+            <a:br/>
+            <a:r>
+              <a:t>SLA Guarantee</a:t>
+            </a:r>
+            <a:br/>
+            <a:r>
+              <a:t>24/7 Support</a:t>
             </a:r>
           </a:p>
         </p:txBody>
@@ -6702,7 +6742,7 @@
     <p:bg>
       <p:bgPr>
         <a:solidFill>
-          <a:srgbClr val="06080E"/>
+          <a:srgbClr val="0B0F19"/>
         </a:solidFill>
         <a:effectLst/>
       </p:bgPr>
@@ -6723,7 +6763,7 @@
         <p:spPr>
           <a:xfrm>
             <a:off x="731520" y="365760"/>
-            <a:ext cx="9144000" cy="365760"/>
+            <a:ext cx="9144000" cy="320040"/>
           </a:xfrm>
           <a:prstGeom prst="rect">
             <a:avLst/>
@@ -6739,12 +6779,12 @@
             <a:pPr>
               <a:defRPr sz="1000" b="1">
                 <a:solidFill>
-                  <a:srgbClr val="06B6D4"/>
-                </a:solidFill>
-              </a:defRPr>
-            </a:pPr>
-            <a:r>
-              <a:t>EVALMESH INVESTOR DECK</a:t>
+                  <a:srgbClr val="00F0FF"/>
+                </a:solidFill>
+              </a:defRPr>
+            </a:pPr>
+            <a:r>
+              <a:t>08 / TRACTION &amp; VERIFICATION</a:t>
             </a:r>
           </a:p>
         </p:txBody>
@@ -6758,7 +6798,7 @@
         <p:spPr>
           <a:xfrm>
             <a:off x="731520" y="640080"/>
-            <a:ext cx="10515600" cy="731520"/>
+            <a:ext cx="10698480" cy="685800"/>
           </a:xfrm>
           <a:prstGeom prst="rect">
             <a:avLst/>
@@ -6774,12 +6814,12 @@
             <a:pPr>
               <a:defRPr sz="2600" b="1">
                 <a:solidFill>
-                  <a:srgbClr val="F8FAFC"/>
-                </a:solidFill>
-              </a:defRPr>
-            </a:pPr>
-            <a:r>
-              <a:t>100% Operational &amp; Verified Codebase</a:t>
+                  <a:srgbClr val="F9FAFB"/>
+                </a:solidFill>
+              </a:defRPr>
+            </a:pPr>
+            <a:r>
+              <a:t>Production Readiness: 100% Operational Codebase</a:t>
             </a:r>
           </a:p>
         </p:txBody>
@@ -6799,11 +6839,11 @@
             <a:avLst/>
           </a:prstGeom>
           <a:solidFill>
-            <a:srgbClr val="0D1322"/>
+            <a:srgbClr val="111827"/>
           </a:solidFill>
           <a:ln>
             <a:solidFill>
-              <a:srgbClr val="3B82F6"/>
+              <a:srgbClr val="10B981"/>
             </a:solidFill>
           </a:ln>
         </p:spPr>
@@ -6867,7 +6907,7 @@
             <a:pPr>
               <a:defRPr sz="1500">
                 <a:solidFill>
-                  <a:srgbClr val="F8FAFC"/>
+                  <a:srgbClr val="F9FAFB"/>
                 </a:solidFill>
               </a:defRPr>
             </a:pPr>

</xml_diff>

<commit_message>
Upgrade PowerPoint presentation to Pro Tier with footer branding and custom card layouts
</commit_message>
<xml_diff>
--- a/EvalMesh_Investor_Pitch_Deck.pptx
+++ b/EvalMesh_Investor_Pitch_Deck.pptx
@@ -3093,7 +3093,7 @@
     <p:bg>
       <p:bgPr>
         <a:solidFill>
-          <a:srgbClr val="0B0F19"/>
+          <a:srgbClr val="080C16"/>
         </a:solidFill>
         <a:effectLst/>
       </p:bgPr>
@@ -3113,14 +3113,14 @@
         </p:nvSpPr>
         <p:spPr>
           <a:xfrm>
-            <a:off x="1097280" y="1097280"/>
-            <a:ext cx="9994392" cy="4663440"/>
+            <a:off x="914400" y="914400"/>
+            <a:ext cx="10360152" cy="5029200"/>
           </a:xfrm>
           <a:prstGeom prst="roundRect">
             <a:avLst/>
           </a:prstGeom>
           <a:solidFill>
-            <a:srgbClr val="111827"/>
+            <a:srgbClr val="0F172A"/>
           </a:solidFill>
           <a:ln w="25400">
             <a:solidFill>
@@ -3158,8 +3158,8 @@
         </p:nvSpPr>
         <p:spPr>
           <a:xfrm>
-            <a:off x="1645920" y="1645920"/>
-            <a:ext cx="8869680" cy="3566160"/>
+            <a:off x="1371600" y="1371600"/>
+            <a:ext cx="9445752" cy="4114800"/>
           </a:xfrm>
           <a:prstGeom prst="rect">
             <a:avLst/>
@@ -3175,24 +3175,24 @@
             <a:pPr>
               <a:defRPr sz="1100" b="1">
                 <a:solidFill>
-                  <a:srgbClr val="00F0FF"/>
-                </a:solidFill>
-              </a:defRPr>
-            </a:pPr>
-            <a:r>
-              <a:t>SERIES SEED PITCH DECK</a:t>
-            </a:r>
-          </a:p>
-          <a:p>
-            <a:pPr>
-              <a:defRPr sz="5200" b="1">
-                <a:solidFill>
-                  <a:srgbClr val="F9FAFB"/>
-                </a:solidFill>
-              </a:defRPr>
-            </a:pPr>
-            <a:r>
-              <a:t>EvalMesh</a:t>
+                  <a:srgbClr val="06B6D4"/>
+                </a:solidFill>
+              </a:defRPr>
+            </a:pPr>
+            <a:r>
+              <a:t>SERIES SEED PITCH DECK  •  2026 EDITION</a:t>
+            </a:r>
+          </a:p>
+          <a:p>
+            <a:pPr>
+              <a:defRPr sz="5400" b="1">
+                <a:solidFill>
+                  <a:srgbClr val="F8FAFC"/>
+                </a:solidFill>
+              </a:defRPr>
+            </a:pPr>
+            <a:r>
+              <a:t>🛡️ EvalMesh</a:t>
             </a:r>
           </a:p>
           <a:p>
@@ -3212,12 +3212,25 @@
             <a:pPr>
               <a:defRPr sz="1600">
                 <a:solidFill>
-                  <a:srgbClr val="9CA3AF"/>
+                  <a:srgbClr val="94A3B8"/>
                 </a:solidFill>
               </a:defRPr>
             </a:pPr>
             <a:r>
               <a:t>Cloudflare + GitHub Actions for Autonomous AI Agents</a:t>
+            </a:r>
+          </a:p>
+          <a:p>
+            <a:br/>
+            <a:pPr>
+              <a:defRPr sz="1200">
+                <a:solidFill>
+                  <a:srgbClr val="06B6D4"/>
+                </a:solidFill>
+              </a:defRPr>
+            </a:pPr>
+            <a:r>
+              <a:t>Website: http://localhost:8000   │   GitHub: github.com/deswanth12/EvalMesh</a:t>
             </a:r>
           </a:p>
         </p:txBody>
@@ -3236,7 +3249,7 @@
     <p:bg>
       <p:bgPr>
         <a:solidFill>
-          <a:srgbClr val="0B0F19"/>
+          <a:srgbClr val="080C16"/>
         </a:solidFill>
         <a:effectLst/>
       </p:bgPr>
@@ -3250,24 +3263,129 @@
       <p:grpSpPr/>
       <p:sp>
         <p:nvSpPr>
-          <p:cNvPr id="2" name="Rounded Rectangle 1"/>
+          <p:cNvPr id="2" name="TextBox 1"/>
+          <p:cNvSpPr txBox="1"/>
+          <p:nvPr/>
+        </p:nvSpPr>
+        <p:spPr>
+          <a:xfrm>
+            <a:off x="731520" y="365760"/>
+            <a:ext cx="9144000" cy="320040"/>
+          </a:xfrm>
+          <a:prstGeom prst="rect">
+            <a:avLst/>
+          </a:prstGeom>
+          <a:noFill/>
+        </p:spPr>
+        <p:txBody>
+          <a:bodyPr wrap="square">
+            <a:spAutoFit/>
+          </a:bodyPr>
+          <a:lstStyle/>
+          <a:p>
+            <a:pPr>
+              <a:defRPr sz="1000" b="1">
+                <a:solidFill>
+                  <a:srgbClr val="06B6D4"/>
+                </a:solidFill>
+              </a:defRPr>
+            </a:pPr>
+            <a:r>
+              <a:t>10 / VISION &amp; CALL TO ACTION</a:t>
+            </a:r>
+          </a:p>
+        </p:txBody>
+      </p:sp>
+      <p:sp>
+        <p:nvSpPr>
+          <p:cNvPr id="3" name="TextBox 2"/>
+          <p:cNvSpPr txBox="1"/>
+          <p:nvPr/>
+        </p:nvSpPr>
+        <p:spPr>
+          <a:xfrm>
+            <a:off x="731520" y="640080"/>
+            <a:ext cx="10698480" cy="685800"/>
+          </a:xfrm>
+          <a:prstGeom prst="rect">
+            <a:avLst/>
+          </a:prstGeom>
+          <a:noFill/>
+        </p:spPr>
+        <p:txBody>
+          <a:bodyPr wrap="square">
+            <a:spAutoFit/>
+          </a:bodyPr>
+          <a:lstStyle/>
+          <a:p>
+            <a:pPr>
+              <a:defRPr sz="2600" b="1">
+                <a:solidFill>
+                  <a:srgbClr val="F8FAFC"/>
+                </a:solidFill>
+              </a:defRPr>
+            </a:pPr>
+            <a:r>
+              <a:t>Join the Future of AI Reliability</a:t>
+            </a:r>
+          </a:p>
+        </p:txBody>
+      </p:sp>
+      <p:sp>
+        <p:nvSpPr>
+          <p:cNvPr id="4" name="TextBox 3"/>
+          <p:cNvSpPr txBox="1"/>
+          <p:nvPr/>
+        </p:nvSpPr>
+        <p:spPr>
+          <a:xfrm>
+            <a:off x="731520" y="6400800"/>
+            <a:ext cx="10725912" cy="320040"/>
+          </a:xfrm>
+          <a:prstGeom prst="rect">
+            <a:avLst/>
+          </a:prstGeom>
+          <a:noFill/>
+        </p:spPr>
+        <p:txBody>
+          <a:bodyPr wrap="none">
+            <a:spAutoFit/>
+          </a:bodyPr>
+          <a:lstStyle/>
+          <a:p>
+            <a:pPr>
+              <a:defRPr sz="900">
+                <a:solidFill>
+                  <a:srgbClr val="94A3B8"/>
+                </a:solidFill>
+              </a:defRPr>
+            </a:pPr>
+            <a:r>
+              <a:t>EvalMesh | AI Gateway for Secure &amp; Reliable Agent Deployment   •   Slide 10 of 10</a:t>
+            </a:r>
+          </a:p>
+        </p:txBody>
+      </p:sp>
+      <p:sp>
+        <p:nvSpPr>
+          <p:cNvPr id="5" name="Rounded Rectangle 4"/>
           <p:cNvSpPr/>
           <p:nvPr/>
         </p:nvSpPr>
         <p:spPr>
           <a:xfrm>
-            <a:off x="1097280" y="1097280"/>
-            <a:ext cx="9994392" cy="4663440"/>
+            <a:off x="914400" y="1554480"/>
+            <a:ext cx="10360152" cy="4572000"/>
           </a:xfrm>
           <a:prstGeom prst="roundRect">
             <a:avLst/>
           </a:prstGeom>
           <a:solidFill>
-            <a:srgbClr val="111827"/>
+            <a:srgbClr val="0F172A"/>
           </a:solidFill>
           <a:ln w="25400">
             <a:solidFill>
-              <a:srgbClr val="00F0FF"/>
+              <a:srgbClr val="06B6D4"/>
             </a:solidFill>
           </a:ln>
         </p:spPr>
@@ -3295,14 +3413,14 @@
       </p:sp>
       <p:sp>
         <p:nvSpPr>
-          <p:cNvPr id="3" name="TextBox 2"/>
+          <p:cNvPr id="6" name="TextBox 5"/>
           <p:cNvSpPr txBox="1"/>
           <p:nvPr/>
         </p:nvSpPr>
         <p:spPr>
           <a:xfrm>
-            <a:off x="1645920" y="1645920"/>
-            <a:ext cx="8869680" cy="3566160"/>
+            <a:off x="1371600" y="1920240"/>
+            <a:ext cx="9445752" cy="3840480"/>
           </a:xfrm>
           <a:prstGeom prst="rect">
             <a:avLst/>
@@ -3316,21 +3434,21 @@
           <a:lstStyle/>
           <a:p>
             <a:pPr>
-              <a:defRPr sz="4200" b="1">
-                <a:solidFill>
-                  <a:srgbClr val="F9FAFB"/>
-                </a:solidFill>
-              </a:defRPr>
-            </a:pPr>
-            <a:r>
-              <a:t>Join the Future of AI Reliability</a:t>
+              <a:defRPr sz="4000" b="1">
+                <a:solidFill>
+                  <a:srgbClr val="F8FAFC"/>
+                </a:solidFill>
+              </a:defRPr>
+            </a:pPr>
+            <a:r>
+              <a:t>Deploy AI Agents with Zero Friction</a:t>
             </a:r>
           </a:p>
           <a:p>
             <a:pPr>
               <a:defRPr sz="2200" b="1">
                 <a:solidFill>
-                  <a:srgbClr val="00F0FF"/>
+                  <a:srgbClr val="06B6D4"/>
                 </a:solidFill>
               </a:defRPr>
             </a:pPr>
@@ -3343,7 +3461,7 @@
             <a:pPr>
               <a:defRPr sz="1600">
                 <a:solidFill>
-                  <a:srgbClr val="9CA3AF"/>
+                  <a:srgbClr val="94A3B8"/>
                 </a:solidFill>
               </a:defRPr>
             </a:pPr>
@@ -3375,7 +3493,7 @@
     <p:bg>
       <p:bgPr>
         <a:solidFill>
-          <a:srgbClr val="0B0F19"/>
+          <a:srgbClr val="080C16"/>
         </a:solidFill>
         <a:effectLst/>
       </p:bgPr>
@@ -3412,7 +3530,7 @@
             <a:pPr>
               <a:defRPr sz="1000" b="1">
                 <a:solidFill>
-                  <a:srgbClr val="00F0FF"/>
+                  <a:srgbClr val="06B6D4"/>
                 </a:solidFill>
               </a:defRPr>
             </a:pPr>
@@ -3447,32 +3565,67 @@
             <a:pPr>
               <a:defRPr sz="2600" b="1">
                 <a:solidFill>
-                  <a:srgbClr val="F9FAFB"/>
-                </a:solidFill>
-              </a:defRPr>
-            </a:pPr>
-            <a:r>
-              <a:t>The Problem: Autonomous Agents Break in Production</a:t>
-            </a:r>
-          </a:p>
-        </p:txBody>
-      </p:sp>
-      <p:sp>
-        <p:nvSpPr>
-          <p:cNvPr id="4" name="Rounded Rectangle 3"/>
+                  <a:srgbClr val="F8FAFC"/>
+                </a:solidFill>
+              </a:defRPr>
+            </a:pPr>
+            <a:r>
+              <a:t>The Problem: Autonomous AI Agents Break in Production</a:t>
+            </a:r>
+          </a:p>
+        </p:txBody>
+      </p:sp>
+      <p:sp>
+        <p:nvSpPr>
+          <p:cNvPr id="4" name="TextBox 3"/>
+          <p:cNvSpPr txBox="1"/>
+          <p:nvPr/>
+        </p:nvSpPr>
+        <p:spPr>
+          <a:xfrm>
+            <a:off x="731520" y="6400800"/>
+            <a:ext cx="10725912" cy="320040"/>
+          </a:xfrm>
+          <a:prstGeom prst="rect">
+            <a:avLst/>
+          </a:prstGeom>
+          <a:noFill/>
+        </p:spPr>
+        <p:txBody>
+          <a:bodyPr wrap="none">
+            <a:spAutoFit/>
+          </a:bodyPr>
+          <a:lstStyle/>
+          <a:p>
+            <a:pPr>
+              <a:defRPr sz="900">
+                <a:solidFill>
+                  <a:srgbClr val="94A3B8"/>
+                </a:solidFill>
+              </a:defRPr>
+            </a:pPr>
+            <a:r>
+              <a:t>EvalMesh | AI Gateway for Secure &amp; Reliable Agent Deployment   •   Slide 2 of 10</a:t>
+            </a:r>
+          </a:p>
+        </p:txBody>
+      </p:sp>
+      <p:sp>
+        <p:nvSpPr>
+          <p:cNvPr id="5" name="Rounded Rectangle 4"/>
           <p:cNvSpPr/>
           <p:nvPr/>
         </p:nvSpPr>
         <p:spPr>
           <a:xfrm>
-            <a:off x="731520" y="1645920"/>
-            <a:ext cx="3291840" cy="4389120"/>
+            <a:off x="731520" y="1554480"/>
+            <a:ext cx="3319272" cy="4572000"/>
           </a:xfrm>
           <a:prstGeom prst="roundRect">
             <a:avLst/>
           </a:prstGeom>
           <a:solidFill>
-            <a:srgbClr val="111827"/>
+            <a:srgbClr val="0F172A"/>
           </a:solidFill>
           <a:ln w="19050">
             <a:solidFill>
@@ -3504,14 +3657,14 @@
       </p:sp>
       <p:sp>
         <p:nvSpPr>
-          <p:cNvPr id="5" name="TextBox 4"/>
+          <p:cNvPr id="6" name="TextBox 5"/>
           <p:cNvSpPr txBox="1"/>
           <p:nvPr/>
         </p:nvSpPr>
         <p:spPr>
           <a:xfrm>
-            <a:off x="914400" y="1920240"/>
-            <a:ext cx="2926080" cy="3840480"/>
+            <a:off x="914400" y="1828800"/>
+            <a:ext cx="2953512" cy="4023360"/>
           </a:xfrm>
           <a:prstGeom prst="rect">
             <a:avLst/>
@@ -3532,7 +3685,7 @@
               </a:defRPr>
             </a:pPr>
             <a:r>
-              <a:t>💸 Runaway API Billing Spikes</a:t>
+              <a:t>💸 Runaway Billing Spikes</a:t>
             </a:r>
           </a:p>
           <a:p>
@@ -3540,7 +3693,7 @@
             <a:pPr>
               <a:defRPr sz="1500" b="1">
                 <a:solidFill>
-                  <a:srgbClr val="F9FAFB"/>
+                  <a:srgbClr val="F8FAFC"/>
                 </a:solidFill>
               </a:defRPr>
             </a:pPr>
@@ -3553,32 +3706,32 @@
             <a:pPr>
               <a:defRPr sz="1300">
                 <a:solidFill>
-                  <a:srgbClr val="9CA3AF"/>
-                </a:solidFill>
-              </a:defRPr>
-            </a:pPr>
-            <a:r>
-              <a:t>Recursive agent loops execute 500+ calls overnight without safety limits.</a:t>
-            </a:r>
-          </a:p>
-        </p:txBody>
-      </p:sp>
-      <p:sp>
-        <p:nvSpPr>
-          <p:cNvPr id="6" name="Rounded Rectangle 5"/>
+                  <a:srgbClr val="94A3B8"/>
+                </a:solidFill>
+              </a:defRPr>
+            </a:pPr>
+            <a:r>
+              <a:t>Recursive agent loops execute 500+ calls overnight without safety thresholds.</a:t>
+            </a:r>
+          </a:p>
+        </p:txBody>
+      </p:sp>
+      <p:sp>
+        <p:nvSpPr>
+          <p:cNvPr id="7" name="Rounded Rectangle 6"/>
           <p:cNvSpPr/>
           <p:nvPr/>
         </p:nvSpPr>
         <p:spPr>
           <a:xfrm>
-            <a:off x="4297680" y="1645920"/>
-            <a:ext cx="3291840" cy="4389120"/>
+            <a:off x="4297680" y="1554480"/>
+            <a:ext cx="3319272" cy="4572000"/>
           </a:xfrm>
           <a:prstGeom prst="roundRect">
             <a:avLst/>
           </a:prstGeom>
           <a:solidFill>
-            <a:srgbClr val="111827"/>
+            <a:srgbClr val="0F172A"/>
           </a:solidFill>
           <a:ln w="19050">
             <a:solidFill>
@@ -3610,14 +3763,14 @@
       </p:sp>
       <p:sp>
         <p:nvSpPr>
-          <p:cNvPr id="7" name="TextBox 6"/>
+          <p:cNvPr id="8" name="TextBox 7"/>
           <p:cNvSpPr txBox="1"/>
           <p:nvPr/>
         </p:nvSpPr>
         <p:spPr>
           <a:xfrm>
-            <a:off x="4480560" y="1920240"/>
-            <a:ext cx="2926080" cy="3840480"/>
+            <a:off x="4480560" y="1828800"/>
+            <a:ext cx="2953512" cy="4023360"/>
           </a:xfrm>
           <a:prstGeom prst="rect">
             <a:avLst/>
@@ -3638,7 +3791,7 @@
               </a:defRPr>
             </a:pPr>
             <a:r>
-              <a:t>🔓 Security &amp; PII Data Leaks</a:t>
+              <a:t>🔓 Security &amp; PII Leaks</a:t>
             </a:r>
           </a:p>
           <a:p>
@@ -3646,7 +3799,7 @@
             <a:pPr>
               <a:defRPr sz="1500" b="1">
                 <a:solidFill>
-                  <a:srgbClr val="F9FAFB"/>
+                  <a:srgbClr val="F8FAFC"/>
                 </a:solidFill>
               </a:defRPr>
             </a:pPr>
@@ -3659,7 +3812,7 @@
             <a:pPr>
               <a:defRPr sz="1300">
                 <a:solidFill>
-                  <a:srgbClr val="9CA3AF"/>
+                  <a:srgbClr val="94A3B8"/>
                 </a:solidFill>
               </a:defRPr>
             </a:pPr>
@@ -3671,20 +3824,20 @@
       </p:sp>
       <p:sp>
         <p:nvSpPr>
-          <p:cNvPr id="8" name="Rounded Rectangle 7"/>
+          <p:cNvPr id="9" name="Rounded Rectangle 8"/>
           <p:cNvSpPr/>
           <p:nvPr/>
         </p:nvSpPr>
         <p:spPr>
           <a:xfrm>
-            <a:off x="7863840" y="1645920"/>
-            <a:ext cx="3291840" cy="4389120"/>
+            <a:off x="7863840" y="1554480"/>
+            <a:ext cx="3319272" cy="4572000"/>
           </a:xfrm>
           <a:prstGeom prst="roundRect">
             <a:avLst/>
           </a:prstGeom>
           <a:solidFill>
-            <a:srgbClr val="111827"/>
+            <a:srgbClr val="0F172A"/>
           </a:solidFill>
           <a:ln w="19050">
             <a:solidFill>
@@ -3716,14 +3869,14 @@
       </p:sp>
       <p:sp>
         <p:nvSpPr>
-          <p:cNvPr id="9" name="TextBox 8"/>
+          <p:cNvPr id="10" name="TextBox 9"/>
           <p:cNvSpPr txBox="1"/>
           <p:nvPr/>
         </p:nvSpPr>
         <p:spPr>
           <a:xfrm>
-            <a:off x="8046720" y="1920240"/>
-            <a:ext cx="2926080" cy="3840480"/>
+            <a:off x="8046720" y="1828800"/>
+            <a:ext cx="2953512" cy="4023360"/>
           </a:xfrm>
           <a:prstGeom prst="rect">
             <a:avLst/>
@@ -3744,7 +3897,7 @@
               </a:defRPr>
             </a:pPr>
             <a:r>
-              <a:t>💥 Silent Model Output Drift</a:t>
+              <a:t>💥 Silent Output Drift</a:t>
             </a:r>
           </a:p>
           <a:p>
@@ -3752,7 +3905,7 @@
             <a:pPr>
               <a:defRPr sz="1500" b="1">
                 <a:solidFill>
-                  <a:srgbClr val="F9FAFB"/>
+                  <a:srgbClr val="F8FAFC"/>
                 </a:solidFill>
               </a:defRPr>
             </a:pPr>
@@ -3765,7 +3918,7 @@
             <a:pPr>
               <a:defRPr sz="1300">
                 <a:solidFill>
-                  <a:srgbClr val="9CA3AF"/>
+                  <a:srgbClr val="94A3B8"/>
                 </a:solidFill>
               </a:defRPr>
             </a:pPr>
@@ -3789,7 +3942,7 @@
     <p:bg>
       <p:bgPr>
         <a:solidFill>
-          <a:srgbClr val="0B0F19"/>
+          <a:srgbClr val="080C16"/>
         </a:solidFill>
         <a:effectLst/>
       </p:bgPr>
@@ -3826,7 +3979,7 @@
             <a:pPr>
               <a:defRPr sz="1000" b="1">
                 <a:solidFill>
-                  <a:srgbClr val="00F0FF"/>
+                  <a:srgbClr val="06B6D4"/>
                 </a:solidFill>
               </a:defRPr>
             </a:pPr>
@@ -3861,7 +4014,7 @@
             <a:pPr>
               <a:defRPr sz="2600" b="1">
                 <a:solidFill>
-                  <a:srgbClr val="F9FAFB"/>
+                  <a:srgbClr val="F8FAFC"/>
                 </a:solidFill>
               </a:defRPr>
             </a:pPr>
@@ -3873,20 +4026,55 @@
       </p:sp>
       <p:sp>
         <p:nvSpPr>
-          <p:cNvPr id="4" name="Rounded Rectangle 3"/>
+          <p:cNvPr id="4" name="TextBox 3"/>
+          <p:cNvSpPr txBox="1"/>
+          <p:nvPr/>
+        </p:nvSpPr>
+        <p:spPr>
+          <a:xfrm>
+            <a:off x="731520" y="6400800"/>
+            <a:ext cx="10725912" cy="320040"/>
+          </a:xfrm>
+          <a:prstGeom prst="rect">
+            <a:avLst/>
+          </a:prstGeom>
+          <a:noFill/>
+        </p:spPr>
+        <p:txBody>
+          <a:bodyPr wrap="none">
+            <a:spAutoFit/>
+          </a:bodyPr>
+          <a:lstStyle/>
+          <a:p>
+            <a:pPr>
+              <a:defRPr sz="900">
+                <a:solidFill>
+                  <a:srgbClr val="94A3B8"/>
+                </a:solidFill>
+              </a:defRPr>
+            </a:pPr>
+            <a:r>
+              <a:t>EvalMesh | AI Gateway for Secure &amp; Reliable Agent Deployment   •   Slide 3 of 10</a:t>
+            </a:r>
+          </a:p>
+        </p:txBody>
+      </p:sp>
+      <p:sp>
+        <p:nvSpPr>
+          <p:cNvPr id="5" name="Rounded Rectangle 4"/>
           <p:cNvSpPr/>
           <p:nvPr/>
         </p:nvSpPr>
         <p:spPr>
           <a:xfrm>
-            <a:off x="731520" y="1645920"/>
-            <a:ext cx="3291840" cy="4389120"/>
+            <a:off x="731520" y="1554480"/>
+            <a:ext cx="3319272" cy="4572000"/>
           </a:xfrm>
           <a:prstGeom prst="roundRect">
             <a:avLst/>
           </a:prstGeom>
           <a:solidFill>
-            <a:srgbClr val="111827"/>
+            <a:srgbClr val="0F172A"/>
           </a:solidFill>
           <a:ln w="19050">
             <a:solidFill>
@@ -3918,14 +4106,14 @@
       </p:sp>
       <p:sp>
         <p:nvSpPr>
-          <p:cNvPr id="5" name="TextBox 4"/>
+          <p:cNvPr id="6" name="TextBox 5"/>
           <p:cNvSpPr txBox="1"/>
           <p:nvPr/>
         </p:nvSpPr>
         <p:spPr>
           <a:xfrm>
-            <a:off x="914400" y="1920240"/>
-            <a:ext cx="2926080" cy="3840480"/>
+            <a:off x="914400" y="1828800"/>
+            <a:ext cx="2953512" cy="4023360"/>
           </a:xfrm>
           <a:prstGeom prst="rect">
             <a:avLst/>
@@ -3954,7 +4142,7 @@
             <a:pPr>
               <a:defRPr sz="1500" b="1">
                 <a:solidFill>
-                  <a:srgbClr val="F9FAFB"/>
+                  <a:srgbClr val="F8FAFC"/>
                 </a:solidFill>
               </a:defRPr>
             </a:pPr>
@@ -3967,7 +4155,7 @@
             <a:pPr>
               <a:defRPr sz="1300">
                 <a:solidFill>
-                  <a:srgbClr val="9CA3AF"/>
+                  <a:srgbClr val="94A3B8"/>
                 </a:solidFill>
               </a:defRPr>
             </a:pPr>
@@ -3979,20 +4167,20 @@
       </p:sp>
       <p:sp>
         <p:nvSpPr>
-          <p:cNvPr id="6" name="Rounded Rectangle 5"/>
+          <p:cNvPr id="7" name="Rounded Rectangle 6"/>
           <p:cNvSpPr/>
           <p:nvPr/>
         </p:nvSpPr>
         <p:spPr>
           <a:xfrm>
-            <a:off x="4297680" y="1645920"/>
-            <a:ext cx="3291840" cy="4389120"/>
+            <a:off x="4297680" y="1554480"/>
+            <a:ext cx="3319272" cy="4572000"/>
           </a:xfrm>
           <a:prstGeom prst="roundRect">
             <a:avLst/>
           </a:prstGeom>
           <a:solidFill>
-            <a:srgbClr val="111827"/>
+            <a:srgbClr val="0F172A"/>
           </a:solidFill>
           <a:ln w="19050">
             <a:solidFill>
@@ -4024,14 +4212,14 @@
       </p:sp>
       <p:sp>
         <p:nvSpPr>
-          <p:cNvPr id="7" name="TextBox 6"/>
+          <p:cNvPr id="8" name="TextBox 7"/>
           <p:cNvSpPr txBox="1"/>
           <p:nvPr/>
         </p:nvSpPr>
         <p:spPr>
           <a:xfrm>
-            <a:off x="4480560" y="1920240"/>
-            <a:ext cx="2926080" cy="3840480"/>
+            <a:off x="4480560" y="1828800"/>
+            <a:ext cx="2953512" cy="4023360"/>
           </a:xfrm>
           <a:prstGeom prst="rect">
             <a:avLst/>
@@ -4060,7 +4248,7 @@
             <a:pPr>
               <a:defRPr sz="1500" b="1">
                 <a:solidFill>
-                  <a:srgbClr val="F9FAFB"/>
+                  <a:srgbClr val="F8FAFC"/>
                 </a:solidFill>
               </a:defRPr>
             </a:pPr>
@@ -4073,7 +4261,7 @@
             <a:pPr>
               <a:defRPr sz="1300">
                 <a:solidFill>
-                  <a:srgbClr val="9CA3AF"/>
+                  <a:srgbClr val="94A3B8"/>
                 </a:solidFill>
               </a:defRPr>
             </a:pPr>
@@ -4085,20 +4273,20 @@
       </p:sp>
       <p:sp>
         <p:nvSpPr>
-          <p:cNvPr id="8" name="Rounded Rectangle 7"/>
+          <p:cNvPr id="9" name="Rounded Rectangle 8"/>
           <p:cNvSpPr/>
           <p:nvPr/>
         </p:nvSpPr>
         <p:spPr>
           <a:xfrm>
-            <a:off x="7863840" y="1645920"/>
-            <a:ext cx="3291840" cy="4389120"/>
+            <a:off x="7863840" y="1554480"/>
+            <a:ext cx="3319272" cy="4572000"/>
           </a:xfrm>
           <a:prstGeom prst="roundRect">
             <a:avLst/>
           </a:prstGeom>
           <a:solidFill>
-            <a:srgbClr val="111827"/>
+            <a:srgbClr val="0F172A"/>
           </a:solidFill>
           <a:ln w="19050">
             <a:solidFill>
@@ -4130,14 +4318,14 @@
       </p:sp>
       <p:sp>
         <p:nvSpPr>
-          <p:cNvPr id="9" name="TextBox 8"/>
+          <p:cNvPr id="10" name="TextBox 9"/>
           <p:cNvSpPr txBox="1"/>
           <p:nvPr/>
         </p:nvSpPr>
         <p:spPr>
           <a:xfrm>
-            <a:off x="8046720" y="1920240"/>
-            <a:ext cx="2926080" cy="3840480"/>
+            <a:off x="8046720" y="1828800"/>
+            <a:ext cx="2953512" cy="4023360"/>
           </a:xfrm>
           <a:prstGeom prst="rect">
             <a:avLst/>
@@ -4166,7 +4354,7 @@
             <a:pPr>
               <a:defRPr sz="1500" b="1">
                 <a:solidFill>
-                  <a:srgbClr val="F9FAFB"/>
+                  <a:srgbClr val="F8FAFC"/>
                 </a:solidFill>
               </a:defRPr>
             </a:pPr>
@@ -4179,7 +4367,7 @@
             <a:pPr>
               <a:defRPr sz="1300">
                 <a:solidFill>
-                  <a:srgbClr val="9CA3AF"/>
+                  <a:srgbClr val="94A3B8"/>
                 </a:solidFill>
               </a:defRPr>
             </a:pPr>
@@ -4203,7 +4391,7 @@
     <p:bg>
       <p:bgPr>
         <a:solidFill>
-          <a:srgbClr val="0B0F19"/>
+          <a:srgbClr val="080C16"/>
         </a:solidFill>
         <a:effectLst/>
       </p:bgPr>
@@ -4240,7 +4428,7 @@
             <a:pPr>
               <a:defRPr sz="1000" b="1">
                 <a:solidFill>
-                  <a:srgbClr val="00F0FF"/>
+                  <a:srgbClr val="06B6D4"/>
                 </a:solidFill>
               </a:defRPr>
             </a:pPr>
@@ -4275,7 +4463,7 @@
             <a:pPr>
               <a:defRPr sz="2600" b="1">
                 <a:solidFill>
-                  <a:srgbClr val="F9FAFB"/>
+                  <a:srgbClr val="F8FAFC"/>
                 </a:solidFill>
               </a:defRPr>
             </a:pPr>
@@ -4287,20 +4475,55 @@
       </p:sp>
       <p:sp>
         <p:nvSpPr>
-          <p:cNvPr id="4" name="Rounded Rectangle 3"/>
+          <p:cNvPr id="4" name="TextBox 3"/>
+          <p:cNvSpPr txBox="1"/>
+          <p:nvPr/>
+        </p:nvSpPr>
+        <p:spPr>
+          <a:xfrm>
+            <a:off x="731520" y="6400800"/>
+            <a:ext cx="10725912" cy="320040"/>
+          </a:xfrm>
+          <a:prstGeom prst="rect">
+            <a:avLst/>
+          </a:prstGeom>
+          <a:noFill/>
+        </p:spPr>
+        <p:txBody>
+          <a:bodyPr wrap="none">
+            <a:spAutoFit/>
+          </a:bodyPr>
+          <a:lstStyle/>
+          <a:p>
+            <a:pPr>
+              <a:defRPr sz="900">
+                <a:solidFill>
+                  <a:srgbClr val="94A3B8"/>
+                </a:solidFill>
+              </a:defRPr>
+            </a:pPr>
+            <a:r>
+              <a:t>EvalMesh | AI Gateway for Secure &amp; Reliable Agent Deployment   •   Slide 4 of 10</a:t>
+            </a:r>
+          </a:p>
+        </p:txBody>
+      </p:sp>
+      <p:sp>
+        <p:nvSpPr>
+          <p:cNvPr id="5" name="Rounded Rectangle 4"/>
           <p:cNvSpPr/>
           <p:nvPr/>
         </p:nvSpPr>
         <p:spPr>
           <a:xfrm>
-            <a:off x="731520" y="1645920"/>
-            <a:ext cx="10725912" cy="4389120"/>
+            <a:off x="731520" y="1554480"/>
+            <a:ext cx="10725912" cy="4572000"/>
           </a:xfrm>
           <a:prstGeom prst="roundRect">
             <a:avLst/>
           </a:prstGeom>
           <a:solidFill>
-            <a:srgbClr val="111827"/>
+            <a:srgbClr val="0F172A"/>
           </a:solidFill>
           <a:ln>
             <a:solidFill>
@@ -4332,14 +4555,14 @@
       </p:sp>
       <p:sp>
         <p:nvSpPr>
-          <p:cNvPr id="5" name="TextBox 4"/>
+          <p:cNvPr id="6" name="TextBox 5"/>
           <p:cNvSpPr txBox="1"/>
           <p:nvPr/>
         </p:nvSpPr>
         <p:spPr>
           <a:xfrm>
-            <a:off x="1005840" y="1828800"/>
-            <a:ext cx="10149840" cy="4023360"/>
+            <a:off x="1005840" y="1737360"/>
+            <a:ext cx="10149840" cy="4206240"/>
           </a:xfrm>
           <a:prstGeom prst="rect">
             <a:avLst/>
@@ -4355,7 +4578,7 @@
             <a:pPr>
               <a:defRPr sz="1600" b="1">
                 <a:solidFill>
-                  <a:srgbClr val="00F0FF"/>
+                  <a:srgbClr val="06B6D4"/>
                 </a:solidFill>
               </a:defRPr>
             </a:pPr>
@@ -4367,7 +4590,7 @@
             <a:pPr>
               <a:defRPr sz="1400">
                 <a:solidFill>
-                  <a:srgbClr val="F9FAFB"/>
+                  <a:srgbClr val="F8FAFC"/>
                 </a:solidFill>
                 <a:latin typeface="JetBrains Mono"/>
               </a:defRPr>
@@ -4436,7 +4659,7 @@
     <p:bg>
       <p:bgPr>
         <a:solidFill>
-          <a:srgbClr val="0B0F19"/>
+          <a:srgbClr val="080C16"/>
         </a:solidFill>
         <a:effectLst/>
       </p:bgPr>
@@ -4473,7 +4696,7 @@
             <a:pPr>
               <a:defRPr sz="1000" b="1">
                 <a:solidFill>
-                  <a:srgbClr val="00F0FF"/>
+                  <a:srgbClr val="06B6D4"/>
                 </a:solidFill>
               </a:defRPr>
             </a:pPr>
@@ -4508,7 +4731,7 @@
             <a:pPr>
               <a:defRPr sz="2600" b="1">
                 <a:solidFill>
-                  <a:srgbClr val="F9FAFB"/>
+                  <a:srgbClr val="F8FAFC"/>
                 </a:solidFill>
               </a:defRPr>
             </a:pPr>
@@ -4520,20 +4743,55 @@
       </p:sp>
       <p:sp>
         <p:nvSpPr>
-          <p:cNvPr id="4" name="Rounded Rectangle 3"/>
+          <p:cNvPr id="4" name="TextBox 3"/>
+          <p:cNvSpPr txBox="1"/>
+          <p:nvPr/>
+        </p:nvSpPr>
+        <p:spPr>
+          <a:xfrm>
+            <a:off x="731520" y="6400800"/>
+            <a:ext cx="10725912" cy="320040"/>
+          </a:xfrm>
+          <a:prstGeom prst="rect">
+            <a:avLst/>
+          </a:prstGeom>
+          <a:noFill/>
+        </p:spPr>
+        <p:txBody>
+          <a:bodyPr wrap="none">
+            <a:spAutoFit/>
+          </a:bodyPr>
+          <a:lstStyle/>
+          <a:p>
+            <a:pPr>
+              <a:defRPr sz="900">
+                <a:solidFill>
+                  <a:srgbClr val="94A3B8"/>
+                </a:solidFill>
+              </a:defRPr>
+            </a:pPr>
+            <a:r>
+              <a:t>EvalMesh | AI Gateway for Secure &amp; Reliable Agent Deployment   •   Slide 5 of 10</a:t>
+            </a:r>
+          </a:p>
+        </p:txBody>
+      </p:sp>
+      <p:sp>
+        <p:nvSpPr>
+          <p:cNvPr id="5" name="Rounded Rectangle 4"/>
           <p:cNvSpPr/>
           <p:nvPr/>
         </p:nvSpPr>
         <p:spPr>
           <a:xfrm>
-            <a:off x="731520" y="1645920"/>
-            <a:ext cx="5120640" cy="1005840"/>
+            <a:off x="731520" y="1554480"/>
+            <a:ext cx="5148072" cy="1051560"/>
           </a:xfrm>
           <a:prstGeom prst="roundRect">
             <a:avLst/>
           </a:prstGeom>
           <a:solidFill>
-            <a:srgbClr val="111827"/>
+            <a:srgbClr val="0F172A"/>
           </a:solidFill>
           <a:ln>
             <a:solidFill>
@@ -4565,14 +4823,14 @@
       </p:sp>
       <p:sp>
         <p:nvSpPr>
-          <p:cNvPr id="5" name="TextBox 4"/>
+          <p:cNvPr id="6" name="TextBox 5"/>
           <p:cNvSpPr txBox="1"/>
           <p:nvPr/>
         </p:nvSpPr>
         <p:spPr>
           <a:xfrm>
-            <a:off x="868680" y="1737360"/>
-            <a:ext cx="4846320" cy="822960"/>
+            <a:off x="868680" y="1645920"/>
+            <a:ext cx="4873752" cy="868680"/>
           </a:xfrm>
           <a:prstGeom prst="rect">
             <a:avLst/>
@@ -4588,7 +4846,7 @@
             <a:pPr>
               <a:defRPr sz="1600" b="1">
                 <a:solidFill>
-                  <a:srgbClr val="F9FAFB"/>
+                  <a:srgbClr val="F8FAFC"/>
                 </a:solidFill>
               </a:defRPr>
             </a:pPr>
@@ -4600,7 +4858,7 @@
             <a:pPr>
               <a:defRPr sz="1200">
                 <a:solidFill>
-                  <a:srgbClr val="9CA3AF"/>
+                  <a:srgbClr val="94A3B8"/>
                 </a:solidFill>
               </a:defRPr>
             </a:pPr>
@@ -4612,20 +4870,20 @@
       </p:sp>
       <p:sp>
         <p:nvSpPr>
-          <p:cNvPr id="6" name="Rounded Rectangle 5"/>
+          <p:cNvPr id="7" name="Rounded Rectangle 6"/>
           <p:cNvSpPr/>
           <p:nvPr/>
         </p:nvSpPr>
         <p:spPr>
           <a:xfrm>
-            <a:off x="6126480" y="1645920"/>
-            <a:ext cx="5120640" cy="1005840"/>
+            <a:off x="6126480" y="1554480"/>
+            <a:ext cx="5148072" cy="1051560"/>
           </a:xfrm>
           <a:prstGeom prst="roundRect">
             <a:avLst/>
           </a:prstGeom>
           <a:solidFill>
-            <a:srgbClr val="111827"/>
+            <a:srgbClr val="0F172A"/>
           </a:solidFill>
           <a:ln>
             <a:solidFill>
@@ -4657,14 +4915,14 @@
       </p:sp>
       <p:sp>
         <p:nvSpPr>
-          <p:cNvPr id="7" name="TextBox 6"/>
+          <p:cNvPr id="8" name="TextBox 7"/>
           <p:cNvSpPr txBox="1"/>
           <p:nvPr/>
         </p:nvSpPr>
         <p:spPr>
           <a:xfrm>
-            <a:off x="6263640" y="1737360"/>
-            <a:ext cx="4846320" cy="822960"/>
+            <a:off x="6263640" y="1645920"/>
+            <a:ext cx="4873752" cy="868680"/>
           </a:xfrm>
           <a:prstGeom prst="rect">
             <a:avLst/>
@@ -4680,7 +4938,7 @@
             <a:pPr>
               <a:defRPr sz="1600" b="1">
                 <a:solidFill>
-                  <a:srgbClr val="F9FAFB"/>
+                  <a:srgbClr val="F8FAFC"/>
                 </a:solidFill>
               </a:defRPr>
             </a:pPr>
@@ -4692,7 +4950,7 @@
             <a:pPr>
               <a:defRPr sz="1200">
                 <a:solidFill>
-                  <a:srgbClr val="9CA3AF"/>
+                  <a:srgbClr val="94A3B8"/>
                 </a:solidFill>
               </a:defRPr>
             </a:pPr>
@@ -4704,20 +4962,20 @@
       </p:sp>
       <p:sp>
         <p:nvSpPr>
-          <p:cNvPr id="8" name="Rounded Rectangle 7"/>
+          <p:cNvPr id="9" name="Rounded Rectangle 8"/>
           <p:cNvSpPr/>
           <p:nvPr/>
         </p:nvSpPr>
         <p:spPr>
           <a:xfrm>
-            <a:off x="731520" y="2788920"/>
-            <a:ext cx="5120640" cy="1005840"/>
+            <a:off x="731520" y="2743200"/>
+            <a:ext cx="5148072" cy="1051560"/>
           </a:xfrm>
           <a:prstGeom prst="roundRect">
             <a:avLst/>
           </a:prstGeom>
           <a:solidFill>
-            <a:srgbClr val="111827"/>
+            <a:srgbClr val="0F172A"/>
           </a:solidFill>
           <a:ln>
             <a:solidFill>
@@ -4749,14 +5007,14 @@
       </p:sp>
       <p:sp>
         <p:nvSpPr>
-          <p:cNvPr id="9" name="TextBox 8"/>
+          <p:cNvPr id="10" name="TextBox 9"/>
           <p:cNvSpPr txBox="1"/>
           <p:nvPr/>
         </p:nvSpPr>
         <p:spPr>
           <a:xfrm>
-            <a:off x="868680" y="2880360"/>
-            <a:ext cx="4846320" cy="822960"/>
+            <a:off x="868680" y="2834640"/>
+            <a:ext cx="4873752" cy="868680"/>
           </a:xfrm>
           <a:prstGeom prst="rect">
             <a:avLst/>
@@ -4772,7 +5030,7 @@
             <a:pPr>
               <a:defRPr sz="1600" b="1">
                 <a:solidFill>
-                  <a:srgbClr val="F9FAFB"/>
+                  <a:srgbClr val="F8FAFC"/>
                 </a:solidFill>
               </a:defRPr>
             </a:pPr>
@@ -4784,7 +5042,7 @@
             <a:pPr>
               <a:defRPr sz="1200">
                 <a:solidFill>
-                  <a:srgbClr val="9CA3AF"/>
+                  <a:srgbClr val="94A3B8"/>
                 </a:solidFill>
               </a:defRPr>
             </a:pPr>
@@ -4796,20 +5054,20 @@
       </p:sp>
       <p:sp>
         <p:nvSpPr>
-          <p:cNvPr id="10" name="Rounded Rectangle 9"/>
+          <p:cNvPr id="11" name="Rounded Rectangle 10"/>
           <p:cNvSpPr/>
           <p:nvPr/>
         </p:nvSpPr>
         <p:spPr>
           <a:xfrm>
-            <a:off x="6126480" y="2788920"/>
-            <a:ext cx="5120640" cy="1005840"/>
+            <a:off x="6126480" y="2743200"/>
+            <a:ext cx="5148072" cy="1051560"/>
           </a:xfrm>
           <a:prstGeom prst="roundRect">
             <a:avLst/>
           </a:prstGeom>
           <a:solidFill>
-            <a:srgbClr val="111827"/>
+            <a:srgbClr val="0F172A"/>
           </a:solidFill>
           <a:ln>
             <a:solidFill>
@@ -4841,14 +5099,14 @@
       </p:sp>
       <p:sp>
         <p:nvSpPr>
-          <p:cNvPr id="11" name="TextBox 10"/>
+          <p:cNvPr id="12" name="TextBox 11"/>
           <p:cNvSpPr txBox="1"/>
           <p:nvPr/>
         </p:nvSpPr>
         <p:spPr>
           <a:xfrm>
-            <a:off x="6263640" y="2880360"/>
-            <a:ext cx="4846320" cy="822960"/>
+            <a:off x="6263640" y="2834640"/>
+            <a:ext cx="4873752" cy="868680"/>
           </a:xfrm>
           <a:prstGeom prst="rect">
             <a:avLst/>
@@ -4864,7 +5122,7 @@
             <a:pPr>
               <a:defRPr sz="1600" b="1">
                 <a:solidFill>
-                  <a:srgbClr val="F9FAFB"/>
+                  <a:srgbClr val="F8FAFC"/>
                 </a:solidFill>
               </a:defRPr>
             </a:pPr>
@@ -4876,7 +5134,7 @@
             <a:pPr>
               <a:defRPr sz="1200">
                 <a:solidFill>
-                  <a:srgbClr val="9CA3AF"/>
+                  <a:srgbClr val="94A3B8"/>
                 </a:solidFill>
               </a:defRPr>
             </a:pPr>
@@ -4888,20 +5146,20 @@
       </p:sp>
       <p:sp>
         <p:nvSpPr>
-          <p:cNvPr id="12" name="Rounded Rectangle 11"/>
+          <p:cNvPr id="13" name="Rounded Rectangle 12"/>
           <p:cNvSpPr/>
           <p:nvPr/>
         </p:nvSpPr>
         <p:spPr>
           <a:xfrm>
             <a:off x="731520" y="3931920"/>
-            <a:ext cx="5120640" cy="1005840"/>
+            <a:ext cx="5148072" cy="1051560"/>
           </a:xfrm>
           <a:prstGeom prst="roundRect">
             <a:avLst/>
           </a:prstGeom>
           <a:solidFill>
-            <a:srgbClr val="111827"/>
+            <a:srgbClr val="0F172A"/>
           </a:solidFill>
           <a:ln>
             <a:solidFill>
@@ -4933,14 +5191,14 @@
       </p:sp>
       <p:sp>
         <p:nvSpPr>
-          <p:cNvPr id="13" name="TextBox 12"/>
+          <p:cNvPr id="14" name="TextBox 13"/>
           <p:cNvSpPr txBox="1"/>
           <p:nvPr/>
         </p:nvSpPr>
         <p:spPr>
           <a:xfrm>
             <a:off x="868680" y="4023360"/>
-            <a:ext cx="4846320" cy="822960"/>
+            <a:ext cx="4873752" cy="868680"/>
           </a:xfrm>
           <a:prstGeom prst="rect">
             <a:avLst/>
@@ -4956,7 +5214,7 @@
             <a:pPr>
               <a:defRPr sz="1600" b="1">
                 <a:solidFill>
-                  <a:srgbClr val="F9FAFB"/>
+                  <a:srgbClr val="F8FAFC"/>
                 </a:solidFill>
               </a:defRPr>
             </a:pPr>
@@ -4968,7 +5226,7 @@
             <a:pPr>
               <a:defRPr sz="1200">
                 <a:solidFill>
-                  <a:srgbClr val="9CA3AF"/>
+                  <a:srgbClr val="94A3B8"/>
                 </a:solidFill>
               </a:defRPr>
             </a:pPr>
@@ -4980,20 +5238,20 @@
       </p:sp>
       <p:sp>
         <p:nvSpPr>
-          <p:cNvPr id="14" name="Rounded Rectangle 13"/>
+          <p:cNvPr id="15" name="Rounded Rectangle 14"/>
           <p:cNvSpPr/>
           <p:nvPr/>
         </p:nvSpPr>
         <p:spPr>
           <a:xfrm>
             <a:off x="6126480" y="3931920"/>
-            <a:ext cx="5120640" cy="1005840"/>
+            <a:ext cx="5148072" cy="1051560"/>
           </a:xfrm>
           <a:prstGeom prst="roundRect">
             <a:avLst/>
           </a:prstGeom>
           <a:solidFill>
-            <a:srgbClr val="111827"/>
+            <a:srgbClr val="0F172A"/>
           </a:solidFill>
           <a:ln>
             <a:solidFill>
@@ -5025,14 +5283,14 @@
       </p:sp>
       <p:sp>
         <p:nvSpPr>
-          <p:cNvPr id="15" name="TextBox 14"/>
+          <p:cNvPr id="16" name="TextBox 15"/>
           <p:cNvSpPr txBox="1"/>
           <p:nvPr/>
         </p:nvSpPr>
         <p:spPr>
           <a:xfrm>
             <a:off x="6263640" y="4023360"/>
-            <a:ext cx="4846320" cy="822960"/>
+            <a:ext cx="4873752" cy="868680"/>
           </a:xfrm>
           <a:prstGeom prst="rect">
             <a:avLst/>
@@ -5048,7 +5306,7 @@
             <a:pPr>
               <a:defRPr sz="1600" b="1">
                 <a:solidFill>
-                  <a:srgbClr val="F9FAFB"/>
+                  <a:srgbClr val="F8FAFC"/>
                 </a:solidFill>
               </a:defRPr>
             </a:pPr>
@@ -5060,7 +5318,7 @@
             <a:pPr>
               <a:defRPr sz="1200">
                 <a:solidFill>
-                  <a:srgbClr val="9CA3AF"/>
+                  <a:srgbClr val="94A3B8"/>
                 </a:solidFill>
               </a:defRPr>
             </a:pPr>
@@ -5072,20 +5330,20 @@
       </p:sp>
       <p:sp>
         <p:nvSpPr>
-          <p:cNvPr id="16" name="Rounded Rectangle 15"/>
+          <p:cNvPr id="17" name="Rounded Rectangle 16"/>
           <p:cNvSpPr/>
           <p:nvPr/>
         </p:nvSpPr>
         <p:spPr>
           <a:xfrm>
-            <a:off x="731520" y="5074920"/>
-            <a:ext cx="5120640" cy="1005840"/>
+            <a:off x="731520" y="5120640"/>
+            <a:ext cx="5148072" cy="1051560"/>
           </a:xfrm>
           <a:prstGeom prst="roundRect">
             <a:avLst/>
           </a:prstGeom>
           <a:solidFill>
-            <a:srgbClr val="111827"/>
+            <a:srgbClr val="0F172A"/>
           </a:solidFill>
           <a:ln>
             <a:solidFill>
@@ -5117,14 +5375,14 @@
       </p:sp>
       <p:sp>
         <p:nvSpPr>
-          <p:cNvPr id="17" name="TextBox 16"/>
+          <p:cNvPr id="18" name="TextBox 17"/>
           <p:cNvSpPr txBox="1"/>
           <p:nvPr/>
         </p:nvSpPr>
         <p:spPr>
           <a:xfrm>
-            <a:off x="868680" y="5166360"/>
-            <a:ext cx="4846320" cy="822960"/>
+            <a:off x="868680" y="5212080"/>
+            <a:ext cx="4873752" cy="868680"/>
           </a:xfrm>
           <a:prstGeom prst="rect">
             <a:avLst/>
@@ -5140,7 +5398,7 @@
             <a:pPr>
               <a:defRPr sz="1600" b="1">
                 <a:solidFill>
-                  <a:srgbClr val="F9FAFB"/>
+                  <a:srgbClr val="F8FAFC"/>
                 </a:solidFill>
               </a:defRPr>
             </a:pPr>
@@ -5152,7 +5410,7 @@
             <a:pPr>
               <a:defRPr sz="1200">
                 <a:solidFill>
-                  <a:srgbClr val="9CA3AF"/>
+                  <a:srgbClr val="94A3B8"/>
                 </a:solidFill>
               </a:defRPr>
             </a:pPr>
@@ -5164,20 +5422,20 @@
       </p:sp>
       <p:sp>
         <p:nvSpPr>
-          <p:cNvPr id="18" name="Rounded Rectangle 17"/>
+          <p:cNvPr id="19" name="Rounded Rectangle 18"/>
           <p:cNvSpPr/>
           <p:nvPr/>
         </p:nvSpPr>
         <p:spPr>
           <a:xfrm>
-            <a:off x="6126480" y="5074920"/>
-            <a:ext cx="5120640" cy="1005840"/>
+            <a:off x="6126480" y="5120640"/>
+            <a:ext cx="5148072" cy="1051560"/>
           </a:xfrm>
           <a:prstGeom prst="roundRect">
             <a:avLst/>
           </a:prstGeom>
           <a:solidFill>
-            <a:srgbClr val="111827"/>
+            <a:srgbClr val="0F172A"/>
           </a:solidFill>
           <a:ln>
             <a:solidFill>
@@ -5209,14 +5467,14 @@
       </p:sp>
       <p:sp>
         <p:nvSpPr>
-          <p:cNvPr id="19" name="TextBox 18"/>
+          <p:cNvPr id="20" name="TextBox 19"/>
           <p:cNvSpPr txBox="1"/>
           <p:nvPr/>
         </p:nvSpPr>
         <p:spPr>
           <a:xfrm>
-            <a:off x="6263640" y="5166360"/>
-            <a:ext cx="4846320" cy="822960"/>
+            <a:off x="6263640" y="5212080"/>
+            <a:ext cx="4873752" cy="868680"/>
           </a:xfrm>
           <a:prstGeom prst="rect">
             <a:avLst/>
@@ -5232,7 +5490,7 @@
             <a:pPr>
               <a:defRPr sz="1600" b="1">
                 <a:solidFill>
-                  <a:srgbClr val="F9FAFB"/>
+                  <a:srgbClr val="F8FAFC"/>
                 </a:solidFill>
               </a:defRPr>
             </a:pPr>
@@ -5244,7 +5502,7 @@
             <a:pPr>
               <a:defRPr sz="1200">
                 <a:solidFill>
-                  <a:srgbClr val="9CA3AF"/>
+                  <a:srgbClr val="94A3B8"/>
                 </a:solidFill>
               </a:defRPr>
             </a:pPr>
@@ -5268,7 +5526,7 @@
     <p:bg>
       <p:bgPr>
         <a:solidFill>
-          <a:srgbClr val="0B0F19"/>
+          <a:srgbClr val="080C16"/>
         </a:solidFill>
         <a:effectLst/>
       </p:bgPr>
@@ -5305,7 +5563,7 @@
             <a:pPr>
               <a:defRPr sz="1000" b="1">
                 <a:solidFill>
-                  <a:srgbClr val="00F0FF"/>
+                  <a:srgbClr val="06B6D4"/>
                 </a:solidFill>
               </a:defRPr>
             </a:pPr>
@@ -5340,7 +5598,7 @@
             <a:pPr>
               <a:defRPr sz="2600" b="1">
                 <a:solidFill>
-                  <a:srgbClr val="F9FAFB"/>
+                  <a:srgbClr val="F8FAFC"/>
                 </a:solidFill>
               </a:defRPr>
             </a:pPr>
@@ -5352,20 +5610,55 @@
       </p:sp>
       <p:sp>
         <p:nvSpPr>
-          <p:cNvPr id="4" name="Rounded Rectangle 3"/>
+          <p:cNvPr id="4" name="TextBox 3"/>
+          <p:cNvSpPr txBox="1"/>
+          <p:nvPr/>
+        </p:nvSpPr>
+        <p:spPr>
+          <a:xfrm>
+            <a:off x="731520" y="6400800"/>
+            <a:ext cx="10725912" cy="320040"/>
+          </a:xfrm>
+          <a:prstGeom prst="rect">
+            <a:avLst/>
+          </a:prstGeom>
+          <a:noFill/>
+        </p:spPr>
+        <p:txBody>
+          <a:bodyPr wrap="none">
+            <a:spAutoFit/>
+          </a:bodyPr>
+          <a:lstStyle/>
+          <a:p>
+            <a:pPr>
+              <a:defRPr sz="900">
+                <a:solidFill>
+                  <a:srgbClr val="94A3B8"/>
+                </a:solidFill>
+              </a:defRPr>
+            </a:pPr>
+            <a:r>
+              <a:t>EvalMesh | AI Gateway for Secure &amp; Reliable Agent Deployment   •   Slide 6 of 10</a:t>
+            </a:r>
+          </a:p>
+        </p:txBody>
+      </p:sp>
+      <p:sp>
+        <p:nvSpPr>
+          <p:cNvPr id="5" name="Rounded Rectangle 4"/>
           <p:cNvSpPr/>
           <p:nvPr/>
         </p:nvSpPr>
         <p:spPr>
           <a:xfrm>
-            <a:off x="731520" y="1645920"/>
+            <a:off x="731520" y="1554480"/>
             <a:ext cx="10725912" cy="777240"/>
           </a:xfrm>
           <a:prstGeom prst="roundRect">
             <a:avLst/>
           </a:prstGeom>
           <a:solidFill>
-            <a:srgbClr val="111827"/>
+            <a:srgbClr val="0F172A"/>
           </a:solidFill>
           <a:ln>
             <a:solidFill>
@@ -5397,14 +5690,14 @@
       </p:sp>
       <p:sp>
         <p:nvSpPr>
-          <p:cNvPr id="5" name="TextBox 4"/>
+          <p:cNvPr id="6" name="TextBox 5"/>
           <p:cNvSpPr txBox="1"/>
           <p:nvPr/>
         </p:nvSpPr>
         <p:spPr>
           <a:xfrm>
-            <a:off x="914400" y="1737360"/>
-            <a:ext cx="10332720" cy="594360"/>
+            <a:off x="914400" y="1645920"/>
+            <a:ext cx="10360152" cy="594360"/>
           </a:xfrm>
           <a:prstGeom prst="rect">
             <a:avLst/>
@@ -5420,7 +5713,7 @@
             <a:pPr>
               <a:defRPr sz="1600" b="1">
                 <a:solidFill>
-                  <a:srgbClr val="F9FAFB"/>
+                  <a:srgbClr val="F8FAFC"/>
                 </a:solidFill>
               </a:defRPr>
             </a:pPr>
@@ -5432,20 +5725,20 @@
       </p:sp>
       <p:sp>
         <p:nvSpPr>
-          <p:cNvPr id="6" name="Rounded Rectangle 5"/>
+          <p:cNvPr id="7" name="Rounded Rectangle 6"/>
           <p:cNvSpPr/>
           <p:nvPr/>
         </p:nvSpPr>
         <p:spPr>
           <a:xfrm>
-            <a:off x="731520" y="2560320"/>
+            <a:off x="731520" y="2468880"/>
             <a:ext cx="10725912" cy="777240"/>
           </a:xfrm>
           <a:prstGeom prst="roundRect">
             <a:avLst/>
           </a:prstGeom>
           <a:solidFill>
-            <a:srgbClr val="111827"/>
+            <a:srgbClr val="0F172A"/>
           </a:solidFill>
           <a:ln>
             <a:solidFill>
@@ -5477,14 +5770,14 @@
       </p:sp>
       <p:sp>
         <p:nvSpPr>
-          <p:cNvPr id="7" name="TextBox 6"/>
+          <p:cNvPr id="8" name="TextBox 7"/>
           <p:cNvSpPr txBox="1"/>
           <p:nvPr/>
         </p:nvSpPr>
         <p:spPr>
           <a:xfrm>
-            <a:off x="914400" y="2651760"/>
-            <a:ext cx="10332720" cy="594360"/>
+            <a:off x="914400" y="2560320"/>
+            <a:ext cx="10360152" cy="594360"/>
           </a:xfrm>
           <a:prstGeom prst="rect">
             <a:avLst/>
@@ -5500,7 +5793,7 @@
             <a:pPr>
               <a:defRPr sz="1600" b="1">
                 <a:solidFill>
-                  <a:srgbClr val="F9FAFB"/>
+                  <a:srgbClr val="F8FAFC"/>
                 </a:solidFill>
               </a:defRPr>
             </a:pPr>
@@ -5512,20 +5805,20 @@
       </p:sp>
       <p:sp>
         <p:nvSpPr>
-          <p:cNvPr id="8" name="Rounded Rectangle 7"/>
+          <p:cNvPr id="9" name="Rounded Rectangle 8"/>
           <p:cNvSpPr/>
           <p:nvPr/>
         </p:nvSpPr>
         <p:spPr>
           <a:xfrm>
-            <a:off x="731520" y="3474720"/>
+            <a:off x="731520" y="3383280"/>
             <a:ext cx="10725912" cy="777240"/>
           </a:xfrm>
           <a:prstGeom prst="roundRect">
             <a:avLst/>
           </a:prstGeom>
           <a:solidFill>
-            <a:srgbClr val="111827"/>
+            <a:srgbClr val="0F172A"/>
           </a:solidFill>
           <a:ln>
             <a:solidFill>
@@ -5557,14 +5850,14 @@
       </p:sp>
       <p:sp>
         <p:nvSpPr>
-          <p:cNvPr id="9" name="TextBox 8"/>
+          <p:cNvPr id="10" name="TextBox 9"/>
           <p:cNvSpPr txBox="1"/>
           <p:nvPr/>
         </p:nvSpPr>
         <p:spPr>
           <a:xfrm>
-            <a:off x="914400" y="3566160"/>
-            <a:ext cx="10332720" cy="594360"/>
+            <a:off x="914400" y="3474720"/>
+            <a:ext cx="10360152" cy="594360"/>
           </a:xfrm>
           <a:prstGeom prst="rect">
             <a:avLst/>
@@ -5580,7 +5873,7 @@
             <a:pPr>
               <a:defRPr sz="1600" b="1">
                 <a:solidFill>
-                  <a:srgbClr val="F9FAFB"/>
+                  <a:srgbClr val="F8FAFC"/>
                 </a:solidFill>
               </a:defRPr>
             </a:pPr>
@@ -5592,20 +5885,20 @@
       </p:sp>
       <p:sp>
         <p:nvSpPr>
-          <p:cNvPr id="10" name="Rounded Rectangle 9"/>
+          <p:cNvPr id="11" name="Rounded Rectangle 10"/>
           <p:cNvSpPr/>
           <p:nvPr/>
         </p:nvSpPr>
         <p:spPr>
           <a:xfrm>
-            <a:off x="731520" y="4389120"/>
+            <a:off x="731520" y="4297680"/>
             <a:ext cx="10725912" cy="777240"/>
           </a:xfrm>
           <a:prstGeom prst="roundRect">
             <a:avLst/>
           </a:prstGeom>
           <a:solidFill>
-            <a:srgbClr val="111827"/>
+            <a:srgbClr val="0F172A"/>
           </a:solidFill>
           <a:ln>
             <a:solidFill>
@@ -5637,14 +5930,14 @@
       </p:sp>
       <p:sp>
         <p:nvSpPr>
-          <p:cNvPr id="11" name="TextBox 10"/>
+          <p:cNvPr id="12" name="TextBox 11"/>
           <p:cNvSpPr txBox="1"/>
           <p:nvPr/>
         </p:nvSpPr>
         <p:spPr>
           <a:xfrm>
-            <a:off x="914400" y="4480560"/>
-            <a:ext cx="10332720" cy="594360"/>
+            <a:off x="914400" y="4389120"/>
+            <a:ext cx="10360152" cy="594360"/>
           </a:xfrm>
           <a:prstGeom prst="rect">
             <a:avLst/>
@@ -5660,7 +5953,7 @@
             <a:pPr>
               <a:defRPr sz="1600" b="1">
                 <a:solidFill>
-                  <a:srgbClr val="F9FAFB"/>
+                  <a:srgbClr val="F8FAFC"/>
                 </a:solidFill>
               </a:defRPr>
             </a:pPr>
@@ -5672,20 +5965,20 @@
       </p:sp>
       <p:sp>
         <p:nvSpPr>
-          <p:cNvPr id="12" name="Rounded Rectangle 11"/>
+          <p:cNvPr id="13" name="Rounded Rectangle 12"/>
           <p:cNvSpPr/>
           <p:nvPr/>
         </p:nvSpPr>
         <p:spPr>
           <a:xfrm>
-            <a:off x="731520" y="5303520"/>
+            <a:off x="731520" y="5212080"/>
             <a:ext cx="10725912" cy="777240"/>
           </a:xfrm>
           <a:prstGeom prst="roundRect">
             <a:avLst/>
           </a:prstGeom>
           <a:solidFill>
-            <a:srgbClr val="111827"/>
+            <a:srgbClr val="0F172A"/>
           </a:solidFill>
           <a:ln>
             <a:solidFill>
@@ -5717,14 +6010,14 @@
       </p:sp>
       <p:sp>
         <p:nvSpPr>
-          <p:cNvPr id="13" name="TextBox 12"/>
+          <p:cNvPr id="14" name="TextBox 13"/>
           <p:cNvSpPr txBox="1"/>
           <p:nvPr/>
         </p:nvSpPr>
         <p:spPr>
           <a:xfrm>
-            <a:off x="914400" y="5394960"/>
-            <a:ext cx="10332720" cy="594360"/>
+            <a:off x="914400" y="5303520"/>
+            <a:ext cx="10360152" cy="594360"/>
           </a:xfrm>
           <a:prstGeom prst="rect">
             <a:avLst/>
@@ -5740,7 +6033,7 @@
             <a:pPr>
               <a:defRPr sz="1600" b="1">
                 <a:solidFill>
-                  <a:srgbClr val="F9FAFB"/>
+                  <a:srgbClr val="F8FAFC"/>
                 </a:solidFill>
               </a:defRPr>
             </a:pPr>
@@ -5764,7 +6057,7 @@
     <p:bg>
       <p:bgPr>
         <a:solidFill>
-          <a:srgbClr val="0B0F19"/>
+          <a:srgbClr val="080C16"/>
         </a:solidFill>
         <a:effectLst/>
       </p:bgPr>
@@ -5801,7 +6094,7 @@
             <a:pPr>
               <a:defRPr sz="1000" b="1">
                 <a:solidFill>
-                  <a:srgbClr val="00F0FF"/>
+                  <a:srgbClr val="06B6D4"/>
                 </a:solidFill>
               </a:defRPr>
             </a:pPr>
@@ -5836,7 +6129,7 @@
             <a:pPr>
               <a:defRPr sz="2600" b="1">
                 <a:solidFill>
-                  <a:srgbClr val="F9FAFB"/>
+                  <a:srgbClr val="F8FAFC"/>
                 </a:solidFill>
               </a:defRPr>
             </a:pPr>
@@ -5848,24 +6141,59 @@
       </p:sp>
       <p:sp>
         <p:nvSpPr>
-          <p:cNvPr id="4" name="Rounded Rectangle 3"/>
+          <p:cNvPr id="4" name="TextBox 3"/>
+          <p:cNvSpPr txBox="1"/>
+          <p:nvPr/>
+        </p:nvSpPr>
+        <p:spPr>
+          <a:xfrm>
+            <a:off x="731520" y="6400800"/>
+            <a:ext cx="10725912" cy="320040"/>
+          </a:xfrm>
+          <a:prstGeom prst="rect">
+            <a:avLst/>
+          </a:prstGeom>
+          <a:noFill/>
+        </p:spPr>
+        <p:txBody>
+          <a:bodyPr wrap="none">
+            <a:spAutoFit/>
+          </a:bodyPr>
+          <a:lstStyle/>
+          <a:p>
+            <a:pPr>
+              <a:defRPr sz="900">
+                <a:solidFill>
+                  <a:srgbClr val="94A3B8"/>
+                </a:solidFill>
+              </a:defRPr>
+            </a:pPr>
+            <a:r>
+              <a:t>EvalMesh | AI Gateway for Secure &amp; Reliable Agent Deployment   •   Slide 7 of 10</a:t>
+            </a:r>
+          </a:p>
+        </p:txBody>
+      </p:sp>
+      <p:sp>
+        <p:nvSpPr>
+          <p:cNvPr id="5" name="Rounded Rectangle 4"/>
           <p:cNvSpPr/>
           <p:nvPr/>
         </p:nvSpPr>
         <p:spPr>
           <a:xfrm>
-            <a:off x="731520" y="1645920"/>
-            <a:ext cx="3291840" cy="4389120"/>
+            <a:off x="731520" y="1554480"/>
+            <a:ext cx="3319272" cy="4572000"/>
           </a:xfrm>
           <a:prstGeom prst="roundRect">
             <a:avLst/>
           </a:prstGeom>
           <a:solidFill>
-            <a:srgbClr val="111827"/>
+            <a:srgbClr val="0F172A"/>
           </a:solidFill>
           <a:ln w="19050">
             <a:solidFill>
-              <a:srgbClr val="00F0FF"/>
+              <a:srgbClr val="06B6D4"/>
             </a:solidFill>
           </a:ln>
         </p:spPr>
@@ -5893,14 +6221,14 @@
       </p:sp>
       <p:sp>
         <p:nvSpPr>
-          <p:cNvPr id="5" name="TextBox 4"/>
+          <p:cNvPr id="6" name="TextBox 5"/>
           <p:cNvSpPr txBox="1"/>
           <p:nvPr/>
         </p:nvSpPr>
         <p:spPr>
           <a:xfrm>
-            <a:off x="914400" y="1920240"/>
-            <a:ext cx="2926080" cy="3840480"/>
+            <a:off x="914400" y="1828800"/>
+            <a:ext cx="2953512" cy="4023360"/>
           </a:xfrm>
           <a:prstGeom prst="rect">
             <a:avLst/>
@@ -5916,7 +6244,7 @@
             <a:pPr>
               <a:defRPr sz="3600" b="1">
                 <a:solidFill>
-                  <a:srgbClr val="00F0FF"/>
+                  <a:srgbClr val="06B6D4"/>
                 </a:solidFill>
               </a:defRPr>
             </a:pPr>
@@ -5929,7 +6257,7 @@
             <a:pPr>
               <a:defRPr sz="1600" b="1">
                 <a:solidFill>
-                  <a:srgbClr val="F9FAFB"/>
+                  <a:srgbClr val="F8FAFC"/>
                 </a:solidFill>
               </a:defRPr>
             </a:pPr>
@@ -5942,7 +6270,7 @@
             <a:pPr>
               <a:defRPr sz="1300">
                 <a:solidFill>
-                  <a:srgbClr val="9CA3AF"/>
+                  <a:srgbClr val="94A3B8"/>
                 </a:solidFill>
               </a:defRPr>
             </a:pPr>
@@ -5954,24 +6282,24 @@
       </p:sp>
       <p:sp>
         <p:nvSpPr>
-          <p:cNvPr id="6" name="Rounded Rectangle 5"/>
+          <p:cNvPr id="7" name="Rounded Rectangle 6"/>
           <p:cNvSpPr/>
           <p:nvPr/>
         </p:nvSpPr>
         <p:spPr>
           <a:xfrm>
-            <a:off x="4297680" y="1645920"/>
-            <a:ext cx="3291840" cy="4389120"/>
+            <a:off x="4297680" y="1554480"/>
+            <a:ext cx="3319272" cy="4572000"/>
           </a:xfrm>
           <a:prstGeom prst="roundRect">
             <a:avLst/>
           </a:prstGeom>
           <a:solidFill>
-            <a:srgbClr val="111827"/>
+            <a:srgbClr val="0F172A"/>
           </a:solidFill>
           <a:ln w="19050">
             <a:solidFill>
-              <a:srgbClr val="00F0FF"/>
+              <a:srgbClr val="06B6D4"/>
             </a:solidFill>
           </a:ln>
         </p:spPr>
@@ -5999,14 +6327,14 @@
       </p:sp>
       <p:sp>
         <p:nvSpPr>
-          <p:cNvPr id="7" name="TextBox 6"/>
+          <p:cNvPr id="8" name="TextBox 7"/>
           <p:cNvSpPr txBox="1"/>
           <p:nvPr/>
         </p:nvSpPr>
         <p:spPr>
           <a:xfrm>
-            <a:off x="4480560" y="1920240"/>
-            <a:ext cx="2926080" cy="3840480"/>
+            <a:off x="4480560" y="1828800"/>
+            <a:ext cx="2953512" cy="4023360"/>
           </a:xfrm>
           <a:prstGeom prst="rect">
             <a:avLst/>
@@ -6022,7 +6350,7 @@
             <a:pPr>
               <a:defRPr sz="3600" b="1">
                 <a:solidFill>
-                  <a:srgbClr val="00F0FF"/>
+                  <a:srgbClr val="06B6D4"/>
                 </a:solidFill>
               </a:defRPr>
             </a:pPr>
@@ -6035,7 +6363,7 @@
             <a:pPr>
               <a:defRPr sz="1600" b="1">
                 <a:solidFill>
-                  <a:srgbClr val="F9FAFB"/>
+                  <a:srgbClr val="F8FAFC"/>
                 </a:solidFill>
               </a:defRPr>
             </a:pPr>
@@ -6048,7 +6376,7 @@
             <a:pPr>
               <a:defRPr sz="1300">
                 <a:solidFill>
-                  <a:srgbClr val="9CA3AF"/>
+                  <a:srgbClr val="94A3B8"/>
                 </a:solidFill>
               </a:defRPr>
             </a:pPr>
@@ -6060,24 +6388,24 @@
       </p:sp>
       <p:sp>
         <p:nvSpPr>
-          <p:cNvPr id="8" name="Rounded Rectangle 7"/>
+          <p:cNvPr id="9" name="Rounded Rectangle 8"/>
           <p:cNvSpPr/>
           <p:nvPr/>
         </p:nvSpPr>
         <p:spPr>
           <a:xfrm>
-            <a:off x="7863840" y="1645920"/>
-            <a:ext cx="3291840" cy="4389120"/>
+            <a:off x="7863840" y="1554480"/>
+            <a:ext cx="3319272" cy="4572000"/>
           </a:xfrm>
           <a:prstGeom prst="roundRect">
             <a:avLst/>
           </a:prstGeom>
           <a:solidFill>
-            <a:srgbClr val="111827"/>
+            <a:srgbClr val="0F172A"/>
           </a:solidFill>
           <a:ln w="19050">
             <a:solidFill>
-              <a:srgbClr val="00F0FF"/>
+              <a:srgbClr val="06B6D4"/>
             </a:solidFill>
           </a:ln>
         </p:spPr>
@@ -6105,14 +6433,14 @@
       </p:sp>
       <p:sp>
         <p:nvSpPr>
-          <p:cNvPr id="9" name="TextBox 8"/>
+          <p:cNvPr id="10" name="TextBox 9"/>
           <p:cNvSpPr txBox="1"/>
           <p:nvPr/>
         </p:nvSpPr>
         <p:spPr>
           <a:xfrm>
-            <a:off x="8046720" y="1920240"/>
-            <a:ext cx="2926080" cy="3840480"/>
+            <a:off x="8046720" y="1828800"/>
+            <a:ext cx="2953512" cy="4023360"/>
           </a:xfrm>
           <a:prstGeom prst="rect">
             <a:avLst/>
@@ -6128,7 +6456,7 @@
             <a:pPr>
               <a:defRPr sz="3600" b="1">
                 <a:solidFill>
-                  <a:srgbClr val="00F0FF"/>
+                  <a:srgbClr val="06B6D4"/>
                 </a:solidFill>
               </a:defRPr>
             </a:pPr>
@@ -6141,7 +6469,7 @@
             <a:pPr>
               <a:defRPr sz="1600" b="1">
                 <a:solidFill>
-                  <a:srgbClr val="F9FAFB"/>
+                  <a:srgbClr val="F8FAFC"/>
                 </a:solidFill>
               </a:defRPr>
             </a:pPr>
@@ -6154,7 +6482,7 @@
             <a:pPr>
               <a:defRPr sz="1300">
                 <a:solidFill>
-                  <a:srgbClr val="9CA3AF"/>
+                  <a:srgbClr val="94A3B8"/>
                 </a:solidFill>
               </a:defRPr>
             </a:pPr>
@@ -6178,7 +6506,7 @@
     <p:bg>
       <p:bgPr>
         <a:solidFill>
-          <a:srgbClr val="0B0F19"/>
+          <a:srgbClr val="080C16"/>
         </a:solidFill>
         <a:effectLst/>
       </p:bgPr>
@@ -6215,7 +6543,7 @@
             <a:pPr>
               <a:defRPr sz="1000" b="1">
                 <a:solidFill>
-                  <a:srgbClr val="00F0FF"/>
+                  <a:srgbClr val="06B6D4"/>
                 </a:solidFill>
               </a:defRPr>
             </a:pPr>
@@ -6250,7 +6578,7 @@
             <a:pPr>
               <a:defRPr sz="2600" b="1">
                 <a:solidFill>
-                  <a:srgbClr val="F9FAFB"/>
+                  <a:srgbClr val="F8FAFC"/>
                 </a:solidFill>
               </a:defRPr>
             </a:pPr>
@@ -6262,20 +6590,55 @@
       </p:sp>
       <p:sp>
         <p:nvSpPr>
-          <p:cNvPr id="4" name="Rounded Rectangle 3"/>
+          <p:cNvPr id="4" name="TextBox 3"/>
+          <p:cNvSpPr txBox="1"/>
+          <p:nvPr/>
+        </p:nvSpPr>
+        <p:spPr>
+          <a:xfrm>
+            <a:off x="731520" y="6400800"/>
+            <a:ext cx="10725912" cy="320040"/>
+          </a:xfrm>
+          <a:prstGeom prst="rect">
+            <a:avLst/>
+          </a:prstGeom>
+          <a:noFill/>
+        </p:spPr>
+        <p:txBody>
+          <a:bodyPr wrap="none">
+            <a:spAutoFit/>
+          </a:bodyPr>
+          <a:lstStyle/>
+          <a:p>
+            <a:pPr>
+              <a:defRPr sz="900">
+                <a:solidFill>
+                  <a:srgbClr val="94A3B8"/>
+                </a:solidFill>
+              </a:defRPr>
+            </a:pPr>
+            <a:r>
+              <a:t>EvalMesh | AI Gateway for Secure &amp; Reliable Agent Deployment   •   Slide 8 of 10</a:t>
+            </a:r>
+          </a:p>
+        </p:txBody>
+      </p:sp>
+      <p:sp>
+        <p:nvSpPr>
+          <p:cNvPr id="5" name="Rounded Rectangle 4"/>
           <p:cNvSpPr/>
           <p:nvPr/>
         </p:nvSpPr>
         <p:spPr>
           <a:xfrm>
-            <a:off x="731520" y="1645920"/>
-            <a:ext cx="2514600" cy="4389120"/>
+            <a:off x="731520" y="1554480"/>
+            <a:ext cx="2514600" cy="4572000"/>
           </a:xfrm>
           <a:prstGeom prst="roundRect">
             <a:avLst/>
           </a:prstGeom>
           <a:solidFill>
-            <a:srgbClr val="111827"/>
+            <a:srgbClr val="0F172A"/>
           </a:solidFill>
           <a:ln w="25400">
             <a:solidFill>
@@ -6307,14 +6670,14 @@
       </p:sp>
       <p:sp>
         <p:nvSpPr>
-          <p:cNvPr id="5" name="TextBox 4"/>
+          <p:cNvPr id="6" name="TextBox 5"/>
           <p:cNvSpPr txBox="1"/>
           <p:nvPr/>
         </p:nvSpPr>
         <p:spPr>
           <a:xfrm>
-            <a:off x="868680" y="1828800"/>
-            <a:ext cx="2240280" cy="4023360"/>
+            <a:off x="868680" y="1737360"/>
+            <a:ext cx="2240280" cy="4206240"/>
           </a:xfrm>
           <a:prstGeom prst="rect">
             <a:avLst/>
@@ -6342,7 +6705,7 @@
             <a:pPr>
               <a:defRPr sz="2600" b="1">
                 <a:solidFill>
-                  <a:srgbClr val="F9FAFB"/>
+                  <a:srgbClr val="F8FAFC"/>
                 </a:solidFill>
               </a:defRPr>
             </a:pPr>
@@ -6355,7 +6718,7 @@
             <a:pPr>
               <a:defRPr sz="1300">
                 <a:solidFill>
-                  <a:srgbClr val="9CA3AF"/>
+                  <a:srgbClr val="94A3B8"/>
                 </a:solidFill>
               </a:defRPr>
             </a:pPr>
@@ -6379,20 +6742,20 @@
       </p:sp>
       <p:sp>
         <p:nvSpPr>
-          <p:cNvPr id="6" name="Rounded Rectangle 5"/>
+          <p:cNvPr id="7" name="Rounded Rectangle 6"/>
           <p:cNvSpPr/>
           <p:nvPr/>
         </p:nvSpPr>
         <p:spPr>
           <a:xfrm>
-            <a:off x="3429000" y="1645920"/>
-            <a:ext cx="2514600" cy="4389120"/>
+            <a:off x="3429000" y="1554480"/>
+            <a:ext cx="2514600" cy="4572000"/>
           </a:xfrm>
           <a:prstGeom prst="roundRect">
             <a:avLst/>
           </a:prstGeom>
           <a:solidFill>
-            <a:srgbClr val="111827"/>
+            <a:srgbClr val="0F172A"/>
           </a:solidFill>
           <a:ln w="25400">
             <a:solidFill>
@@ -6424,14 +6787,14 @@
       </p:sp>
       <p:sp>
         <p:nvSpPr>
-          <p:cNvPr id="7" name="TextBox 6"/>
+          <p:cNvPr id="8" name="TextBox 7"/>
           <p:cNvSpPr txBox="1"/>
           <p:nvPr/>
         </p:nvSpPr>
         <p:spPr>
           <a:xfrm>
-            <a:off x="3566160" y="1828800"/>
-            <a:ext cx="2240280" cy="4023360"/>
+            <a:off x="3566160" y="1737360"/>
+            <a:ext cx="2240280" cy="4206240"/>
           </a:xfrm>
           <a:prstGeom prst="rect">
             <a:avLst/>
@@ -6459,7 +6822,7 @@
             <a:pPr>
               <a:defRPr sz="2600" b="1">
                 <a:solidFill>
-                  <a:srgbClr val="F9FAFB"/>
+                  <a:srgbClr val="F8FAFC"/>
                 </a:solidFill>
               </a:defRPr>
             </a:pPr>
@@ -6472,7 +6835,7 @@
             <a:pPr>
               <a:defRPr sz="1300">
                 <a:solidFill>
-                  <a:srgbClr val="9CA3AF"/>
+                  <a:srgbClr val="94A3B8"/>
                 </a:solidFill>
               </a:defRPr>
             </a:pPr>
@@ -6496,20 +6859,20 @@
       </p:sp>
       <p:sp>
         <p:nvSpPr>
-          <p:cNvPr id="8" name="Rounded Rectangle 7"/>
+          <p:cNvPr id="9" name="Rounded Rectangle 8"/>
           <p:cNvSpPr/>
           <p:nvPr/>
         </p:nvSpPr>
         <p:spPr>
           <a:xfrm>
-            <a:off x="6126480" y="1645920"/>
-            <a:ext cx="2514600" cy="4389120"/>
+            <a:off x="6126480" y="1554480"/>
+            <a:ext cx="2514600" cy="4572000"/>
           </a:xfrm>
           <a:prstGeom prst="roundRect">
             <a:avLst/>
           </a:prstGeom>
           <a:solidFill>
-            <a:srgbClr val="111827"/>
+            <a:srgbClr val="0F172A"/>
           </a:solidFill>
           <a:ln w="25400">
             <a:solidFill>
@@ -6541,14 +6904,14 @@
       </p:sp>
       <p:sp>
         <p:nvSpPr>
-          <p:cNvPr id="9" name="TextBox 8"/>
+          <p:cNvPr id="10" name="TextBox 9"/>
           <p:cNvSpPr txBox="1"/>
           <p:nvPr/>
         </p:nvSpPr>
         <p:spPr>
           <a:xfrm>
-            <a:off x="6263640" y="1828800"/>
-            <a:ext cx="2240280" cy="4023360"/>
+            <a:off x="6263640" y="1737360"/>
+            <a:ext cx="2240280" cy="4206240"/>
           </a:xfrm>
           <a:prstGeom prst="rect">
             <a:avLst/>
@@ -6576,7 +6939,7 @@
             <a:pPr>
               <a:defRPr sz="2600" b="1">
                 <a:solidFill>
-                  <a:srgbClr val="F9FAFB"/>
+                  <a:srgbClr val="F8FAFC"/>
                 </a:solidFill>
               </a:defRPr>
             </a:pPr>
@@ -6589,7 +6952,7 @@
             <a:pPr>
               <a:defRPr sz="1300">
                 <a:solidFill>
-                  <a:srgbClr val="9CA3AF"/>
+                  <a:srgbClr val="94A3B8"/>
                 </a:solidFill>
               </a:defRPr>
             </a:pPr>
@@ -6613,24 +6976,24 @@
       </p:sp>
       <p:sp>
         <p:nvSpPr>
-          <p:cNvPr id="10" name="Rounded Rectangle 9"/>
+          <p:cNvPr id="11" name="Rounded Rectangle 10"/>
           <p:cNvSpPr/>
           <p:nvPr/>
         </p:nvSpPr>
         <p:spPr>
           <a:xfrm>
-            <a:off x="8823960" y="1645920"/>
-            <a:ext cx="2514600" cy="4389120"/>
+            <a:off x="8823960" y="1554480"/>
+            <a:ext cx="2514600" cy="4572000"/>
           </a:xfrm>
           <a:prstGeom prst="roundRect">
             <a:avLst/>
           </a:prstGeom>
           <a:solidFill>
-            <a:srgbClr val="111827"/>
+            <a:srgbClr val="0F172A"/>
           </a:solidFill>
           <a:ln w="25400">
             <a:solidFill>
-              <a:srgbClr val="00F0FF"/>
+              <a:srgbClr val="06B6D4"/>
             </a:solidFill>
           </a:ln>
         </p:spPr>
@@ -6658,14 +7021,14 @@
       </p:sp>
       <p:sp>
         <p:nvSpPr>
-          <p:cNvPr id="11" name="TextBox 10"/>
+          <p:cNvPr id="12" name="TextBox 11"/>
           <p:cNvSpPr txBox="1"/>
           <p:nvPr/>
         </p:nvSpPr>
         <p:spPr>
           <a:xfrm>
-            <a:off x="8961120" y="1828800"/>
-            <a:ext cx="2240280" cy="4023360"/>
+            <a:off x="8961120" y="1737360"/>
+            <a:ext cx="2240280" cy="4206240"/>
           </a:xfrm>
           <a:prstGeom prst="rect">
             <a:avLst/>
@@ -6681,7 +7044,7 @@
             <a:pPr>
               <a:defRPr sz="2200" b="1">
                 <a:solidFill>
-                  <a:srgbClr val="00F0FF"/>
+                  <a:srgbClr val="06B6D4"/>
                 </a:solidFill>
               </a:defRPr>
             </a:pPr>
@@ -6693,7 +7056,7 @@
             <a:pPr>
               <a:defRPr sz="2600" b="1">
                 <a:solidFill>
-                  <a:srgbClr val="F9FAFB"/>
+                  <a:srgbClr val="F8FAFC"/>
                 </a:solidFill>
               </a:defRPr>
             </a:pPr>
@@ -6706,7 +7069,7 @@
             <a:pPr>
               <a:defRPr sz="1300">
                 <a:solidFill>
-                  <a:srgbClr val="9CA3AF"/>
+                  <a:srgbClr val="94A3B8"/>
                 </a:solidFill>
               </a:defRPr>
             </a:pPr>
@@ -6742,7 +7105,7 @@
     <p:bg>
       <p:bgPr>
         <a:solidFill>
-          <a:srgbClr val="0B0F19"/>
+          <a:srgbClr val="080C16"/>
         </a:solidFill>
         <a:effectLst/>
       </p:bgPr>
@@ -6779,7 +7142,7 @@
             <a:pPr>
               <a:defRPr sz="1000" b="1">
                 <a:solidFill>
-                  <a:srgbClr val="00F0FF"/>
+                  <a:srgbClr val="06B6D4"/>
                 </a:solidFill>
               </a:defRPr>
             </a:pPr>
@@ -6814,7 +7177,7 @@
             <a:pPr>
               <a:defRPr sz="2600" b="1">
                 <a:solidFill>
-                  <a:srgbClr val="F9FAFB"/>
+                  <a:srgbClr val="F8FAFC"/>
                 </a:solidFill>
               </a:defRPr>
             </a:pPr>
@@ -6826,20 +7189,55 @@
       </p:sp>
       <p:sp>
         <p:nvSpPr>
-          <p:cNvPr id="4" name="Rounded Rectangle 3"/>
+          <p:cNvPr id="4" name="TextBox 3"/>
+          <p:cNvSpPr txBox="1"/>
+          <p:nvPr/>
+        </p:nvSpPr>
+        <p:spPr>
+          <a:xfrm>
+            <a:off x="731520" y="6400800"/>
+            <a:ext cx="10725912" cy="320040"/>
+          </a:xfrm>
+          <a:prstGeom prst="rect">
+            <a:avLst/>
+          </a:prstGeom>
+          <a:noFill/>
+        </p:spPr>
+        <p:txBody>
+          <a:bodyPr wrap="none">
+            <a:spAutoFit/>
+          </a:bodyPr>
+          <a:lstStyle/>
+          <a:p>
+            <a:pPr>
+              <a:defRPr sz="900">
+                <a:solidFill>
+                  <a:srgbClr val="94A3B8"/>
+                </a:solidFill>
+              </a:defRPr>
+            </a:pPr>
+            <a:r>
+              <a:t>EvalMesh | AI Gateway for Secure &amp; Reliable Agent Deployment   •   Slide 9 of 10</a:t>
+            </a:r>
+          </a:p>
+        </p:txBody>
+      </p:sp>
+      <p:sp>
+        <p:nvSpPr>
+          <p:cNvPr id="5" name="Rounded Rectangle 4"/>
           <p:cNvSpPr/>
           <p:nvPr/>
         </p:nvSpPr>
         <p:spPr>
           <a:xfrm>
-            <a:off x="731520" y="1645920"/>
-            <a:ext cx="10725912" cy="4389120"/>
+            <a:off x="731520" y="1554480"/>
+            <a:ext cx="10725912" cy="4572000"/>
           </a:xfrm>
           <a:prstGeom prst="roundRect">
             <a:avLst/>
           </a:prstGeom>
           <a:solidFill>
-            <a:srgbClr val="111827"/>
+            <a:srgbClr val="0F172A"/>
           </a:solidFill>
           <a:ln>
             <a:solidFill>
@@ -6871,14 +7269,14 @@
       </p:sp>
       <p:sp>
         <p:nvSpPr>
-          <p:cNvPr id="5" name="TextBox 4"/>
+          <p:cNvPr id="6" name="TextBox 5"/>
           <p:cNvSpPr txBox="1"/>
           <p:nvPr/>
         </p:nvSpPr>
         <p:spPr>
           <a:xfrm>
-            <a:off x="1005840" y="1828800"/>
-            <a:ext cx="10149840" cy="4023360"/>
+            <a:off x="1005840" y="1737360"/>
+            <a:ext cx="10149840" cy="4206240"/>
           </a:xfrm>
           <a:prstGeom prst="rect">
             <a:avLst/>
@@ -6907,7 +7305,7 @@
             <a:pPr>
               <a:defRPr sz="1500">
                 <a:solidFill>
-                  <a:srgbClr val="F9FAFB"/>
+                  <a:srgbClr val="F8FAFC"/>
                 </a:solidFill>
               </a:defRPr>
             </a:pPr>

</xml_diff>

<commit_message>
Enforce high-contrast text styling across all slides for system dark theme compatibility
</commit_message>
<xml_diff>
--- a/EvalMesh_Investor_Pitch_Deck.pptx
+++ b/EvalMesh_Investor_Pitch_Deck.pptx
@@ -3093,7 +3093,7 @@
     <p:bg>
       <p:bgPr>
         <a:solidFill>
-          <a:srgbClr val="080C16"/>
+          <a:srgbClr val="0B0F19"/>
         </a:solidFill>
         <a:effectLst/>
       </p:bgPr>
@@ -3120,11 +3120,11 @@
             <a:avLst/>
           </a:prstGeom>
           <a:solidFill>
-            <a:srgbClr val="0F172A"/>
+            <a:srgbClr val="111827"/>
           </a:solidFill>
           <a:ln w="25400">
             <a:solidFill>
-              <a:srgbClr val="3B82F6"/>
+              <a:srgbClr val="60A5FA"/>
             </a:solidFill>
           </a:ln>
         </p:spPr>
@@ -3175,7 +3175,7 @@
             <a:pPr>
               <a:defRPr sz="1100" b="1">
                 <a:solidFill>
-                  <a:srgbClr val="06B6D4"/>
+                  <a:srgbClr val="00F0FF"/>
                 </a:solidFill>
               </a:defRPr>
             </a:pPr>
@@ -3187,7 +3187,7 @@
             <a:pPr>
               <a:defRPr sz="5400" b="1">
                 <a:solidFill>
-                  <a:srgbClr val="F8FAFC"/>
+                  <a:srgbClr val="FFFFFF"/>
                 </a:solidFill>
               </a:defRPr>
             </a:pPr>
@@ -3199,7 +3199,7 @@
             <a:pPr>
               <a:defRPr sz="2400" b="1">
                 <a:solidFill>
-                  <a:srgbClr val="3B82F6"/>
+                  <a:srgbClr val="60A5FA"/>
                 </a:solidFill>
               </a:defRPr>
             </a:pPr>
@@ -3212,7 +3212,7 @@
             <a:pPr>
               <a:defRPr sz="1600">
                 <a:solidFill>
-                  <a:srgbClr val="94A3B8"/>
+                  <a:srgbClr val="CBD5E1"/>
                 </a:solidFill>
               </a:defRPr>
             </a:pPr>
@@ -3225,7 +3225,7 @@
             <a:pPr>
               <a:defRPr sz="1200">
                 <a:solidFill>
-                  <a:srgbClr val="06B6D4"/>
+                  <a:srgbClr val="00F0FF"/>
                 </a:solidFill>
               </a:defRPr>
             </a:pPr>
@@ -3249,7 +3249,7 @@
     <p:bg>
       <p:bgPr>
         <a:solidFill>
-          <a:srgbClr val="080C16"/>
+          <a:srgbClr val="0B0F19"/>
         </a:solidFill>
         <a:effectLst/>
       </p:bgPr>
@@ -3286,7 +3286,7 @@
             <a:pPr>
               <a:defRPr sz="1000" b="1">
                 <a:solidFill>
-                  <a:srgbClr val="06B6D4"/>
+                  <a:srgbClr val="00F0FF"/>
                 </a:solidFill>
               </a:defRPr>
             </a:pPr>
@@ -3321,7 +3321,7 @@
             <a:pPr>
               <a:defRPr sz="2600" b="1">
                 <a:solidFill>
-                  <a:srgbClr val="F8FAFC"/>
+                  <a:srgbClr val="FFFFFF"/>
                 </a:solidFill>
               </a:defRPr>
             </a:pPr>
@@ -3356,7 +3356,7 @@
             <a:pPr>
               <a:defRPr sz="900">
                 <a:solidFill>
-                  <a:srgbClr val="94A3B8"/>
+                  <a:srgbClr val="CBD5E1"/>
                 </a:solidFill>
               </a:defRPr>
             </a:pPr>
@@ -3381,11 +3381,11 @@
             <a:avLst/>
           </a:prstGeom>
           <a:solidFill>
-            <a:srgbClr val="0F172A"/>
+            <a:srgbClr val="111827"/>
           </a:solidFill>
           <a:ln w="25400">
             <a:solidFill>
-              <a:srgbClr val="06B6D4"/>
+              <a:srgbClr val="00F0FF"/>
             </a:solidFill>
           </a:ln>
         </p:spPr>
@@ -3436,7 +3436,7 @@
             <a:pPr>
               <a:defRPr sz="4000" b="1">
                 <a:solidFill>
-                  <a:srgbClr val="F8FAFC"/>
+                  <a:srgbClr val="FFFFFF"/>
                 </a:solidFill>
               </a:defRPr>
             </a:pPr>
@@ -3448,7 +3448,7 @@
             <a:pPr>
               <a:defRPr sz="2200" b="1">
                 <a:solidFill>
-                  <a:srgbClr val="06B6D4"/>
+                  <a:srgbClr val="00F0FF"/>
                 </a:solidFill>
               </a:defRPr>
             </a:pPr>
@@ -3461,7 +3461,7 @@
             <a:pPr>
               <a:defRPr sz="1600">
                 <a:solidFill>
-                  <a:srgbClr val="94A3B8"/>
+                  <a:srgbClr val="CBD5E1"/>
                 </a:solidFill>
               </a:defRPr>
             </a:pPr>
@@ -3493,7 +3493,7 @@
     <p:bg>
       <p:bgPr>
         <a:solidFill>
-          <a:srgbClr val="080C16"/>
+          <a:srgbClr val="0B0F19"/>
         </a:solidFill>
         <a:effectLst/>
       </p:bgPr>
@@ -3530,7 +3530,7 @@
             <a:pPr>
               <a:defRPr sz="1000" b="1">
                 <a:solidFill>
-                  <a:srgbClr val="06B6D4"/>
+                  <a:srgbClr val="00F0FF"/>
                 </a:solidFill>
               </a:defRPr>
             </a:pPr>
@@ -3565,7 +3565,7 @@
             <a:pPr>
               <a:defRPr sz="2600" b="1">
                 <a:solidFill>
-                  <a:srgbClr val="F8FAFC"/>
+                  <a:srgbClr val="FFFFFF"/>
                 </a:solidFill>
               </a:defRPr>
             </a:pPr>
@@ -3600,7 +3600,7 @@
             <a:pPr>
               <a:defRPr sz="900">
                 <a:solidFill>
-                  <a:srgbClr val="94A3B8"/>
+                  <a:srgbClr val="CBD5E1"/>
                 </a:solidFill>
               </a:defRPr>
             </a:pPr>
@@ -3625,11 +3625,11 @@
             <a:avLst/>
           </a:prstGeom>
           <a:solidFill>
-            <a:srgbClr val="0F172A"/>
+            <a:srgbClr val="111827"/>
           </a:solidFill>
           <a:ln w="19050">
             <a:solidFill>
-              <a:srgbClr val="EF4444"/>
+              <a:srgbClr val="F87171"/>
             </a:solidFill>
           </a:ln>
         </p:spPr>
@@ -3680,7 +3680,7 @@
             <a:pPr>
               <a:defRPr sz="1800" b="1">
                 <a:solidFill>
-                  <a:srgbClr val="EF4444"/>
+                  <a:srgbClr val="F87171"/>
                 </a:solidFill>
               </a:defRPr>
             </a:pPr>
@@ -3693,7 +3693,7 @@
             <a:pPr>
               <a:defRPr sz="1500" b="1">
                 <a:solidFill>
-                  <a:srgbClr val="F8FAFC"/>
+                  <a:srgbClr val="FFFFFF"/>
                 </a:solidFill>
               </a:defRPr>
             </a:pPr>
@@ -3706,7 +3706,7 @@
             <a:pPr>
               <a:defRPr sz="1300">
                 <a:solidFill>
-                  <a:srgbClr val="94A3B8"/>
+                  <a:srgbClr val="CBD5E1"/>
                 </a:solidFill>
               </a:defRPr>
             </a:pPr>
@@ -3731,11 +3731,11 @@
             <a:avLst/>
           </a:prstGeom>
           <a:solidFill>
-            <a:srgbClr val="0F172A"/>
+            <a:srgbClr val="111827"/>
           </a:solidFill>
           <a:ln w="19050">
             <a:solidFill>
-              <a:srgbClr val="EF4444"/>
+              <a:srgbClr val="F87171"/>
             </a:solidFill>
           </a:ln>
         </p:spPr>
@@ -3786,7 +3786,7 @@
             <a:pPr>
               <a:defRPr sz="1800" b="1">
                 <a:solidFill>
-                  <a:srgbClr val="EF4444"/>
+                  <a:srgbClr val="F87171"/>
                 </a:solidFill>
               </a:defRPr>
             </a:pPr>
@@ -3799,7 +3799,7 @@
             <a:pPr>
               <a:defRPr sz="1500" b="1">
                 <a:solidFill>
-                  <a:srgbClr val="F8FAFC"/>
+                  <a:srgbClr val="FFFFFF"/>
                 </a:solidFill>
               </a:defRPr>
             </a:pPr>
@@ -3812,7 +3812,7 @@
             <a:pPr>
               <a:defRPr sz="1300">
                 <a:solidFill>
-                  <a:srgbClr val="94A3B8"/>
+                  <a:srgbClr val="CBD5E1"/>
                 </a:solidFill>
               </a:defRPr>
             </a:pPr>
@@ -3837,11 +3837,11 @@
             <a:avLst/>
           </a:prstGeom>
           <a:solidFill>
-            <a:srgbClr val="0F172A"/>
+            <a:srgbClr val="111827"/>
           </a:solidFill>
           <a:ln w="19050">
             <a:solidFill>
-              <a:srgbClr val="EF4444"/>
+              <a:srgbClr val="F87171"/>
             </a:solidFill>
           </a:ln>
         </p:spPr>
@@ -3892,7 +3892,7 @@
             <a:pPr>
               <a:defRPr sz="1800" b="1">
                 <a:solidFill>
-                  <a:srgbClr val="EF4444"/>
+                  <a:srgbClr val="F87171"/>
                 </a:solidFill>
               </a:defRPr>
             </a:pPr>
@@ -3905,7 +3905,7 @@
             <a:pPr>
               <a:defRPr sz="1500" b="1">
                 <a:solidFill>
-                  <a:srgbClr val="F8FAFC"/>
+                  <a:srgbClr val="FFFFFF"/>
                 </a:solidFill>
               </a:defRPr>
             </a:pPr>
@@ -3918,7 +3918,7 @@
             <a:pPr>
               <a:defRPr sz="1300">
                 <a:solidFill>
-                  <a:srgbClr val="94A3B8"/>
+                  <a:srgbClr val="CBD5E1"/>
                 </a:solidFill>
               </a:defRPr>
             </a:pPr>
@@ -3942,7 +3942,7 @@
     <p:bg>
       <p:bgPr>
         <a:solidFill>
-          <a:srgbClr val="080C16"/>
+          <a:srgbClr val="0B0F19"/>
         </a:solidFill>
         <a:effectLst/>
       </p:bgPr>
@@ -3979,7 +3979,7 @@
             <a:pPr>
               <a:defRPr sz="1000" b="1">
                 <a:solidFill>
-                  <a:srgbClr val="06B6D4"/>
+                  <a:srgbClr val="00F0FF"/>
                 </a:solidFill>
               </a:defRPr>
             </a:pPr>
@@ -4014,7 +4014,7 @@
             <a:pPr>
               <a:defRPr sz="2600" b="1">
                 <a:solidFill>
-                  <a:srgbClr val="F8FAFC"/>
+                  <a:srgbClr val="FFFFFF"/>
                 </a:solidFill>
               </a:defRPr>
             </a:pPr>
@@ -4049,7 +4049,7 @@
             <a:pPr>
               <a:defRPr sz="900">
                 <a:solidFill>
-                  <a:srgbClr val="94A3B8"/>
+                  <a:srgbClr val="CBD5E1"/>
                 </a:solidFill>
               </a:defRPr>
             </a:pPr>
@@ -4074,11 +4074,11 @@
             <a:avLst/>
           </a:prstGeom>
           <a:solidFill>
-            <a:srgbClr val="0F172A"/>
+            <a:srgbClr val="111827"/>
           </a:solidFill>
           <a:ln w="19050">
             <a:solidFill>
-              <a:srgbClr val="10B981"/>
+              <a:srgbClr val="34D399"/>
             </a:solidFill>
           </a:ln>
         </p:spPr>
@@ -4129,7 +4129,7 @@
             <a:pPr>
               <a:defRPr sz="1800" b="1">
                 <a:solidFill>
-                  <a:srgbClr val="10B981"/>
+                  <a:srgbClr val="34D399"/>
                 </a:solidFill>
               </a:defRPr>
             </a:pPr>
@@ -4142,7 +4142,7 @@
             <a:pPr>
               <a:defRPr sz="1500" b="1">
                 <a:solidFill>
-                  <a:srgbClr val="F8FAFC"/>
+                  <a:srgbClr val="FFFFFF"/>
                 </a:solidFill>
               </a:defRPr>
             </a:pPr>
@@ -4155,7 +4155,7 @@
             <a:pPr>
               <a:defRPr sz="1300">
                 <a:solidFill>
-                  <a:srgbClr val="94A3B8"/>
+                  <a:srgbClr val="CBD5E1"/>
                 </a:solidFill>
               </a:defRPr>
             </a:pPr>
@@ -4180,11 +4180,11 @@
             <a:avLst/>
           </a:prstGeom>
           <a:solidFill>
-            <a:srgbClr val="0F172A"/>
+            <a:srgbClr val="111827"/>
           </a:solidFill>
           <a:ln w="19050">
             <a:solidFill>
-              <a:srgbClr val="10B981"/>
+              <a:srgbClr val="34D399"/>
             </a:solidFill>
           </a:ln>
         </p:spPr>
@@ -4235,7 +4235,7 @@
             <a:pPr>
               <a:defRPr sz="1800" b="1">
                 <a:solidFill>
-                  <a:srgbClr val="10B981"/>
+                  <a:srgbClr val="34D399"/>
                 </a:solidFill>
               </a:defRPr>
             </a:pPr>
@@ -4248,7 +4248,7 @@
             <a:pPr>
               <a:defRPr sz="1500" b="1">
                 <a:solidFill>
-                  <a:srgbClr val="F8FAFC"/>
+                  <a:srgbClr val="FFFFFF"/>
                 </a:solidFill>
               </a:defRPr>
             </a:pPr>
@@ -4261,7 +4261,7 @@
             <a:pPr>
               <a:defRPr sz="1300">
                 <a:solidFill>
-                  <a:srgbClr val="94A3B8"/>
+                  <a:srgbClr val="CBD5E1"/>
                 </a:solidFill>
               </a:defRPr>
             </a:pPr>
@@ -4286,11 +4286,11 @@
             <a:avLst/>
           </a:prstGeom>
           <a:solidFill>
-            <a:srgbClr val="0F172A"/>
+            <a:srgbClr val="111827"/>
           </a:solidFill>
           <a:ln w="19050">
             <a:solidFill>
-              <a:srgbClr val="10B981"/>
+              <a:srgbClr val="34D399"/>
             </a:solidFill>
           </a:ln>
         </p:spPr>
@@ -4341,7 +4341,7 @@
             <a:pPr>
               <a:defRPr sz="1800" b="1">
                 <a:solidFill>
-                  <a:srgbClr val="10B981"/>
+                  <a:srgbClr val="34D399"/>
                 </a:solidFill>
               </a:defRPr>
             </a:pPr>
@@ -4354,7 +4354,7 @@
             <a:pPr>
               <a:defRPr sz="1500" b="1">
                 <a:solidFill>
-                  <a:srgbClr val="F8FAFC"/>
+                  <a:srgbClr val="FFFFFF"/>
                 </a:solidFill>
               </a:defRPr>
             </a:pPr>
@@ -4367,7 +4367,7 @@
             <a:pPr>
               <a:defRPr sz="1300">
                 <a:solidFill>
-                  <a:srgbClr val="94A3B8"/>
+                  <a:srgbClr val="CBD5E1"/>
                 </a:solidFill>
               </a:defRPr>
             </a:pPr>
@@ -4391,7 +4391,7 @@
     <p:bg>
       <p:bgPr>
         <a:solidFill>
-          <a:srgbClr val="080C16"/>
+          <a:srgbClr val="0B0F19"/>
         </a:solidFill>
         <a:effectLst/>
       </p:bgPr>
@@ -4428,7 +4428,7 @@
             <a:pPr>
               <a:defRPr sz="1000" b="1">
                 <a:solidFill>
-                  <a:srgbClr val="06B6D4"/>
+                  <a:srgbClr val="00F0FF"/>
                 </a:solidFill>
               </a:defRPr>
             </a:pPr>
@@ -4463,7 +4463,7 @@
             <a:pPr>
               <a:defRPr sz="2600" b="1">
                 <a:solidFill>
-                  <a:srgbClr val="F8FAFC"/>
+                  <a:srgbClr val="FFFFFF"/>
                 </a:solidFill>
               </a:defRPr>
             </a:pPr>
@@ -4498,7 +4498,7 @@
             <a:pPr>
               <a:defRPr sz="900">
                 <a:solidFill>
-                  <a:srgbClr val="94A3B8"/>
+                  <a:srgbClr val="CBD5E1"/>
                 </a:solidFill>
               </a:defRPr>
             </a:pPr>
@@ -4523,11 +4523,11 @@
             <a:avLst/>
           </a:prstGeom>
           <a:solidFill>
-            <a:srgbClr val="0F172A"/>
+            <a:srgbClr val="111827"/>
           </a:solidFill>
           <a:ln>
             <a:solidFill>
-              <a:srgbClr val="3B82F6"/>
+              <a:srgbClr val="60A5FA"/>
             </a:solidFill>
           </a:ln>
         </p:spPr>
@@ -4578,7 +4578,7 @@
             <a:pPr>
               <a:defRPr sz="1600" b="1">
                 <a:solidFill>
-                  <a:srgbClr val="06B6D4"/>
+                  <a:srgbClr val="00F0FF"/>
                 </a:solidFill>
               </a:defRPr>
             </a:pPr>
@@ -4590,7 +4590,7 @@
             <a:pPr>
               <a:defRPr sz="1400">
                 <a:solidFill>
-                  <a:srgbClr val="F8FAFC"/>
+                  <a:srgbClr val="FFFFFF"/>
                 </a:solidFill>
                 <a:latin typeface="JetBrains Mono"/>
               </a:defRPr>
@@ -4659,7 +4659,7 @@
     <p:bg>
       <p:bgPr>
         <a:solidFill>
-          <a:srgbClr val="080C16"/>
+          <a:srgbClr val="0B0F19"/>
         </a:solidFill>
         <a:effectLst/>
       </p:bgPr>
@@ -4696,7 +4696,7 @@
             <a:pPr>
               <a:defRPr sz="1000" b="1">
                 <a:solidFill>
-                  <a:srgbClr val="06B6D4"/>
+                  <a:srgbClr val="00F0FF"/>
                 </a:solidFill>
               </a:defRPr>
             </a:pPr>
@@ -4731,7 +4731,7 @@
             <a:pPr>
               <a:defRPr sz="2600" b="1">
                 <a:solidFill>
-                  <a:srgbClr val="F8FAFC"/>
+                  <a:srgbClr val="FFFFFF"/>
                 </a:solidFill>
               </a:defRPr>
             </a:pPr>
@@ -4766,7 +4766,7 @@
             <a:pPr>
               <a:defRPr sz="900">
                 <a:solidFill>
-                  <a:srgbClr val="94A3B8"/>
+                  <a:srgbClr val="CBD5E1"/>
                 </a:solidFill>
               </a:defRPr>
             </a:pPr>
@@ -4791,11 +4791,11 @@
             <a:avLst/>
           </a:prstGeom>
           <a:solidFill>
-            <a:srgbClr val="0F172A"/>
+            <a:srgbClr val="111827"/>
           </a:solidFill>
           <a:ln>
             <a:solidFill>
-              <a:srgbClr val="3B82F6"/>
+              <a:srgbClr val="60A5FA"/>
             </a:solidFill>
           </a:ln>
         </p:spPr>
@@ -4846,7 +4846,7 @@
             <a:pPr>
               <a:defRPr sz="1600" b="1">
                 <a:solidFill>
-                  <a:srgbClr val="F8FAFC"/>
+                  <a:srgbClr val="FFFFFF"/>
                 </a:solidFill>
               </a:defRPr>
             </a:pPr>
@@ -4858,7 +4858,7 @@
             <a:pPr>
               <a:defRPr sz="1200">
                 <a:solidFill>
-                  <a:srgbClr val="94A3B8"/>
+                  <a:srgbClr val="CBD5E1"/>
                 </a:solidFill>
               </a:defRPr>
             </a:pPr>
@@ -4883,11 +4883,11 @@
             <a:avLst/>
           </a:prstGeom>
           <a:solidFill>
-            <a:srgbClr val="0F172A"/>
+            <a:srgbClr val="111827"/>
           </a:solidFill>
           <a:ln>
             <a:solidFill>
-              <a:srgbClr val="3B82F6"/>
+              <a:srgbClr val="60A5FA"/>
             </a:solidFill>
           </a:ln>
         </p:spPr>
@@ -4938,7 +4938,7 @@
             <a:pPr>
               <a:defRPr sz="1600" b="1">
                 <a:solidFill>
-                  <a:srgbClr val="F8FAFC"/>
+                  <a:srgbClr val="FFFFFF"/>
                 </a:solidFill>
               </a:defRPr>
             </a:pPr>
@@ -4950,7 +4950,7 @@
             <a:pPr>
               <a:defRPr sz="1200">
                 <a:solidFill>
-                  <a:srgbClr val="94A3B8"/>
+                  <a:srgbClr val="CBD5E1"/>
                 </a:solidFill>
               </a:defRPr>
             </a:pPr>
@@ -4975,11 +4975,11 @@
             <a:avLst/>
           </a:prstGeom>
           <a:solidFill>
-            <a:srgbClr val="0F172A"/>
+            <a:srgbClr val="111827"/>
           </a:solidFill>
           <a:ln>
             <a:solidFill>
-              <a:srgbClr val="3B82F6"/>
+              <a:srgbClr val="60A5FA"/>
             </a:solidFill>
           </a:ln>
         </p:spPr>
@@ -5030,7 +5030,7 @@
             <a:pPr>
               <a:defRPr sz="1600" b="1">
                 <a:solidFill>
-                  <a:srgbClr val="F8FAFC"/>
+                  <a:srgbClr val="FFFFFF"/>
                 </a:solidFill>
               </a:defRPr>
             </a:pPr>
@@ -5042,7 +5042,7 @@
             <a:pPr>
               <a:defRPr sz="1200">
                 <a:solidFill>
-                  <a:srgbClr val="94A3B8"/>
+                  <a:srgbClr val="CBD5E1"/>
                 </a:solidFill>
               </a:defRPr>
             </a:pPr>
@@ -5067,11 +5067,11 @@
             <a:avLst/>
           </a:prstGeom>
           <a:solidFill>
-            <a:srgbClr val="0F172A"/>
+            <a:srgbClr val="111827"/>
           </a:solidFill>
           <a:ln>
             <a:solidFill>
-              <a:srgbClr val="3B82F6"/>
+              <a:srgbClr val="60A5FA"/>
             </a:solidFill>
           </a:ln>
         </p:spPr>
@@ -5122,7 +5122,7 @@
             <a:pPr>
               <a:defRPr sz="1600" b="1">
                 <a:solidFill>
-                  <a:srgbClr val="F8FAFC"/>
+                  <a:srgbClr val="FFFFFF"/>
                 </a:solidFill>
               </a:defRPr>
             </a:pPr>
@@ -5134,7 +5134,7 @@
             <a:pPr>
               <a:defRPr sz="1200">
                 <a:solidFill>
-                  <a:srgbClr val="94A3B8"/>
+                  <a:srgbClr val="CBD5E1"/>
                 </a:solidFill>
               </a:defRPr>
             </a:pPr>
@@ -5159,11 +5159,11 @@
             <a:avLst/>
           </a:prstGeom>
           <a:solidFill>
-            <a:srgbClr val="0F172A"/>
+            <a:srgbClr val="111827"/>
           </a:solidFill>
           <a:ln>
             <a:solidFill>
-              <a:srgbClr val="3B82F6"/>
+              <a:srgbClr val="60A5FA"/>
             </a:solidFill>
           </a:ln>
         </p:spPr>
@@ -5214,7 +5214,7 @@
             <a:pPr>
               <a:defRPr sz="1600" b="1">
                 <a:solidFill>
-                  <a:srgbClr val="F8FAFC"/>
+                  <a:srgbClr val="FFFFFF"/>
                 </a:solidFill>
               </a:defRPr>
             </a:pPr>
@@ -5226,7 +5226,7 @@
             <a:pPr>
               <a:defRPr sz="1200">
                 <a:solidFill>
-                  <a:srgbClr val="94A3B8"/>
+                  <a:srgbClr val="CBD5E1"/>
                 </a:solidFill>
               </a:defRPr>
             </a:pPr>
@@ -5251,11 +5251,11 @@
             <a:avLst/>
           </a:prstGeom>
           <a:solidFill>
-            <a:srgbClr val="0F172A"/>
+            <a:srgbClr val="111827"/>
           </a:solidFill>
           <a:ln>
             <a:solidFill>
-              <a:srgbClr val="3B82F6"/>
+              <a:srgbClr val="60A5FA"/>
             </a:solidFill>
           </a:ln>
         </p:spPr>
@@ -5306,7 +5306,7 @@
             <a:pPr>
               <a:defRPr sz="1600" b="1">
                 <a:solidFill>
-                  <a:srgbClr val="F8FAFC"/>
+                  <a:srgbClr val="FFFFFF"/>
                 </a:solidFill>
               </a:defRPr>
             </a:pPr>
@@ -5318,7 +5318,7 @@
             <a:pPr>
               <a:defRPr sz="1200">
                 <a:solidFill>
-                  <a:srgbClr val="94A3B8"/>
+                  <a:srgbClr val="CBD5E1"/>
                 </a:solidFill>
               </a:defRPr>
             </a:pPr>
@@ -5343,11 +5343,11 @@
             <a:avLst/>
           </a:prstGeom>
           <a:solidFill>
-            <a:srgbClr val="0F172A"/>
+            <a:srgbClr val="111827"/>
           </a:solidFill>
           <a:ln>
             <a:solidFill>
-              <a:srgbClr val="3B82F6"/>
+              <a:srgbClr val="60A5FA"/>
             </a:solidFill>
           </a:ln>
         </p:spPr>
@@ -5398,7 +5398,7 @@
             <a:pPr>
               <a:defRPr sz="1600" b="1">
                 <a:solidFill>
-                  <a:srgbClr val="F8FAFC"/>
+                  <a:srgbClr val="FFFFFF"/>
                 </a:solidFill>
               </a:defRPr>
             </a:pPr>
@@ -5410,7 +5410,7 @@
             <a:pPr>
               <a:defRPr sz="1200">
                 <a:solidFill>
-                  <a:srgbClr val="94A3B8"/>
+                  <a:srgbClr val="CBD5E1"/>
                 </a:solidFill>
               </a:defRPr>
             </a:pPr>
@@ -5435,11 +5435,11 @@
             <a:avLst/>
           </a:prstGeom>
           <a:solidFill>
-            <a:srgbClr val="0F172A"/>
+            <a:srgbClr val="111827"/>
           </a:solidFill>
           <a:ln>
             <a:solidFill>
-              <a:srgbClr val="3B82F6"/>
+              <a:srgbClr val="60A5FA"/>
             </a:solidFill>
           </a:ln>
         </p:spPr>
@@ -5490,7 +5490,7 @@
             <a:pPr>
               <a:defRPr sz="1600" b="1">
                 <a:solidFill>
-                  <a:srgbClr val="F8FAFC"/>
+                  <a:srgbClr val="FFFFFF"/>
                 </a:solidFill>
               </a:defRPr>
             </a:pPr>
@@ -5502,7 +5502,7 @@
             <a:pPr>
               <a:defRPr sz="1200">
                 <a:solidFill>
-                  <a:srgbClr val="94A3B8"/>
+                  <a:srgbClr val="CBD5E1"/>
                 </a:solidFill>
               </a:defRPr>
             </a:pPr>
@@ -5526,7 +5526,7 @@
     <p:bg>
       <p:bgPr>
         <a:solidFill>
-          <a:srgbClr val="080C16"/>
+          <a:srgbClr val="0B0F19"/>
         </a:solidFill>
         <a:effectLst/>
       </p:bgPr>
@@ -5563,7 +5563,7 @@
             <a:pPr>
               <a:defRPr sz="1000" b="1">
                 <a:solidFill>
-                  <a:srgbClr val="06B6D4"/>
+                  <a:srgbClr val="00F0FF"/>
                 </a:solidFill>
               </a:defRPr>
             </a:pPr>
@@ -5598,7 +5598,7 @@
             <a:pPr>
               <a:defRPr sz="2600" b="1">
                 <a:solidFill>
-                  <a:srgbClr val="F8FAFC"/>
+                  <a:srgbClr val="FFFFFF"/>
                 </a:solidFill>
               </a:defRPr>
             </a:pPr>
@@ -5633,7 +5633,7 @@
             <a:pPr>
               <a:defRPr sz="900">
                 <a:solidFill>
-                  <a:srgbClr val="94A3B8"/>
+                  <a:srgbClr val="CBD5E1"/>
                 </a:solidFill>
               </a:defRPr>
             </a:pPr>
@@ -5658,11 +5658,11 @@
             <a:avLst/>
           </a:prstGeom>
           <a:solidFill>
-            <a:srgbClr val="0F172A"/>
+            <a:srgbClr val="111827"/>
           </a:solidFill>
           <a:ln>
             <a:solidFill>
-              <a:srgbClr val="8B5CF6"/>
+              <a:srgbClr val="C084FC"/>
             </a:solidFill>
           </a:ln>
         </p:spPr>
@@ -5713,7 +5713,7 @@
             <a:pPr>
               <a:defRPr sz="1600" b="1">
                 <a:solidFill>
-                  <a:srgbClr val="F8FAFC"/>
+                  <a:srgbClr val="FFFFFF"/>
                 </a:solidFill>
               </a:defRPr>
             </a:pPr>
@@ -5738,11 +5738,11 @@
             <a:avLst/>
           </a:prstGeom>
           <a:solidFill>
-            <a:srgbClr val="0F172A"/>
+            <a:srgbClr val="111827"/>
           </a:solidFill>
           <a:ln>
             <a:solidFill>
-              <a:srgbClr val="8B5CF6"/>
+              <a:srgbClr val="C084FC"/>
             </a:solidFill>
           </a:ln>
         </p:spPr>
@@ -5793,7 +5793,7 @@
             <a:pPr>
               <a:defRPr sz="1600" b="1">
                 <a:solidFill>
-                  <a:srgbClr val="F8FAFC"/>
+                  <a:srgbClr val="FFFFFF"/>
                 </a:solidFill>
               </a:defRPr>
             </a:pPr>
@@ -5818,11 +5818,11 @@
             <a:avLst/>
           </a:prstGeom>
           <a:solidFill>
-            <a:srgbClr val="0F172A"/>
+            <a:srgbClr val="111827"/>
           </a:solidFill>
           <a:ln>
             <a:solidFill>
-              <a:srgbClr val="8B5CF6"/>
+              <a:srgbClr val="C084FC"/>
             </a:solidFill>
           </a:ln>
         </p:spPr>
@@ -5873,7 +5873,7 @@
             <a:pPr>
               <a:defRPr sz="1600" b="1">
                 <a:solidFill>
-                  <a:srgbClr val="F8FAFC"/>
+                  <a:srgbClr val="FFFFFF"/>
                 </a:solidFill>
               </a:defRPr>
             </a:pPr>
@@ -5898,11 +5898,11 @@
             <a:avLst/>
           </a:prstGeom>
           <a:solidFill>
-            <a:srgbClr val="0F172A"/>
+            <a:srgbClr val="111827"/>
           </a:solidFill>
           <a:ln>
             <a:solidFill>
-              <a:srgbClr val="8B5CF6"/>
+              <a:srgbClr val="C084FC"/>
             </a:solidFill>
           </a:ln>
         </p:spPr>
@@ -5953,7 +5953,7 @@
             <a:pPr>
               <a:defRPr sz="1600" b="1">
                 <a:solidFill>
-                  <a:srgbClr val="F8FAFC"/>
+                  <a:srgbClr val="FFFFFF"/>
                 </a:solidFill>
               </a:defRPr>
             </a:pPr>
@@ -5978,11 +5978,11 @@
             <a:avLst/>
           </a:prstGeom>
           <a:solidFill>
-            <a:srgbClr val="0F172A"/>
+            <a:srgbClr val="111827"/>
           </a:solidFill>
           <a:ln>
             <a:solidFill>
-              <a:srgbClr val="8B5CF6"/>
+              <a:srgbClr val="C084FC"/>
             </a:solidFill>
           </a:ln>
         </p:spPr>
@@ -6033,7 +6033,7 @@
             <a:pPr>
               <a:defRPr sz="1600" b="1">
                 <a:solidFill>
-                  <a:srgbClr val="F8FAFC"/>
+                  <a:srgbClr val="FFFFFF"/>
                 </a:solidFill>
               </a:defRPr>
             </a:pPr>
@@ -6057,7 +6057,7 @@
     <p:bg>
       <p:bgPr>
         <a:solidFill>
-          <a:srgbClr val="080C16"/>
+          <a:srgbClr val="0B0F19"/>
         </a:solidFill>
         <a:effectLst/>
       </p:bgPr>
@@ -6094,7 +6094,7 @@
             <a:pPr>
               <a:defRPr sz="1000" b="1">
                 <a:solidFill>
-                  <a:srgbClr val="06B6D4"/>
+                  <a:srgbClr val="00F0FF"/>
                 </a:solidFill>
               </a:defRPr>
             </a:pPr>
@@ -6129,7 +6129,7 @@
             <a:pPr>
               <a:defRPr sz="2600" b="1">
                 <a:solidFill>
-                  <a:srgbClr val="F8FAFC"/>
+                  <a:srgbClr val="FFFFFF"/>
                 </a:solidFill>
               </a:defRPr>
             </a:pPr>
@@ -6164,7 +6164,7 @@
             <a:pPr>
               <a:defRPr sz="900">
                 <a:solidFill>
-                  <a:srgbClr val="94A3B8"/>
+                  <a:srgbClr val="CBD5E1"/>
                 </a:solidFill>
               </a:defRPr>
             </a:pPr>
@@ -6189,11 +6189,11 @@
             <a:avLst/>
           </a:prstGeom>
           <a:solidFill>
-            <a:srgbClr val="0F172A"/>
+            <a:srgbClr val="111827"/>
           </a:solidFill>
           <a:ln w="19050">
             <a:solidFill>
-              <a:srgbClr val="06B6D4"/>
+              <a:srgbClr val="00F0FF"/>
             </a:solidFill>
           </a:ln>
         </p:spPr>
@@ -6244,7 +6244,7 @@
             <a:pPr>
               <a:defRPr sz="3600" b="1">
                 <a:solidFill>
-                  <a:srgbClr val="06B6D4"/>
+                  <a:srgbClr val="00F0FF"/>
                 </a:solidFill>
               </a:defRPr>
             </a:pPr>
@@ -6257,7 +6257,7 @@
             <a:pPr>
               <a:defRPr sz="1600" b="1">
                 <a:solidFill>
-                  <a:srgbClr val="F8FAFC"/>
+                  <a:srgbClr val="FFFFFF"/>
                 </a:solidFill>
               </a:defRPr>
             </a:pPr>
@@ -6270,7 +6270,7 @@
             <a:pPr>
               <a:defRPr sz="1300">
                 <a:solidFill>
-                  <a:srgbClr val="94A3B8"/>
+                  <a:srgbClr val="CBD5E1"/>
                 </a:solidFill>
               </a:defRPr>
             </a:pPr>
@@ -6295,11 +6295,11 @@
             <a:avLst/>
           </a:prstGeom>
           <a:solidFill>
-            <a:srgbClr val="0F172A"/>
+            <a:srgbClr val="111827"/>
           </a:solidFill>
           <a:ln w="19050">
             <a:solidFill>
-              <a:srgbClr val="06B6D4"/>
+              <a:srgbClr val="00F0FF"/>
             </a:solidFill>
           </a:ln>
         </p:spPr>
@@ -6350,7 +6350,7 @@
             <a:pPr>
               <a:defRPr sz="3600" b="1">
                 <a:solidFill>
-                  <a:srgbClr val="06B6D4"/>
+                  <a:srgbClr val="00F0FF"/>
                 </a:solidFill>
               </a:defRPr>
             </a:pPr>
@@ -6363,7 +6363,7 @@
             <a:pPr>
               <a:defRPr sz="1600" b="1">
                 <a:solidFill>
-                  <a:srgbClr val="F8FAFC"/>
+                  <a:srgbClr val="FFFFFF"/>
                 </a:solidFill>
               </a:defRPr>
             </a:pPr>
@@ -6376,7 +6376,7 @@
             <a:pPr>
               <a:defRPr sz="1300">
                 <a:solidFill>
-                  <a:srgbClr val="94A3B8"/>
+                  <a:srgbClr val="CBD5E1"/>
                 </a:solidFill>
               </a:defRPr>
             </a:pPr>
@@ -6401,11 +6401,11 @@
             <a:avLst/>
           </a:prstGeom>
           <a:solidFill>
-            <a:srgbClr val="0F172A"/>
+            <a:srgbClr val="111827"/>
           </a:solidFill>
           <a:ln w="19050">
             <a:solidFill>
-              <a:srgbClr val="06B6D4"/>
+              <a:srgbClr val="00F0FF"/>
             </a:solidFill>
           </a:ln>
         </p:spPr>
@@ -6456,7 +6456,7 @@
             <a:pPr>
               <a:defRPr sz="3600" b="1">
                 <a:solidFill>
-                  <a:srgbClr val="06B6D4"/>
+                  <a:srgbClr val="00F0FF"/>
                 </a:solidFill>
               </a:defRPr>
             </a:pPr>
@@ -6469,7 +6469,7 @@
             <a:pPr>
               <a:defRPr sz="1600" b="1">
                 <a:solidFill>
-                  <a:srgbClr val="F8FAFC"/>
+                  <a:srgbClr val="FFFFFF"/>
                 </a:solidFill>
               </a:defRPr>
             </a:pPr>
@@ -6482,7 +6482,7 @@
             <a:pPr>
               <a:defRPr sz="1300">
                 <a:solidFill>
-                  <a:srgbClr val="94A3B8"/>
+                  <a:srgbClr val="CBD5E1"/>
                 </a:solidFill>
               </a:defRPr>
             </a:pPr>
@@ -6506,7 +6506,7 @@
     <p:bg>
       <p:bgPr>
         <a:solidFill>
-          <a:srgbClr val="080C16"/>
+          <a:srgbClr val="0B0F19"/>
         </a:solidFill>
         <a:effectLst/>
       </p:bgPr>
@@ -6543,7 +6543,7 @@
             <a:pPr>
               <a:defRPr sz="1000" b="1">
                 <a:solidFill>
-                  <a:srgbClr val="06B6D4"/>
+                  <a:srgbClr val="00F0FF"/>
                 </a:solidFill>
               </a:defRPr>
             </a:pPr>
@@ -6578,7 +6578,7 @@
             <a:pPr>
               <a:defRPr sz="2600" b="1">
                 <a:solidFill>
-                  <a:srgbClr val="F8FAFC"/>
+                  <a:srgbClr val="FFFFFF"/>
                 </a:solidFill>
               </a:defRPr>
             </a:pPr>
@@ -6613,7 +6613,7 @@
             <a:pPr>
               <a:defRPr sz="900">
                 <a:solidFill>
-                  <a:srgbClr val="94A3B8"/>
+                  <a:srgbClr val="CBD5E1"/>
                 </a:solidFill>
               </a:defRPr>
             </a:pPr>
@@ -6638,11 +6638,11 @@
             <a:avLst/>
           </a:prstGeom>
           <a:solidFill>
-            <a:srgbClr val="0F172A"/>
+            <a:srgbClr val="111827"/>
           </a:solidFill>
           <a:ln w="25400">
             <a:solidFill>
-              <a:srgbClr val="3B82F6"/>
+              <a:srgbClr val="60A5FA"/>
             </a:solidFill>
           </a:ln>
         </p:spPr>
@@ -6693,7 +6693,7 @@
             <a:pPr>
               <a:defRPr sz="2200" b="1">
                 <a:solidFill>
-                  <a:srgbClr val="3B82F6"/>
+                  <a:srgbClr val="60A5FA"/>
                 </a:solidFill>
               </a:defRPr>
             </a:pPr>
@@ -6705,7 +6705,7 @@
             <a:pPr>
               <a:defRPr sz="2600" b="1">
                 <a:solidFill>
-                  <a:srgbClr val="F8FAFC"/>
+                  <a:srgbClr val="FFFFFF"/>
                 </a:solidFill>
               </a:defRPr>
             </a:pPr>
@@ -6718,7 +6718,7 @@
             <a:pPr>
               <a:defRPr sz="1300">
                 <a:solidFill>
-                  <a:srgbClr val="94A3B8"/>
+                  <a:srgbClr val="CBD5E1"/>
                 </a:solidFill>
               </a:defRPr>
             </a:pPr>
@@ -6755,11 +6755,11 @@
             <a:avLst/>
           </a:prstGeom>
           <a:solidFill>
-            <a:srgbClr val="0F172A"/>
+            <a:srgbClr val="111827"/>
           </a:solidFill>
           <a:ln w="25400">
             <a:solidFill>
-              <a:srgbClr val="10B981"/>
+              <a:srgbClr val="34D399"/>
             </a:solidFill>
           </a:ln>
         </p:spPr>
@@ -6810,7 +6810,7 @@
             <a:pPr>
               <a:defRPr sz="2200" b="1">
                 <a:solidFill>
-                  <a:srgbClr val="10B981"/>
+                  <a:srgbClr val="34D399"/>
                 </a:solidFill>
               </a:defRPr>
             </a:pPr>
@@ -6822,7 +6822,7 @@
             <a:pPr>
               <a:defRPr sz="2600" b="1">
                 <a:solidFill>
-                  <a:srgbClr val="F8FAFC"/>
+                  <a:srgbClr val="FFFFFF"/>
                 </a:solidFill>
               </a:defRPr>
             </a:pPr>
@@ -6835,7 +6835,7 @@
             <a:pPr>
               <a:defRPr sz="1300">
                 <a:solidFill>
-                  <a:srgbClr val="94A3B8"/>
+                  <a:srgbClr val="CBD5E1"/>
                 </a:solidFill>
               </a:defRPr>
             </a:pPr>
@@ -6872,11 +6872,11 @@
             <a:avLst/>
           </a:prstGeom>
           <a:solidFill>
-            <a:srgbClr val="0F172A"/>
+            <a:srgbClr val="111827"/>
           </a:solidFill>
           <a:ln w="25400">
             <a:solidFill>
-              <a:srgbClr val="8B5CF6"/>
+              <a:srgbClr val="C084FC"/>
             </a:solidFill>
           </a:ln>
         </p:spPr>
@@ -6927,7 +6927,7 @@
             <a:pPr>
               <a:defRPr sz="2200" b="1">
                 <a:solidFill>
-                  <a:srgbClr val="8B5CF6"/>
+                  <a:srgbClr val="C084FC"/>
                 </a:solidFill>
               </a:defRPr>
             </a:pPr>
@@ -6939,7 +6939,7 @@
             <a:pPr>
               <a:defRPr sz="2600" b="1">
                 <a:solidFill>
-                  <a:srgbClr val="F8FAFC"/>
+                  <a:srgbClr val="FFFFFF"/>
                 </a:solidFill>
               </a:defRPr>
             </a:pPr>
@@ -6952,7 +6952,7 @@
             <a:pPr>
               <a:defRPr sz="1300">
                 <a:solidFill>
-                  <a:srgbClr val="94A3B8"/>
+                  <a:srgbClr val="CBD5E1"/>
                 </a:solidFill>
               </a:defRPr>
             </a:pPr>
@@ -6989,11 +6989,11 @@
             <a:avLst/>
           </a:prstGeom>
           <a:solidFill>
-            <a:srgbClr val="0F172A"/>
+            <a:srgbClr val="111827"/>
           </a:solidFill>
           <a:ln w="25400">
             <a:solidFill>
-              <a:srgbClr val="06B6D4"/>
+              <a:srgbClr val="00F0FF"/>
             </a:solidFill>
           </a:ln>
         </p:spPr>
@@ -7044,7 +7044,7 @@
             <a:pPr>
               <a:defRPr sz="2200" b="1">
                 <a:solidFill>
-                  <a:srgbClr val="06B6D4"/>
+                  <a:srgbClr val="00F0FF"/>
                 </a:solidFill>
               </a:defRPr>
             </a:pPr>
@@ -7056,7 +7056,7 @@
             <a:pPr>
               <a:defRPr sz="2600" b="1">
                 <a:solidFill>
-                  <a:srgbClr val="F8FAFC"/>
+                  <a:srgbClr val="FFFFFF"/>
                 </a:solidFill>
               </a:defRPr>
             </a:pPr>
@@ -7069,7 +7069,7 @@
             <a:pPr>
               <a:defRPr sz="1300">
                 <a:solidFill>
-                  <a:srgbClr val="94A3B8"/>
+                  <a:srgbClr val="CBD5E1"/>
                 </a:solidFill>
               </a:defRPr>
             </a:pPr>
@@ -7105,7 +7105,7 @@
     <p:bg>
       <p:bgPr>
         <a:solidFill>
-          <a:srgbClr val="080C16"/>
+          <a:srgbClr val="0B0F19"/>
         </a:solidFill>
         <a:effectLst/>
       </p:bgPr>
@@ -7142,7 +7142,7 @@
             <a:pPr>
               <a:defRPr sz="1000" b="1">
                 <a:solidFill>
-                  <a:srgbClr val="06B6D4"/>
+                  <a:srgbClr val="00F0FF"/>
                 </a:solidFill>
               </a:defRPr>
             </a:pPr>
@@ -7177,7 +7177,7 @@
             <a:pPr>
               <a:defRPr sz="2600" b="1">
                 <a:solidFill>
-                  <a:srgbClr val="F8FAFC"/>
+                  <a:srgbClr val="FFFFFF"/>
                 </a:solidFill>
               </a:defRPr>
             </a:pPr>
@@ -7212,7 +7212,7 @@
             <a:pPr>
               <a:defRPr sz="900">
                 <a:solidFill>
-                  <a:srgbClr val="94A3B8"/>
+                  <a:srgbClr val="CBD5E1"/>
                 </a:solidFill>
               </a:defRPr>
             </a:pPr>
@@ -7237,11 +7237,11 @@
             <a:avLst/>
           </a:prstGeom>
           <a:solidFill>
-            <a:srgbClr val="0F172A"/>
+            <a:srgbClr val="111827"/>
           </a:solidFill>
           <a:ln>
             <a:solidFill>
-              <a:srgbClr val="10B981"/>
+              <a:srgbClr val="34D399"/>
             </a:solidFill>
           </a:ln>
         </p:spPr>
@@ -7292,7 +7292,7 @@
             <a:pPr>
               <a:defRPr sz="1600" b="1">
                 <a:solidFill>
-                  <a:srgbClr val="10B981"/>
+                  <a:srgbClr val="34D399"/>
                 </a:solidFill>
               </a:defRPr>
             </a:pPr>
@@ -7305,7 +7305,7 @@
             <a:pPr>
               <a:defRPr sz="1500">
                 <a:solidFill>
-                  <a:srgbClr val="F8FAFC"/>
+                  <a:srgbClr val="FFFFFF"/>
                 </a:solidFill>
               </a:defRPr>
             </a:pPr>

</xml_diff>